<commit_message>
resolve merge conflict (#61)
Co-authored-by: Victor <0929470@hr.nl>
</commit_message>
<xml_diff>
--- a/CapstoneProject_FinalPresentation.pptx
+++ b/CapstoneProject_FinalPresentation.pptx
@@ -1821,7 +1821,7 @@
           <a:p>
             <a:fld id="{A7923405-3004-4FB4-9001-A4AE165A0E82}" type="datetimeFigureOut">
               <a:rPr lang="x-none" smtClean="0"/>
-              <a:t>22/06/2025</a:t>
+              <a:t>22-6-2025</a:t>
             </a:fld>
             <a:endParaRPr lang="x-none"/>
           </a:p>
@@ -1980,7 +1980,7 @@
           <a:p>
             <a:fld id="{7950A447-A630-428B-97CD-90EF8EC62843}" type="slidenum">
               <a:rPr lang="x-none" smtClean="0"/>
-              <a:t>‹#›</a:t>
+              <a:t>‹nr.›</a:t>
             </a:fld>
             <a:endParaRPr lang="x-none"/>
           </a:p>
@@ -2626,7 +2626,7 @@
           <p:cNvPr id="2" name="Title 1">
             <a:extLst>
               <a:ext uri="{FF2B5EF4-FFF2-40B4-BE49-F238E27FC236}">
-                <a16:creationId xmlns="" xmlns:a16="http://schemas.microsoft.com/office/drawing/2014/main" id="{F380E731-116B-528A-2187-9A1120D00B79}"/>
+                <a16:creationId xmlns:a16="http://schemas.microsoft.com/office/drawing/2014/main" id="{F380E731-116B-528A-2187-9A1120D00B79}"/>
               </a:ext>
             </a:extLst>
           </p:cNvPr>
@@ -2664,7 +2664,7 @@
           <p:cNvPr id="3" name="Subtitle 2">
             <a:extLst>
               <a:ext uri="{FF2B5EF4-FFF2-40B4-BE49-F238E27FC236}">
-                <a16:creationId xmlns="" xmlns:a16="http://schemas.microsoft.com/office/drawing/2014/main" id="{9AF3DDC1-BA8B-1C83-AD29-94D72531724C}"/>
+                <a16:creationId xmlns:a16="http://schemas.microsoft.com/office/drawing/2014/main" id="{9AF3DDC1-BA8B-1C83-AD29-94D72531724C}"/>
               </a:ext>
             </a:extLst>
           </p:cNvPr>
@@ -2735,7 +2735,7 @@
           <p:cNvPr id="4" name="Date Placeholder 3">
             <a:extLst>
               <a:ext uri="{FF2B5EF4-FFF2-40B4-BE49-F238E27FC236}">
-                <a16:creationId xmlns="" xmlns:a16="http://schemas.microsoft.com/office/drawing/2014/main" id="{BA984B3D-BDA7-B0C9-8C1F-D0866A3FD98E}"/>
+                <a16:creationId xmlns:a16="http://schemas.microsoft.com/office/drawing/2014/main" id="{BA984B3D-BDA7-B0C9-8C1F-D0866A3FD98E}"/>
               </a:ext>
             </a:extLst>
           </p:cNvPr>
@@ -2753,7 +2753,7 @@
           <a:p>
             <a:fld id="{9625E07E-267C-465F-9BA1-4B4F412DCF6A}" type="datetimeFigureOut">
               <a:rPr lang="x-none" smtClean="0"/>
-              <a:t>22/06/2025</a:t>
+              <a:t>22-6-2025</a:t>
             </a:fld>
             <a:endParaRPr lang="x-none"/>
           </a:p>
@@ -2764,7 +2764,7 @@
           <p:cNvPr id="5" name="Footer Placeholder 4">
             <a:extLst>
               <a:ext uri="{FF2B5EF4-FFF2-40B4-BE49-F238E27FC236}">
-                <a16:creationId xmlns="" xmlns:a16="http://schemas.microsoft.com/office/drawing/2014/main" id="{69F91029-8EFB-D8D2-1696-39EFC9733E4C}"/>
+                <a16:creationId xmlns:a16="http://schemas.microsoft.com/office/drawing/2014/main" id="{69F91029-8EFB-D8D2-1696-39EFC9733E4C}"/>
               </a:ext>
             </a:extLst>
           </p:cNvPr>
@@ -2789,7 +2789,7 @@
           <p:cNvPr id="6" name="Slide Number Placeholder 5">
             <a:extLst>
               <a:ext uri="{FF2B5EF4-FFF2-40B4-BE49-F238E27FC236}">
-                <a16:creationId xmlns="" xmlns:a16="http://schemas.microsoft.com/office/drawing/2014/main" id="{54E5B57C-1624-2644-F71F-3278CD7A9E08}"/>
+                <a16:creationId xmlns:a16="http://schemas.microsoft.com/office/drawing/2014/main" id="{54E5B57C-1624-2644-F71F-3278CD7A9E08}"/>
               </a:ext>
             </a:extLst>
           </p:cNvPr>
@@ -2807,7 +2807,7 @@
           <a:p>
             <a:fld id="{702BEA66-D241-493C-8698-9D3EF34A1033}" type="slidenum">
               <a:rPr lang="x-none" smtClean="0"/>
-              <a:t>‹#›</a:t>
+              <a:t>‹nr.›</a:t>
             </a:fld>
             <a:endParaRPr lang="x-none"/>
           </a:p>
@@ -2848,7 +2848,7 @@
           <p:cNvPr id="2" name="Title 1">
             <a:extLst>
               <a:ext uri="{FF2B5EF4-FFF2-40B4-BE49-F238E27FC236}">
-                <a16:creationId xmlns="" xmlns:a16="http://schemas.microsoft.com/office/drawing/2014/main" id="{608872A8-BFE8-862E-5B55-DAEE13AE1D99}"/>
+                <a16:creationId xmlns:a16="http://schemas.microsoft.com/office/drawing/2014/main" id="{608872A8-BFE8-862E-5B55-DAEE13AE1D99}"/>
               </a:ext>
             </a:extLst>
           </p:cNvPr>
@@ -2877,7 +2877,7 @@
           <p:cNvPr id="3" name="Vertical Text Placeholder 2">
             <a:extLst>
               <a:ext uri="{FF2B5EF4-FFF2-40B4-BE49-F238E27FC236}">
-                <a16:creationId xmlns="" xmlns:a16="http://schemas.microsoft.com/office/drawing/2014/main" id="{7EFDCB7C-268A-93E9-A16D-545F78F6ACAD}"/>
+                <a16:creationId xmlns:a16="http://schemas.microsoft.com/office/drawing/2014/main" id="{7EFDCB7C-268A-93E9-A16D-545F78F6ACAD}"/>
               </a:ext>
             </a:extLst>
           </p:cNvPr>
@@ -2935,7 +2935,7 @@
           <p:cNvPr id="4" name="Date Placeholder 3">
             <a:extLst>
               <a:ext uri="{FF2B5EF4-FFF2-40B4-BE49-F238E27FC236}">
-                <a16:creationId xmlns="" xmlns:a16="http://schemas.microsoft.com/office/drawing/2014/main" id="{D77B35E5-977C-F4C5-A854-1E68B478D899}"/>
+                <a16:creationId xmlns:a16="http://schemas.microsoft.com/office/drawing/2014/main" id="{D77B35E5-977C-F4C5-A854-1E68B478D899}"/>
               </a:ext>
             </a:extLst>
           </p:cNvPr>
@@ -2953,7 +2953,7 @@
           <a:p>
             <a:fld id="{9625E07E-267C-465F-9BA1-4B4F412DCF6A}" type="datetimeFigureOut">
               <a:rPr lang="x-none" smtClean="0"/>
-              <a:t>22/06/2025</a:t>
+              <a:t>22-6-2025</a:t>
             </a:fld>
             <a:endParaRPr lang="x-none"/>
           </a:p>
@@ -2964,7 +2964,7 @@
           <p:cNvPr id="5" name="Footer Placeholder 4">
             <a:extLst>
               <a:ext uri="{FF2B5EF4-FFF2-40B4-BE49-F238E27FC236}">
-                <a16:creationId xmlns="" xmlns:a16="http://schemas.microsoft.com/office/drawing/2014/main" id="{2CF2F422-4899-D919-B68B-F63349E283C4}"/>
+                <a16:creationId xmlns:a16="http://schemas.microsoft.com/office/drawing/2014/main" id="{2CF2F422-4899-D919-B68B-F63349E283C4}"/>
               </a:ext>
             </a:extLst>
           </p:cNvPr>
@@ -2989,7 +2989,7 @@
           <p:cNvPr id="6" name="Slide Number Placeholder 5">
             <a:extLst>
               <a:ext uri="{FF2B5EF4-FFF2-40B4-BE49-F238E27FC236}">
-                <a16:creationId xmlns="" xmlns:a16="http://schemas.microsoft.com/office/drawing/2014/main" id="{11CE9B30-3301-9AE3-D191-D3355990A50F}"/>
+                <a16:creationId xmlns:a16="http://schemas.microsoft.com/office/drawing/2014/main" id="{11CE9B30-3301-9AE3-D191-D3355990A50F}"/>
               </a:ext>
             </a:extLst>
           </p:cNvPr>
@@ -3007,7 +3007,7 @@
           <a:p>
             <a:fld id="{702BEA66-D241-493C-8698-9D3EF34A1033}" type="slidenum">
               <a:rPr lang="x-none" smtClean="0"/>
-              <a:t>‹#›</a:t>
+              <a:t>‹nr.›</a:t>
             </a:fld>
             <a:endParaRPr lang="x-none"/>
           </a:p>
@@ -3048,7 +3048,7 @@
           <p:cNvPr id="2" name="Vertical Title 1">
             <a:extLst>
               <a:ext uri="{FF2B5EF4-FFF2-40B4-BE49-F238E27FC236}">
-                <a16:creationId xmlns="" xmlns:a16="http://schemas.microsoft.com/office/drawing/2014/main" id="{D1BF5D45-53D3-747B-8EE0-30DD1C7E7CB6}"/>
+                <a16:creationId xmlns:a16="http://schemas.microsoft.com/office/drawing/2014/main" id="{D1BF5D45-53D3-747B-8EE0-30DD1C7E7CB6}"/>
               </a:ext>
             </a:extLst>
           </p:cNvPr>
@@ -3082,7 +3082,7 @@
           <p:cNvPr id="3" name="Vertical Text Placeholder 2">
             <a:extLst>
               <a:ext uri="{FF2B5EF4-FFF2-40B4-BE49-F238E27FC236}">
-                <a16:creationId xmlns="" xmlns:a16="http://schemas.microsoft.com/office/drawing/2014/main" id="{BA9D001F-915F-3D84-9401-57F7E1E2E53F}"/>
+                <a16:creationId xmlns:a16="http://schemas.microsoft.com/office/drawing/2014/main" id="{BA9D001F-915F-3D84-9401-57F7E1E2E53F}"/>
               </a:ext>
             </a:extLst>
           </p:cNvPr>
@@ -3145,7 +3145,7 @@
           <p:cNvPr id="4" name="Date Placeholder 3">
             <a:extLst>
               <a:ext uri="{FF2B5EF4-FFF2-40B4-BE49-F238E27FC236}">
-                <a16:creationId xmlns="" xmlns:a16="http://schemas.microsoft.com/office/drawing/2014/main" id="{72BEC80D-3107-EEC4-F2C6-DCD28A7365C4}"/>
+                <a16:creationId xmlns:a16="http://schemas.microsoft.com/office/drawing/2014/main" id="{72BEC80D-3107-EEC4-F2C6-DCD28A7365C4}"/>
               </a:ext>
             </a:extLst>
           </p:cNvPr>
@@ -3163,7 +3163,7 @@
           <a:p>
             <a:fld id="{9625E07E-267C-465F-9BA1-4B4F412DCF6A}" type="datetimeFigureOut">
               <a:rPr lang="x-none" smtClean="0"/>
-              <a:t>22/06/2025</a:t>
+              <a:t>22-6-2025</a:t>
             </a:fld>
             <a:endParaRPr lang="x-none"/>
           </a:p>
@@ -3174,7 +3174,7 @@
           <p:cNvPr id="5" name="Footer Placeholder 4">
             <a:extLst>
               <a:ext uri="{FF2B5EF4-FFF2-40B4-BE49-F238E27FC236}">
-                <a16:creationId xmlns="" xmlns:a16="http://schemas.microsoft.com/office/drawing/2014/main" id="{BC647EBF-AAC0-E145-C468-588E78B1D081}"/>
+                <a16:creationId xmlns:a16="http://schemas.microsoft.com/office/drawing/2014/main" id="{BC647EBF-AAC0-E145-C468-588E78B1D081}"/>
               </a:ext>
             </a:extLst>
           </p:cNvPr>
@@ -3199,7 +3199,7 @@
           <p:cNvPr id="6" name="Slide Number Placeholder 5">
             <a:extLst>
               <a:ext uri="{FF2B5EF4-FFF2-40B4-BE49-F238E27FC236}">
-                <a16:creationId xmlns="" xmlns:a16="http://schemas.microsoft.com/office/drawing/2014/main" id="{1E9A4E4B-C48B-D680-6CA4-10F100471F80}"/>
+                <a16:creationId xmlns:a16="http://schemas.microsoft.com/office/drawing/2014/main" id="{1E9A4E4B-C48B-D680-6CA4-10F100471F80}"/>
               </a:ext>
             </a:extLst>
           </p:cNvPr>
@@ -3217,7 +3217,7 @@
           <a:p>
             <a:fld id="{702BEA66-D241-493C-8698-9D3EF34A1033}" type="slidenum">
               <a:rPr lang="x-none" smtClean="0"/>
-              <a:t>‹#›</a:t>
+              <a:t>‹nr.›</a:t>
             </a:fld>
             <a:endParaRPr lang="x-none"/>
           </a:p>
@@ -3258,7 +3258,7 @@
           <p:cNvPr id="2" name="Title 1">
             <a:extLst>
               <a:ext uri="{FF2B5EF4-FFF2-40B4-BE49-F238E27FC236}">
-                <a16:creationId xmlns="" xmlns:a16="http://schemas.microsoft.com/office/drawing/2014/main" id="{973B5270-D507-A79E-4974-C8E58BAB397A}"/>
+                <a16:creationId xmlns:a16="http://schemas.microsoft.com/office/drawing/2014/main" id="{973B5270-D507-A79E-4974-C8E58BAB397A}"/>
               </a:ext>
             </a:extLst>
           </p:cNvPr>
@@ -3287,7 +3287,7 @@
           <p:cNvPr id="3" name="Content Placeholder 2">
             <a:extLst>
               <a:ext uri="{FF2B5EF4-FFF2-40B4-BE49-F238E27FC236}">
-                <a16:creationId xmlns="" xmlns:a16="http://schemas.microsoft.com/office/drawing/2014/main" id="{925E034E-1785-FD51-033B-8E5C8E7AEDC3}"/>
+                <a16:creationId xmlns:a16="http://schemas.microsoft.com/office/drawing/2014/main" id="{925E034E-1785-FD51-033B-8E5C8E7AEDC3}"/>
               </a:ext>
             </a:extLst>
           </p:cNvPr>
@@ -3345,7 +3345,7 @@
           <p:cNvPr id="4" name="Date Placeholder 3">
             <a:extLst>
               <a:ext uri="{FF2B5EF4-FFF2-40B4-BE49-F238E27FC236}">
-                <a16:creationId xmlns="" xmlns:a16="http://schemas.microsoft.com/office/drawing/2014/main" id="{0DC4AD5F-60E8-53EA-2307-6D890D0008A8}"/>
+                <a16:creationId xmlns:a16="http://schemas.microsoft.com/office/drawing/2014/main" id="{0DC4AD5F-60E8-53EA-2307-6D890D0008A8}"/>
               </a:ext>
             </a:extLst>
           </p:cNvPr>
@@ -3363,7 +3363,7 @@
           <a:p>
             <a:fld id="{9625E07E-267C-465F-9BA1-4B4F412DCF6A}" type="datetimeFigureOut">
               <a:rPr lang="x-none" smtClean="0"/>
-              <a:t>22/06/2025</a:t>
+              <a:t>22-6-2025</a:t>
             </a:fld>
             <a:endParaRPr lang="x-none"/>
           </a:p>
@@ -3374,7 +3374,7 @@
           <p:cNvPr id="5" name="Footer Placeholder 4">
             <a:extLst>
               <a:ext uri="{FF2B5EF4-FFF2-40B4-BE49-F238E27FC236}">
-                <a16:creationId xmlns="" xmlns:a16="http://schemas.microsoft.com/office/drawing/2014/main" id="{80EEC8B6-1F03-0346-0C02-D9F5C5B38764}"/>
+                <a16:creationId xmlns:a16="http://schemas.microsoft.com/office/drawing/2014/main" id="{80EEC8B6-1F03-0346-0C02-D9F5C5B38764}"/>
               </a:ext>
             </a:extLst>
           </p:cNvPr>
@@ -3399,7 +3399,7 @@
           <p:cNvPr id="6" name="Slide Number Placeholder 5">
             <a:extLst>
               <a:ext uri="{FF2B5EF4-FFF2-40B4-BE49-F238E27FC236}">
-                <a16:creationId xmlns="" xmlns:a16="http://schemas.microsoft.com/office/drawing/2014/main" id="{26E0880E-A47F-AE0B-1292-2E39F2AE28E3}"/>
+                <a16:creationId xmlns:a16="http://schemas.microsoft.com/office/drawing/2014/main" id="{26E0880E-A47F-AE0B-1292-2E39F2AE28E3}"/>
               </a:ext>
             </a:extLst>
           </p:cNvPr>
@@ -3417,7 +3417,7 @@
           <a:p>
             <a:fld id="{702BEA66-D241-493C-8698-9D3EF34A1033}" type="slidenum">
               <a:rPr lang="x-none" smtClean="0"/>
-              <a:t>‹#›</a:t>
+              <a:t>‹nr.›</a:t>
             </a:fld>
             <a:endParaRPr lang="x-none"/>
           </a:p>
@@ -3458,7 +3458,7 @@
           <p:cNvPr id="2" name="Title 1">
             <a:extLst>
               <a:ext uri="{FF2B5EF4-FFF2-40B4-BE49-F238E27FC236}">
-                <a16:creationId xmlns="" xmlns:a16="http://schemas.microsoft.com/office/drawing/2014/main" id="{B13A6A22-EE21-9FCA-A932-E4A985E42621}"/>
+                <a16:creationId xmlns:a16="http://schemas.microsoft.com/office/drawing/2014/main" id="{B13A6A22-EE21-9FCA-A932-E4A985E42621}"/>
               </a:ext>
             </a:extLst>
           </p:cNvPr>
@@ -3496,7 +3496,7 @@
           <p:cNvPr id="3" name="Text Placeholder 2">
             <a:extLst>
               <a:ext uri="{FF2B5EF4-FFF2-40B4-BE49-F238E27FC236}">
-                <a16:creationId xmlns="" xmlns:a16="http://schemas.microsoft.com/office/drawing/2014/main" id="{FF4F5594-4786-4410-D417-6B505CFF1186}"/>
+                <a16:creationId xmlns:a16="http://schemas.microsoft.com/office/drawing/2014/main" id="{FF4F5594-4786-4410-D417-6B505CFF1186}"/>
               </a:ext>
             </a:extLst>
           </p:cNvPr>
@@ -3621,7 +3621,7 @@
           <p:cNvPr id="4" name="Date Placeholder 3">
             <a:extLst>
               <a:ext uri="{FF2B5EF4-FFF2-40B4-BE49-F238E27FC236}">
-                <a16:creationId xmlns="" xmlns:a16="http://schemas.microsoft.com/office/drawing/2014/main" id="{57372B17-9119-DF50-3847-E588730ADD97}"/>
+                <a16:creationId xmlns:a16="http://schemas.microsoft.com/office/drawing/2014/main" id="{57372B17-9119-DF50-3847-E588730ADD97}"/>
               </a:ext>
             </a:extLst>
           </p:cNvPr>
@@ -3639,7 +3639,7 @@
           <a:p>
             <a:fld id="{9625E07E-267C-465F-9BA1-4B4F412DCF6A}" type="datetimeFigureOut">
               <a:rPr lang="x-none" smtClean="0"/>
-              <a:t>22/06/2025</a:t>
+              <a:t>22-6-2025</a:t>
             </a:fld>
             <a:endParaRPr lang="x-none"/>
           </a:p>
@@ -3650,7 +3650,7 @@
           <p:cNvPr id="5" name="Footer Placeholder 4">
             <a:extLst>
               <a:ext uri="{FF2B5EF4-FFF2-40B4-BE49-F238E27FC236}">
-                <a16:creationId xmlns="" xmlns:a16="http://schemas.microsoft.com/office/drawing/2014/main" id="{920D5CB4-D80C-C5EE-ECF7-F9872A3DC79C}"/>
+                <a16:creationId xmlns:a16="http://schemas.microsoft.com/office/drawing/2014/main" id="{920D5CB4-D80C-C5EE-ECF7-F9872A3DC79C}"/>
               </a:ext>
             </a:extLst>
           </p:cNvPr>
@@ -3675,7 +3675,7 @@
           <p:cNvPr id="6" name="Slide Number Placeholder 5">
             <a:extLst>
               <a:ext uri="{FF2B5EF4-FFF2-40B4-BE49-F238E27FC236}">
-                <a16:creationId xmlns="" xmlns:a16="http://schemas.microsoft.com/office/drawing/2014/main" id="{8DC47CEE-A20D-ECE6-706F-0C23EA830CE5}"/>
+                <a16:creationId xmlns:a16="http://schemas.microsoft.com/office/drawing/2014/main" id="{8DC47CEE-A20D-ECE6-706F-0C23EA830CE5}"/>
               </a:ext>
             </a:extLst>
           </p:cNvPr>
@@ -3693,7 +3693,7 @@
           <a:p>
             <a:fld id="{702BEA66-D241-493C-8698-9D3EF34A1033}" type="slidenum">
               <a:rPr lang="x-none" smtClean="0"/>
-              <a:t>‹#›</a:t>
+              <a:t>‹nr.›</a:t>
             </a:fld>
             <a:endParaRPr lang="x-none"/>
           </a:p>
@@ -3734,7 +3734,7 @@
           <p:cNvPr id="2" name="Title 1">
             <a:extLst>
               <a:ext uri="{FF2B5EF4-FFF2-40B4-BE49-F238E27FC236}">
-                <a16:creationId xmlns="" xmlns:a16="http://schemas.microsoft.com/office/drawing/2014/main" id="{6B64A50A-94FE-5599-F687-5172D94A3342}"/>
+                <a16:creationId xmlns:a16="http://schemas.microsoft.com/office/drawing/2014/main" id="{6B64A50A-94FE-5599-F687-5172D94A3342}"/>
               </a:ext>
             </a:extLst>
           </p:cNvPr>
@@ -3763,7 +3763,7 @@
           <p:cNvPr id="3" name="Content Placeholder 2">
             <a:extLst>
               <a:ext uri="{FF2B5EF4-FFF2-40B4-BE49-F238E27FC236}">
-                <a16:creationId xmlns="" xmlns:a16="http://schemas.microsoft.com/office/drawing/2014/main" id="{80450256-F422-F56D-4EBB-05B1857E6ED9}"/>
+                <a16:creationId xmlns:a16="http://schemas.microsoft.com/office/drawing/2014/main" id="{80450256-F422-F56D-4EBB-05B1857E6ED9}"/>
               </a:ext>
             </a:extLst>
           </p:cNvPr>
@@ -3826,7 +3826,7 @@
           <p:cNvPr id="4" name="Content Placeholder 3">
             <a:extLst>
               <a:ext uri="{FF2B5EF4-FFF2-40B4-BE49-F238E27FC236}">
-                <a16:creationId xmlns="" xmlns:a16="http://schemas.microsoft.com/office/drawing/2014/main" id="{4F6CF29C-4153-C817-1F12-3B641891AE97}"/>
+                <a16:creationId xmlns:a16="http://schemas.microsoft.com/office/drawing/2014/main" id="{4F6CF29C-4153-C817-1F12-3B641891AE97}"/>
               </a:ext>
             </a:extLst>
           </p:cNvPr>
@@ -3889,7 +3889,7 @@
           <p:cNvPr id="5" name="Date Placeholder 4">
             <a:extLst>
               <a:ext uri="{FF2B5EF4-FFF2-40B4-BE49-F238E27FC236}">
-                <a16:creationId xmlns="" xmlns:a16="http://schemas.microsoft.com/office/drawing/2014/main" id="{7C19D058-1AE7-6A60-A27E-E6D1CEE0B08B}"/>
+                <a16:creationId xmlns:a16="http://schemas.microsoft.com/office/drawing/2014/main" id="{7C19D058-1AE7-6A60-A27E-E6D1CEE0B08B}"/>
               </a:ext>
             </a:extLst>
           </p:cNvPr>
@@ -3907,7 +3907,7 @@
           <a:p>
             <a:fld id="{9625E07E-267C-465F-9BA1-4B4F412DCF6A}" type="datetimeFigureOut">
               <a:rPr lang="x-none" smtClean="0"/>
-              <a:t>22/06/2025</a:t>
+              <a:t>22-6-2025</a:t>
             </a:fld>
             <a:endParaRPr lang="x-none"/>
           </a:p>
@@ -3918,7 +3918,7 @@
           <p:cNvPr id="6" name="Footer Placeholder 5">
             <a:extLst>
               <a:ext uri="{FF2B5EF4-FFF2-40B4-BE49-F238E27FC236}">
-                <a16:creationId xmlns="" xmlns:a16="http://schemas.microsoft.com/office/drawing/2014/main" id="{22A54167-4CA6-2C4E-5379-09CECDB878DD}"/>
+                <a16:creationId xmlns:a16="http://schemas.microsoft.com/office/drawing/2014/main" id="{22A54167-4CA6-2C4E-5379-09CECDB878DD}"/>
               </a:ext>
             </a:extLst>
           </p:cNvPr>
@@ -3943,7 +3943,7 @@
           <p:cNvPr id="7" name="Slide Number Placeholder 6">
             <a:extLst>
               <a:ext uri="{FF2B5EF4-FFF2-40B4-BE49-F238E27FC236}">
-                <a16:creationId xmlns="" xmlns:a16="http://schemas.microsoft.com/office/drawing/2014/main" id="{0105B17C-7865-FA08-33C2-1F43A724BF5A}"/>
+                <a16:creationId xmlns:a16="http://schemas.microsoft.com/office/drawing/2014/main" id="{0105B17C-7865-FA08-33C2-1F43A724BF5A}"/>
               </a:ext>
             </a:extLst>
           </p:cNvPr>
@@ -3961,7 +3961,7 @@
           <a:p>
             <a:fld id="{702BEA66-D241-493C-8698-9D3EF34A1033}" type="slidenum">
               <a:rPr lang="x-none" smtClean="0"/>
-              <a:t>‹#›</a:t>
+              <a:t>‹nr.›</a:t>
             </a:fld>
             <a:endParaRPr lang="x-none"/>
           </a:p>
@@ -4002,7 +4002,7 @@
           <p:cNvPr id="2" name="Title 1">
             <a:extLst>
               <a:ext uri="{FF2B5EF4-FFF2-40B4-BE49-F238E27FC236}">
-                <a16:creationId xmlns="" xmlns:a16="http://schemas.microsoft.com/office/drawing/2014/main" id="{E54CD4E4-E584-E322-D9F4-41F44CB6B793}"/>
+                <a16:creationId xmlns:a16="http://schemas.microsoft.com/office/drawing/2014/main" id="{E54CD4E4-E584-E322-D9F4-41F44CB6B793}"/>
               </a:ext>
             </a:extLst>
           </p:cNvPr>
@@ -4036,7 +4036,7 @@
           <p:cNvPr id="3" name="Text Placeholder 2">
             <a:extLst>
               <a:ext uri="{FF2B5EF4-FFF2-40B4-BE49-F238E27FC236}">
-                <a16:creationId xmlns="" xmlns:a16="http://schemas.microsoft.com/office/drawing/2014/main" id="{AD9F0916-946C-72AB-0D6A-3E073935C6FF}"/>
+                <a16:creationId xmlns:a16="http://schemas.microsoft.com/office/drawing/2014/main" id="{AD9F0916-946C-72AB-0D6A-3E073935C6FF}"/>
               </a:ext>
             </a:extLst>
           </p:cNvPr>
@@ -4107,7 +4107,7 @@
           <p:cNvPr id="4" name="Content Placeholder 3">
             <a:extLst>
               <a:ext uri="{FF2B5EF4-FFF2-40B4-BE49-F238E27FC236}">
-                <a16:creationId xmlns="" xmlns:a16="http://schemas.microsoft.com/office/drawing/2014/main" id="{74566A47-7756-4285-CC71-D882AA55973B}"/>
+                <a16:creationId xmlns:a16="http://schemas.microsoft.com/office/drawing/2014/main" id="{74566A47-7756-4285-CC71-D882AA55973B}"/>
               </a:ext>
             </a:extLst>
           </p:cNvPr>
@@ -4170,7 +4170,7 @@
           <p:cNvPr id="5" name="Text Placeholder 4">
             <a:extLst>
               <a:ext uri="{FF2B5EF4-FFF2-40B4-BE49-F238E27FC236}">
-                <a16:creationId xmlns="" xmlns:a16="http://schemas.microsoft.com/office/drawing/2014/main" id="{E98418EE-5ACD-4296-B470-05B2492843D3}"/>
+                <a16:creationId xmlns:a16="http://schemas.microsoft.com/office/drawing/2014/main" id="{E98418EE-5ACD-4296-B470-05B2492843D3}"/>
               </a:ext>
             </a:extLst>
           </p:cNvPr>
@@ -4241,7 +4241,7 @@
           <p:cNvPr id="6" name="Content Placeholder 5">
             <a:extLst>
               <a:ext uri="{FF2B5EF4-FFF2-40B4-BE49-F238E27FC236}">
-                <a16:creationId xmlns="" xmlns:a16="http://schemas.microsoft.com/office/drawing/2014/main" id="{AA4CEDB6-B5C6-0D65-60ED-D1FD372157C0}"/>
+                <a16:creationId xmlns:a16="http://schemas.microsoft.com/office/drawing/2014/main" id="{AA4CEDB6-B5C6-0D65-60ED-D1FD372157C0}"/>
               </a:ext>
             </a:extLst>
           </p:cNvPr>
@@ -4304,7 +4304,7 @@
           <p:cNvPr id="7" name="Date Placeholder 6">
             <a:extLst>
               <a:ext uri="{FF2B5EF4-FFF2-40B4-BE49-F238E27FC236}">
-                <a16:creationId xmlns="" xmlns:a16="http://schemas.microsoft.com/office/drawing/2014/main" id="{87CA2232-6038-4FF5-E5F5-AA962379153B}"/>
+                <a16:creationId xmlns:a16="http://schemas.microsoft.com/office/drawing/2014/main" id="{87CA2232-6038-4FF5-E5F5-AA962379153B}"/>
               </a:ext>
             </a:extLst>
           </p:cNvPr>
@@ -4322,7 +4322,7 @@
           <a:p>
             <a:fld id="{9625E07E-267C-465F-9BA1-4B4F412DCF6A}" type="datetimeFigureOut">
               <a:rPr lang="x-none" smtClean="0"/>
-              <a:t>22/06/2025</a:t>
+              <a:t>22-6-2025</a:t>
             </a:fld>
             <a:endParaRPr lang="x-none"/>
           </a:p>
@@ -4333,7 +4333,7 @@
           <p:cNvPr id="8" name="Footer Placeholder 7">
             <a:extLst>
               <a:ext uri="{FF2B5EF4-FFF2-40B4-BE49-F238E27FC236}">
-                <a16:creationId xmlns="" xmlns:a16="http://schemas.microsoft.com/office/drawing/2014/main" id="{38131D76-1B57-8F48-1B39-85B5C19382E9}"/>
+                <a16:creationId xmlns:a16="http://schemas.microsoft.com/office/drawing/2014/main" id="{38131D76-1B57-8F48-1B39-85B5C19382E9}"/>
               </a:ext>
             </a:extLst>
           </p:cNvPr>
@@ -4358,7 +4358,7 @@
           <p:cNvPr id="9" name="Slide Number Placeholder 8">
             <a:extLst>
               <a:ext uri="{FF2B5EF4-FFF2-40B4-BE49-F238E27FC236}">
-                <a16:creationId xmlns="" xmlns:a16="http://schemas.microsoft.com/office/drawing/2014/main" id="{9DCC131E-571E-FF15-F8D8-7FC728E920D7}"/>
+                <a16:creationId xmlns:a16="http://schemas.microsoft.com/office/drawing/2014/main" id="{9DCC131E-571E-FF15-F8D8-7FC728E920D7}"/>
               </a:ext>
             </a:extLst>
           </p:cNvPr>
@@ -4376,7 +4376,7 @@
           <a:p>
             <a:fld id="{702BEA66-D241-493C-8698-9D3EF34A1033}" type="slidenum">
               <a:rPr lang="x-none" smtClean="0"/>
-              <a:t>‹#›</a:t>
+              <a:t>‹nr.›</a:t>
             </a:fld>
             <a:endParaRPr lang="x-none"/>
           </a:p>
@@ -4417,7 +4417,7 @@
           <p:cNvPr id="2" name="Title 1">
             <a:extLst>
               <a:ext uri="{FF2B5EF4-FFF2-40B4-BE49-F238E27FC236}">
-                <a16:creationId xmlns="" xmlns:a16="http://schemas.microsoft.com/office/drawing/2014/main" id="{67BEC499-2522-E629-AC8B-1BB16205B686}"/>
+                <a16:creationId xmlns:a16="http://schemas.microsoft.com/office/drawing/2014/main" id="{67BEC499-2522-E629-AC8B-1BB16205B686}"/>
               </a:ext>
             </a:extLst>
           </p:cNvPr>
@@ -4446,7 +4446,7 @@
           <p:cNvPr id="3" name="Date Placeholder 2">
             <a:extLst>
               <a:ext uri="{FF2B5EF4-FFF2-40B4-BE49-F238E27FC236}">
-                <a16:creationId xmlns="" xmlns:a16="http://schemas.microsoft.com/office/drawing/2014/main" id="{DA3548C5-F4AE-F0CA-2C74-EEDF8DD94962}"/>
+                <a16:creationId xmlns:a16="http://schemas.microsoft.com/office/drawing/2014/main" id="{DA3548C5-F4AE-F0CA-2C74-EEDF8DD94962}"/>
               </a:ext>
             </a:extLst>
           </p:cNvPr>
@@ -4464,7 +4464,7 @@
           <a:p>
             <a:fld id="{9625E07E-267C-465F-9BA1-4B4F412DCF6A}" type="datetimeFigureOut">
               <a:rPr lang="x-none" smtClean="0"/>
-              <a:t>22/06/2025</a:t>
+              <a:t>22-6-2025</a:t>
             </a:fld>
             <a:endParaRPr lang="x-none"/>
           </a:p>
@@ -4475,7 +4475,7 @@
           <p:cNvPr id="4" name="Footer Placeholder 3">
             <a:extLst>
               <a:ext uri="{FF2B5EF4-FFF2-40B4-BE49-F238E27FC236}">
-                <a16:creationId xmlns="" xmlns:a16="http://schemas.microsoft.com/office/drawing/2014/main" id="{94B35857-7B26-419F-DC5F-35BA6DCD0B54}"/>
+                <a16:creationId xmlns:a16="http://schemas.microsoft.com/office/drawing/2014/main" id="{94B35857-7B26-419F-DC5F-35BA6DCD0B54}"/>
               </a:ext>
             </a:extLst>
           </p:cNvPr>
@@ -4500,7 +4500,7 @@
           <p:cNvPr id="5" name="Slide Number Placeholder 4">
             <a:extLst>
               <a:ext uri="{FF2B5EF4-FFF2-40B4-BE49-F238E27FC236}">
-                <a16:creationId xmlns="" xmlns:a16="http://schemas.microsoft.com/office/drawing/2014/main" id="{8B85F935-11BB-4620-D389-C516CC630D7D}"/>
+                <a16:creationId xmlns:a16="http://schemas.microsoft.com/office/drawing/2014/main" id="{8B85F935-11BB-4620-D389-C516CC630D7D}"/>
               </a:ext>
             </a:extLst>
           </p:cNvPr>
@@ -4518,7 +4518,7 @@
           <a:p>
             <a:fld id="{702BEA66-D241-493C-8698-9D3EF34A1033}" type="slidenum">
               <a:rPr lang="x-none" smtClean="0"/>
-              <a:t>‹#›</a:t>
+              <a:t>‹nr.›</a:t>
             </a:fld>
             <a:endParaRPr lang="x-none"/>
           </a:p>
@@ -4559,7 +4559,7 @@
           <p:cNvPr id="2" name="Date Placeholder 1">
             <a:extLst>
               <a:ext uri="{FF2B5EF4-FFF2-40B4-BE49-F238E27FC236}">
-                <a16:creationId xmlns="" xmlns:a16="http://schemas.microsoft.com/office/drawing/2014/main" id="{2FC14633-FE5B-A631-5911-A076E70196C1}"/>
+                <a16:creationId xmlns:a16="http://schemas.microsoft.com/office/drawing/2014/main" id="{2FC14633-FE5B-A631-5911-A076E70196C1}"/>
               </a:ext>
             </a:extLst>
           </p:cNvPr>
@@ -4577,7 +4577,7 @@
           <a:p>
             <a:fld id="{9625E07E-267C-465F-9BA1-4B4F412DCF6A}" type="datetimeFigureOut">
               <a:rPr lang="x-none" smtClean="0"/>
-              <a:t>22/06/2025</a:t>
+              <a:t>22-6-2025</a:t>
             </a:fld>
             <a:endParaRPr lang="x-none"/>
           </a:p>
@@ -4588,7 +4588,7 @@
           <p:cNvPr id="3" name="Footer Placeholder 2">
             <a:extLst>
               <a:ext uri="{FF2B5EF4-FFF2-40B4-BE49-F238E27FC236}">
-                <a16:creationId xmlns="" xmlns:a16="http://schemas.microsoft.com/office/drawing/2014/main" id="{0EEA1E4F-5A1E-4701-172A-5E42A8408216}"/>
+                <a16:creationId xmlns:a16="http://schemas.microsoft.com/office/drawing/2014/main" id="{0EEA1E4F-5A1E-4701-172A-5E42A8408216}"/>
               </a:ext>
             </a:extLst>
           </p:cNvPr>
@@ -4613,7 +4613,7 @@
           <p:cNvPr id="4" name="Slide Number Placeholder 3">
             <a:extLst>
               <a:ext uri="{FF2B5EF4-FFF2-40B4-BE49-F238E27FC236}">
-                <a16:creationId xmlns="" xmlns:a16="http://schemas.microsoft.com/office/drawing/2014/main" id="{F54F5126-2A39-1CF0-267B-94DA5FEF72A8}"/>
+                <a16:creationId xmlns:a16="http://schemas.microsoft.com/office/drawing/2014/main" id="{F54F5126-2A39-1CF0-267B-94DA5FEF72A8}"/>
               </a:ext>
             </a:extLst>
           </p:cNvPr>
@@ -4631,7 +4631,7 @@
           <a:p>
             <a:fld id="{702BEA66-D241-493C-8698-9D3EF34A1033}" type="slidenum">
               <a:rPr lang="x-none" smtClean="0"/>
-              <a:t>‹#›</a:t>
+              <a:t>‹nr.›</a:t>
             </a:fld>
             <a:endParaRPr lang="x-none"/>
           </a:p>
@@ -4672,7 +4672,7 @@
           <p:cNvPr id="2" name="Title 1">
             <a:extLst>
               <a:ext uri="{FF2B5EF4-FFF2-40B4-BE49-F238E27FC236}">
-                <a16:creationId xmlns="" xmlns:a16="http://schemas.microsoft.com/office/drawing/2014/main" id="{D96210C1-AC72-3D01-079F-19898FF1E751}"/>
+                <a16:creationId xmlns:a16="http://schemas.microsoft.com/office/drawing/2014/main" id="{D96210C1-AC72-3D01-079F-19898FF1E751}"/>
               </a:ext>
             </a:extLst>
           </p:cNvPr>
@@ -4710,7 +4710,7 @@
           <p:cNvPr id="3" name="Content Placeholder 2">
             <a:extLst>
               <a:ext uri="{FF2B5EF4-FFF2-40B4-BE49-F238E27FC236}">
-                <a16:creationId xmlns="" xmlns:a16="http://schemas.microsoft.com/office/drawing/2014/main" id="{C6BA6CF6-333C-98CF-0B85-A32570120DB3}"/>
+                <a16:creationId xmlns:a16="http://schemas.microsoft.com/office/drawing/2014/main" id="{C6BA6CF6-333C-98CF-0B85-A32570120DB3}"/>
               </a:ext>
             </a:extLst>
           </p:cNvPr>
@@ -4801,7 +4801,7 @@
           <p:cNvPr id="4" name="Text Placeholder 3">
             <a:extLst>
               <a:ext uri="{FF2B5EF4-FFF2-40B4-BE49-F238E27FC236}">
-                <a16:creationId xmlns="" xmlns:a16="http://schemas.microsoft.com/office/drawing/2014/main" id="{0B1D29B6-FD60-4694-0D97-DDE4F5C1CDC9}"/>
+                <a16:creationId xmlns:a16="http://schemas.microsoft.com/office/drawing/2014/main" id="{0B1D29B6-FD60-4694-0D97-DDE4F5C1CDC9}"/>
               </a:ext>
             </a:extLst>
           </p:cNvPr>
@@ -4872,7 +4872,7 @@
           <p:cNvPr id="5" name="Date Placeholder 4">
             <a:extLst>
               <a:ext uri="{FF2B5EF4-FFF2-40B4-BE49-F238E27FC236}">
-                <a16:creationId xmlns="" xmlns:a16="http://schemas.microsoft.com/office/drawing/2014/main" id="{74C4A5A8-50DC-EEF1-D2E6-CB0711F7B420}"/>
+                <a16:creationId xmlns:a16="http://schemas.microsoft.com/office/drawing/2014/main" id="{74C4A5A8-50DC-EEF1-D2E6-CB0711F7B420}"/>
               </a:ext>
             </a:extLst>
           </p:cNvPr>
@@ -4890,7 +4890,7 @@
           <a:p>
             <a:fld id="{9625E07E-267C-465F-9BA1-4B4F412DCF6A}" type="datetimeFigureOut">
               <a:rPr lang="x-none" smtClean="0"/>
-              <a:t>22/06/2025</a:t>
+              <a:t>22-6-2025</a:t>
             </a:fld>
             <a:endParaRPr lang="x-none"/>
           </a:p>
@@ -4901,7 +4901,7 @@
           <p:cNvPr id="6" name="Footer Placeholder 5">
             <a:extLst>
               <a:ext uri="{FF2B5EF4-FFF2-40B4-BE49-F238E27FC236}">
-                <a16:creationId xmlns="" xmlns:a16="http://schemas.microsoft.com/office/drawing/2014/main" id="{0A245FB8-4C03-2797-A282-7533B5C882FD}"/>
+                <a16:creationId xmlns:a16="http://schemas.microsoft.com/office/drawing/2014/main" id="{0A245FB8-4C03-2797-A282-7533B5C882FD}"/>
               </a:ext>
             </a:extLst>
           </p:cNvPr>
@@ -4926,7 +4926,7 @@
           <p:cNvPr id="7" name="Slide Number Placeholder 6">
             <a:extLst>
               <a:ext uri="{FF2B5EF4-FFF2-40B4-BE49-F238E27FC236}">
-                <a16:creationId xmlns="" xmlns:a16="http://schemas.microsoft.com/office/drawing/2014/main" id="{383442A3-1C27-E57D-603F-7B4913664866}"/>
+                <a16:creationId xmlns:a16="http://schemas.microsoft.com/office/drawing/2014/main" id="{383442A3-1C27-E57D-603F-7B4913664866}"/>
               </a:ext>
             </a:extLst>
           </p:cNvPr>
@@ -4944,7 +4944,7 @@
           <a:p>
             <a:fld id="{702BEA66-D241-493C-8698-9D3EF34A1033}" type="slidenum">
               <a:rPr lang="x-none" smtClean="0"/>
-              <a:t>‹#›</a:t>
+              <a:t>‹nr.›</a:t>
             </a:fld>
             <a:endParaRPr lang="x-none"/>
           </a:p>
@@ -4985,7 +4985,7 @@
           <p:cNvPr id="2" name="Title 1">
             <a:extLst>
               <a:ext uri="{FF2B5EF4-FFF2-40B4-BE49-F238E27FC236}">
-                <a16:creationId xmlns="" xmlns:a16="http://schemas.microsoft.com/office/drawing/2014/main" id="{20DC03A7-0887-A6EA-6015-DDA342B34BE7}"/>
+                <a16:creationId xmlns:a16="http://schemas.microsoft.com/office/drawing/2014/main" id="{20DC03A7-0887-A6EA-6015-DDA342B34BE7}"/>
               </a:ext>
             </a:extLst>
           </p:cNvPr>
@@ -5023,7 +5023,7 @@
           <p:cNvPr id="3" name="Picture Placeholder 2">
             <a:extLst>
               <a:ext uri="{FF2B5EF4-FFF2-40B4-BE49-F238E27FC236}">
-                <a16:creationId xmlns="" xmlns:a16="http://schemas.microsoft.com/office/drawing/2014/main" id="{A216381B-2557-2F76-5907-CCB319D8C90A}"/>
+                <a16:creationId xmlns:a16="http://schemas.microsoft.com/office/drawing/2014/main" id="{A216381B-2557-2F76-5907-CCB319D8C90A}"/>
               </a:ext>
             </a:extLst>
           </p:cNvPr>
@@ -5090,7 +5090,7 @@
           <p:cNvPr id="4" name="Text Placeholder 3">
             <a:extLst>
               <a:ext uri="{FF2B5EF4-FFF2-40B4-BE49-F238E27FC236}">
-                <a16:creationId xmlns="" xmlns:a16="http://schemas.microsoft.com/office/drawing/2014/main" id="{22E9AFCF-A872-0D7E-00C5-177411B78EB8}"/>
+                <a16:creationId xmlns:a16="http://schemas.microsoft.com/office/drawing/2014/main" id="{22E9AFCF-A872-0D7E-00C5-177411B78EB8}"/>
               </a:ext>
             </a:extLst>
           </p:cNvPr>
@@ -5161,7 +5161,7 @@
           <p:cNvPr id="5" name="Date Placeholder 4">
             <a:extLst>
               <a:ext uri="{FF2B5EF4-FFF2-40B4-BE49-F238E27FC236}">
-                <a16:creationId xmlns="" xmlns:a16="http://schemas.microsoft.com/office/drawing/2014/main" id="{389BC01C-6BCD-19E7-7A68-F7FE7186F5AA}"/>
+                <a16:creationId xmlns:a16="http://schemas.microsoft.com/office/drawing/2014/main" id="{389BC01C-6BCD-19E7-7A68-F7FE7186F5AA}"/>
               </a:ext>
             </a:extLst>
           </p:cNvPr>
@@ -5179,7 +5179,7 @@
           <a:p>
             <a:fld id="{9625E07E-267C-465F-9BA1-4B4F412DCF6A}" type="datetimeFigureOut">
               <a:rPr lang="x-none" smtClean="0"/>
-              <a:t>22/06/2025</a:t>
+              <a:t>22-6-2025</a:t>
             </a:fld>
             <a:endParaRPr lang="x-none"/>
           </a:p>
@@ -5190,7 +5190,7 @@
           <p:cNvPr id="6" name="Footer Placeholder 5">
             <a:extLst>
               <a:ext uri="{FF2B5EF4-FFF2-40B4-BE49-F238E27FC236}">
-                <a16:creationId xmlns="" xmlns:a16="http://schemas.microsoft.com/office/drawing/2014/main" id="{57E59AC8-9A30-BB7F-E75C-5CF9A45D2CBC}"/>
+                <a16:creationId xmlns:a16="http://schemas.microsoft.com/office/drawing/2014/main" id="{57E59AC8-9A30-BB7F-E75C-5CF9A45D2CBC}"/>
               </a:ext>
             </a:extLst>
           </p:cNvPr>
@@ -5215,7 +5215,7 @@
           <p:cNvPr id="7" name="Slide Number Placeholder 6">
             <a:extLst>
               <a:ext uri="{FF2B5EF4-FFF2-40B4-BE49-F238E27FC236}">
-                <a16:creationId xmlns="" xmlns:a16="http://schemas.microsoft.com/office/drawing/2014/main" id="{531AF731-8836-98E1-D456-F82C9CA5943F}"/>
+                <a16:creationId xmlns:a16="http://schemas.microsoft.com/office/drawing/2014/main" id="{531AF731-8836-98E1-D456-F82C9CA5943F}"/>
               </a:ext>
             </a:extLst>
           </p:cNvPr>
@@ -5233,7 +5233,7 @@
           <a:p>
             <a:fld id="{702BEA66-D241-493C-8698-9D3EF34A1033}" type="slidenum">
               <a:rPr lang="x-none" smtClean="0"/>
-              <a:t>‹#›</a:t>
+              <a:t>‹nr.›</a:t>
             </a:fld>
             <a:endParaRPr lang="x-none"/>
           </a:p>
@@ -5279,7 +5279,7 @@
           <p:cNvPr id="2" name="Title Placeholder 1">
             <a:extLst>
               <a:ext uri="{FF2B5EF4-FFF2-40B4-BE49-F238E27FC236}">
-                <a16:creationId xmlns="" xmlns:a16="http://schemas.microsoft.com/office/drawing/2014/main" id="{845EA37C-47A3-5DB5-9DF9-524A8115415C}"/>
+                <a16:creationId xmlns:a16="http://schemas.microsoft.com/office/drawing/2014/main" id="{845EA37C-47A3-5DB5-9DF9-524A8115415C}"/>
               </a:ext>
             </a:extLst>
           </p:cNvPr>
@@ -5318,7 +5318,7 @@
           <p:cNvPr id="3" name="Text Placeholder 2">
             <a:extLst>
               <a:ext uri="{FF2B5EF4-FFF2-40B4-BE49-F238E27FC236}">
-                <a16:creationId xmlns="" xmlns:a16="http://schemas.microsoft.com/office/drawing/2014/main" id="{B31634C0-369D-11DE-5EF6-5BA1DFB8C23B}"/>
+                <a16:creationId xmlns:a16="http://schemas.microsoft.com/office/drawing/2014/main" id="{B31634C0-369D-11DE-5EF6-5BA1DFB8C23B}"/>
               </a:ext>
             </a:extLst>
           </p:cNvPr>
@@ -5386,7 +5386,7 @@
           <p:cNvPr id="4" name="Date Placeholder 3">
             <a:extLst>
               <a:ext uri="{FF2B5EF4-FFF2-40B4-BE49-F238E27FC236}">
-                <a16:creationId xmlns="" xmlns:a16="http://schemas.microsoft.com/office/drawing/2014/main" id="{1B0A73C7-2346-E06C-D9F8-49BDFB87B82F}"/>
+                <a16:creationId xmlns:a16="http://schemas.microsoft.com/office/drawing/2014/main" id="{1B0A73C7-2346-E06C-D9F8-49BDFB87B82F}"/>
               </a:ext>
             </a:extLst>
           </p:cNvPr>
@@ -5422,7 +5422,7 @@
           <a:p>
             <a:fld id="{9625E07E-267C-465F-9BA1-4B4F412DCF6A}" type="datetimeFigureOut">
               <a:rPr lang="x-none" smtClean="0"/>
-              <a:t>22/06/2025</a:t>
+              <a:t>22-6-2025</a:t>
             </a:fld>
             <a:endParaRPr lang="x-none"/>
           </a:p>
@@ -5433,7 +5433,7 @@
           <p:cNvPr id="5" name="Footer Placeholder 4">
             <a:extLst>
               <a:ext uri="{FF2B5EF4-FFF2-40B4-BE49-F238E27FC236}">
-                <a16:creationId xmlns="" xmlns:a16="http://schemas.microsoft.com/office/drawing/2014/main" id="{4A354C97-D9B9-AF69-4590-735042934F40}"/>
+                <a16:creationId xmlns:a16="http://schemas.microsoft.com/office/drawing/2014/main" id="{4A354C97-D9B9-AF69-4590-735042934F40}"/>
               </a:ext>
             </a:extLst>
           </p:cNvPr>
@@ -5476,7 +5476,7 @@
           <p:cNvPr id="6" name="Slide Number Placeholder 5">
             <a:extLst>
               <a:ext uri="{FF2B5EF4-FFF2-40B4-BE49-F238E27FC236}">
-                <a16:creationId xmlns="" xmlns:a16="http://schemas.microsoft.com/office/drawing/2014/main" id="{E2C8C72D-5D30-65E4-DC6E-C10F556592FD}"/>
+                <a16:creationId xmlns:a16="http://schemas.microsoft.com/office/drawing/2014/main" id="{E2C8C72D-5D30-65E4-DC6E-C10F556592FD}"/>
               </a:ext>
             </a:extLst>
           </p:cNvPr>
@@ -5512,7 +5512,7 @@
           <a:p>
             <a:fld id="{702BEA66-D241-493C-8698-9D3EF34A1033}" type="slidenum">
               <a:rPr lang="x-none" smtClean="0"/>
-              <a:t>‹#›</a:t>
+              <a:t>‹nr.›</a:t>
             </a:fld>
             <a:endParaRPr lang="x-none"/>
           </a:p>
@@ -5841,7 +5841,7 @@
         <p:cNvPr id="1" name="">
           <a:extLst>
             <a:ext uri="{FF2B5EF4-FFF2-40B4-BE49-F238E27FC236}">
-              <a16:creationId xmlns="" xmlns:a16="http://schemas.microsoft.com/office/drawing/2014/main" id="{E10A073C-28E1-D86D-31C9-2E1B17A9214D}"/>
+              <a16:creationId xmlns:a16="http://schemas.microsoft.com/office/drawing/2014/main" id="{E10A073C-28E1-D86D-31C9-2E1B17A9214D}"/>
             </a:ext>
           </a:extLst>
         </p:cNvPr>
@@ -5861,7 +5861,7 @@
           <p:cNvPr id="3" name="TextBox 2">
             <a:extLst>
               <a:ext uri="{FF2B5EF4-FFF2-40B4-BE49-F238E27FC236}">
-                <a16:creationId xmlns="" xmlns:a16="http://schemas.microsoft.com/office/drawing/2014/main" id="{A218E740-3451-BBB6-1CB5-7117BB1F83D4}"/>
+                <a16:creationId xmlns:a16="http://schemas.microsoft.com/office/drawing/2014/main" id="{A218E740-3451-BBB6-1CB5-7117BB1F83D4}"/>
               </a:ext>
             </a:extLst>
           </p:cNvPr>
@@ -5931,7 +5931,7 @@
           <p:cNvPr id="8" name="TextBox 7">
             <a:extLst>
               <a:ext uri="{FF2B5EF4-FFF2-40B4-BE49-F238E27FC236}">
-                <a16:creationId xmlns="" xmlns:a16="http://schemas.microsoft.com/office/drawing/2014/main" id="{56191F34-22CB-5DCC-979B-194A383B6CFB}"/>
+                <a16:creationId xmlns:a16="http://schemas.microsoft.com/office/drawing/2014/main" id="{56191F34-22CB-5DCC-979B-194A383B6CFB}"/>
               </a:ext>
             </a:extLst>
           </p:cNvPr>
@@ -6129,13 +6129,6 @@
   <p:clrMapOvr>
     <a:masterClrMapping/>
   </p:clrMapOvr>
-  <p:timing>
-    <p:tnLst>
-      <p:par>
-        <p:cTn id="1" dur="indefinite" restart="never" nodeType="tmRoot"/>
-      </p:par>
-    </p:tnLst>
-  </p:timing>
 </p:sld>
 </file>
 
@@ -6158,7 +6151,7 @@
         <p:cNvPr id="1" name="">
           <a:extLst>
             <a:ext uri="{FF2B5EF4-FFF2-40B4-BE49-F238E27FC236}">
-              <a16:creationId xmlns="" xmlns:a16="http://schemas.microsoft.com/office/drawing/2014/main" id="{EC8CE6C2-50DA-7B88-B8F4-A60B3BB3C698}"/>
+              <a16:creationId xmlns:a16="http://schemas.microsoft.com/office/drawing/2014/main" id="{EC8CE6C2-50DA-7B88-B8F4-A60B3BB3C698}"/>
             </a:ext>
           </a:extLst>
         </p:cNvPr>
@@ -6178,7 +6171,7 @@
           <p:cNvPr id="5" name="Rectangle 4">
             <a:extLst>
               <a:ext uri="{FF2B5EF4-FFF2-40B4-BE49-F238E27FC236}">
-                <a16:creationId xmlns="" xmlns:a16="http://schemas.microsoft.com/office/drawing/2014/main" id="{F76FBCC6-F9D9-9148-A9D3-12D44C3BA5CA}"/>
+                <a16:creationId xmlns:a16="http://schemas.microsoft.com/office/drawing/2014/main" id="{F76FBCC6-F9D9-9148-A9D3-12D44C3BA5CA}"/>
               </a:ext>
             </a:extLst>
           </p:cNvPr>
@@ -6234,7 +6227,7 @@
           <p:cNvPr id="2" name="000_topleftHeading">
             <a:extLst>
               <a:ext uri="{FF2B5EF4-FFF2-40B4-BE49-F238E27FC236}">
-                <a16:creationId xmlns="" xmlns:a16="http://schemas.microsoft.com/office/drawing/2014/main" id="{768E9ECE-6B6D-743D-B969-573EE62619B9}"/>
+                <a16:creationId xmlns:a16="http://schemas.microsoft.com/office/drawing/2014/main" id="{768E9ECE-6B6D-743D-B969-573EE62619B9}"/>
               </a:ext>
             </a:extLst>
           </p:cNvPr>
@@ -6258,7 +6251,7 @@
           <a:lstStyle/>
           <a:p>
             <a:r>
-              <a:rPr lang="en-US" dirty="0" smtClean="0">
+              <a:rPr lang="en-US" dirty="0">
                 <a:latin typeface="Yu Gothic UI Light" panose="020B0300000000000000" pitchFamily="34" charset="-128"/>
                 <a:ea typeface="Yu Gothic UI Light" panose="020B0300000000000000" pitchFamily="34" charset="-128"/>
               </a:rPr>
@@ -6276,7 +6269,7 @@
           <p:cNvPr id="10" name="001_subtitle">
             <a:extLst>
               <a:ext uri="{FF2B5EF4-FFF2-40B4-BE49-F238E27FC236}">
-                <a16:creationId xmlns="" xmlns:a16="http://schemas.microsoft.com/office/drawing/2014/main" id="{5F0C334F-F24D-F098-108A-AF7FA21D72E4}"/>
+                <a16:creationId xmlns:a16="http://schemas.microsoft.com/office/drawing/2014/main" id="{5F0C334F-F24D-F098-108A-AF7FA21D72E4}"/>
               </a:ext>
             </a:extLst>
           </p:cNvPr>
@@ -6318,7 +6311,7 @@
           <p:cNvPr id="11" name="Rectangle 10">
             <a:extLst>
               <a:ext uri="{FF2B5EF4-FFF2-40B4-BE49-F238E27FC236}">
-                <a16:creationId xmlns="" xmlns:a16="http://schemas.microsoft.com/office/drawing/2014/main" id="{B977D03C-FE2F-8E34-E262-15B6B156FC91}"/>
+                <a16:creationId xmlns:a16="http://schemas.microsoft.com/office/drawing/2014/main" id="{B977D03C-FE2F-8E34-E262-15B6B156FC91}"/>
               </a:ext>
             </a:extLst>
           </p:cNvPr>
@@ -6382,7 +6375,7 @@
           <p:cNvPr id="12" name="Rectangle 11">
             <a:extLst>
               <a:ext uri="{FF2B5EF4-FFF2-40B4-BE49-F238E27FC236}">
-                <a16:creationId xmlns="" xmlns:a16="http://schemas.microsoft.com/office/drawing/2014/main" id="{E3DBEAE1-C4DA-0148-C38A-8B96CAB552F1}"/>
+                <a16:creationId xmlns:a16="http://schemas.microsoft.com/office/drawing/2014/main" id="{E3DBEAE1-C4DA-0148-C38A-8B96CAB552F1}"/>
               </a:ext>
             </a:extLst>
           </p:cNvPr>
@@ -6446,7 +6439,7 @@
           <p:cNvPr id="3" name="Rectangle 2">
             <a:extLst>
               <a:ext uri="{FF2B5EF4-FFF2-40B4-BE49-F238E27FC236}">
-                <a16:creationId xmlns="" xmlns:a16="http://schemas.microsoft.com/office/drawing/2014/main" id="{B64166FE-6558-DEB1-2917-D5A660DB9814}"/>
+                <a16:creationId xmlns:a16="http://schemas.microsoft.com/office/drawing/2014/main" id="{B64166FE-6558-DEB1-2917-D5A660DB9814}"/>
               </a:ext>
             </a:extLst>
           </p:cNvPr>
@@ -6506,7 +6499,7 @@
           <p:cNvPr id="3074" name="Picture 2" descr="Schematic diagram of 2D hyperplane in 3D feature space. The red and ...">
             <a:extLst>
               <a:ext uri="{FF2B5EF4-FFF2-40B4-BE49-F238E27FC236}">
-                <a16:creationId xmlns="" xmlns:a16="http://schemas.microsoft.com/office/drawing/2014/main" id="{39292B54-3F7D-5E1E-C16F-CA7CF57E7C0C}"/>
+                <a16:creationId xmlns:a16="http://schemas.microsoft.com/office/drawing/2014/main" id="{39292B54-3F7D-5E1E-C16F-CA7CF57E7C0C}"/>
               </a:ext>
             </a:extLst>
           </p:cNvPr>
@@ -6553,7 +6546,7 @@
           <p:cNvPr id="3076" name="Picture 4" descr="Random Forest – TikZ.net">
             <a:extLst>
               <a:ext uri="{FF2B5EF4-FFF2-40B4-BE49-F238E27FC236}">
-                <a16:creationId xmlns="" xmlns:a16="http://schemas.microsoft.com/office/drawing/2014/main" id="{4B66FDFC-1A82-93C4-95F5-9935BA4CB599}"/>
+                <a16:creationId xmlns:a16="http://schemas.microsoft.com/office/drawing/2014/main" id="{4B66FDFC-1A82-93C4-95F5-9935BA4CB599}"/>
               </a:ext>
             </a:extLst>
           </p:cNvPr>
@@ -6600,7 +6593,7 @@
           <p:cNvPr id="3078" name="Picture 6" descr="Linear Regression Explained | Papers With Code">
             <a:extLst>
               <a:ext uri="{FF2B5EF4-FFF2-40B4-BE49-F238E27FC236}">
-                <a16:creationId xmlns="" xmlns:a16="http://schemas.microsoft.com/office/drawing/2014/main" id="{D4C8ADE4-274D-5A64-8F69-30483698A725}"/>
+                <a16:creationId xmlns:a16="http://schemas.microsoft.com/office/drawing/2014/main" id="{D4C8ADE4-274D-5A64-8F69-30483698A725}"/>
               </a:ext>
             </a:extLst>
           </p:cNvPr>
@@ -6647,7 +6640,7 @@
           <p:cNvPr id="4" name="Graphic 3">
             <a:extLst>
               <a:ext uri="{FF2B5EF4-FFF2-40B4-BE49-F238E27FC236}">
-                <a16:creationId xmlns="" xmlns:a16="http://schemas.microsoft.com/office/drawing/2014/main" id="{41B84DD7-C8A8-031E-1F48-DAE64F00881C}"/>
+                <a16:creationId xmlns:a16="http://schemas.microsoft.com/office/drawing/2014/main" id="{41B84DD7-C8A8-031E-1F48-DAE64F00881C}"/>
               </a:ext>
             </a:extLst>
           </p:cNvPr>
@@ -6660,7 +6653,7 @@
           <a:blip r:embed="rId5">
             <a:extLst>
               <a:ext uri="{96DAC541-7B7A-43D3-8B79-37D633B846F1}">
-                <asvg:svgBlip xmlns="" xmlns:asvg="http://schemas.microsoft.com/office/drawing/2016/SVG/main" r:embed="rId6"/>
+                <asvg:svgBlip xmlns:asvg="http://schemas.microsoft.com/office/drawing/2016/SVG/main" r:embed="rId6"/>
               </a:ext>
             </a:extLst>
           </a:blip>
@@ -6688,13 +6681,6 @@
   <p:clrMapOvr>
     <a:masterClrMapping/>
   </p:clrMapOvr>
-  <p:timing>
-    <p:tnLst>
-      <p:par>
-        <p:cTn id="1" dur="indefinite" restart="never" nodeType="tmRoot"/>
-      </p:par>
-    </p:tnLst>
-  </p:timing>
 </p:sld>
 </file>
 
@@ -6717,7 +6703,7 @@
         <p:cNvPr id="1" name="">
           <a:extLst>
             <a:ext uri="{FF2B5EF4-FFF2-40B4-BE49-F238E27FC236}">
-              <a16:creationId xmlns="" xmlns:a16="http://schemas.microsoft.com/office/drawing/2014/main" id="{EC8CE6C2-50DA-7B88-B8F4-A60B3BB3C698}"/>
+              <a16:creationId xmlns:a16="http://schemas.microsoft.com/office/drawing/2014/main" id="{EC8CE6C2-50DA-7B88-B8F4-A60B3BB3C698}"/>
             </a:ext>
           </a:extLst>
         </p:cNvPr>
@@ -6737,7 +6723,7 @@
           <p:cNvPr id="5" name="Rectangle 4">
             <a:extLst>
               <a:ext uri="{FF2B5EF4-FFF2-40B4-BE49-F238E27FC236}">
-                <a16:creationId xmlns="" xmlns:a16="http://schemas.microsoft.com/office/drawing/2014/main" id="{F76FBCC6-F9D9-9148-A9D3-12D44C3BA5CA}"/>
+                <a16:creationId xmlns:a16="http://schemas.microsoft.com/office/drawing/2014/main" id="{F76FBCC6-F9D9-9148-A9D3-12D44C3BA5CA}"/>
               </a:ext>
             </a:extLst>
           </p:cNvPr>
@@ -6793,7 +6779,7 @@
           <p:cNvPr id="2" name="000_topleftHeading">
             <a:extLst>
               <a:ext uri="{FF2B5EF4-FFF2-40B4-BE49-F238E27FC236}">
-                <a16:creationId xmlns="" xmlns:a16="http://schemas.microsoft.com/office/drawing/2014/main" id="{768E9ECE-6B6D-743D-B969-573EE62619B9}"/>
+                <a16:creationId xmlns:a16="http://schemas.microsoft.com/office/drawing/2014/main" id="{768E9ECE-6B6D-743D-B969-573EE62619B9}"/>
               </a:ext>
             </a:extLst>
           </p:cNvPr>
@@ -6819,7 +6805,7 @@
           <a:lstStyle/>
           <a:p>
             <a:r>
-              <a:rPr lang="en-US" dirty="0" smtClean="0">
+              <a:rPr lang="en-US" dirty="0">
                 <a:latin typeface="Yu Gothic UI Light" panose="020B0300000000000000" pitchFamily="34" charset="-128"/>
                 <a:ea typeface="Yu Gothic UI Light" panose="020B0300000000000000" pitchFamily="34" charset="-128"/>
               </a:rPr>
@@ -6828,16 +6814,16 @@
           </a:p>
           <a:p>
             <a:r>
-              <a:rPr lang="en-US" dirty="0" smtClean="0">
-                <a:latin typeface="Yu Gothic UI Light" panose="020B0300000000000000" pitchFamily="34" charset="-128"/>
-                <a:ea typeface="Yu Gothic UI Light" panose="020B0300000000000000" pitchFamily="34" charset="-128"/>
-              </a:rPr>
-              <a:t>         evaluation</a:t>
-            </a:r>
-          </a:p>
-          <a:p>
-            <a:r>
-              <a:rPr lang="en-US" dirty="0" smtClean="0">
+              <a:rPr lang="en-US" dirty="0">
+                <a:latin typeface="Yu Gothic UI Light" panose="020B0300000000000000" pitchFamily="34" charset="-128"/>
+                <a:ea typeface="Yu Gothic UI Light" panose="020B0300000000000000" pitchFamily="34" charset="-128"/>
+              </a:rPr>
+              <a:t>evaluation</a:t>
+            </a:r>
+          </a:p>
+          <a:p>
+            <a:r>
+              <a:rPr lang="en-US" dirty="0">
                 <a:latin typeface="Yu Gothic UI Light" panose="020B0300000000000000" pitchFamily="34" charset="-128"/>
                 <a:ea typeface="Yu Gothic UI Light" panose="020B0300000000000000" pitchFamily="34" charset="-128"/>
               </a:rPr>
@@ -6855,7 +6841,7 @@
           <p:cNvPr id="11" name="Rectangle 10">
             <a:extLst>
               <a:ext uri="{FF2B5EF4-FFF2-40B4-BE49-F238E27FC236}">
-                <a16:creationId xmlns="" xmlns:a16="http://schemas.microsoft.com/office/drawing/2014/main" id="{B977D03C-FE2F-8E34-E262-15B6B156FC91}"/>
+                <a16:creationId xmlns:a16="http://schemas.microsoft.com/office/drawing/2014/main" id="{B977D03C-FE2F-8E34-E262-15B6B156FC91}"/>
               </a:ext>
             </a:extLst>
           </p:cNvPr>
@@ -6919,7 +6905,7 @@
           <p:cNvPr id="12" name="Rectangle 11">
             <a:extLst>
               <a:ext uri="{FF2B5EF4-FFF2-40B4-BE49-F238E27FC236}">
-                <a16:creationId xmlns="" xmlns:a16="http://schemas.microsoft.com/office/drawing/2014/main" id="{E3DBEAE1-C4DA-0148-C38A-8B96CAB552F1}"/>
+                <a16:creationId xmlns:a16="http://schemas.microsoft.com/office/drawing/2014/main" id="{E3DBEAE1-C4DA-0148-C38A-8B96CAB552F1}"/>
               </a:ext>
             </a:extLst>
           </p:cNvPr>
@@ -6983,7 +6969,7 @@
           <p:cNvPr id="16" name="Rectangle 15">
             <a:extLst>
               <a:ext uri="{FF2B5EF4-FFF2-40B4-BE49-F238E27FC236}">
-                <a16:creationId xmlns="" xmlns:a16="http://schemas.microsoft.com/office/drawing/2014/main" id="{5FCE5D7E-1EB7-1E53-281F-BCE90E941E6F}"/>
+                <a16:creationId xmlns:a16="http://schemas.microsoft.com/office/drawing/2014/main" id="{5FCE5D7E-1EB7-1E53-281F-BCE90E941E6F}"/>
               </a:ext>
             </a:extLst>
           </p:cNvPr>
@@ -7047,7 +7033,7 @@
           <p:cNvPr id="21" name="Rectangle 20">
             <a:extLst>
               <a:ext uri="{FF2B5EF4-FFF2-40B4-BE49-F238E27FC236}">
-                <a16:creationId xmlns="" xmlns:a16="http://schemas.microsoft.com/office/drawing/2014/main" id="{E63E312E-81EF-4E2E-D165-46A30798A110}"/>
+                <a16:creationId xmlns:a16="http://schemas.microsoft.com/office/drawing/2014/main" id="{E63E312E-81EF-4E2E-D165-46A30798A110}"/>
               </a:ext>
             </a:extLst>
           </p:cNvPr>
@@ -7111,7 +7097,7 @@
           <p:cNvPr id="24" name="Rectangle 23">
             <a:extLst>
               <a:ext uri="{FF2B5EF4-FFF2-40B4-BE49-F238E27FC236}">
-                <a16:creationId xmlns="" xmlns:a16="http://schemas.microsoft.com/office/drawing/2014/main" id="{2847509F-7CDD-5BB4-6FE7-FBED3A0874BC}"/>
+                <a16:creationId xmlns:a16="http://schemas.microsoft.com/office/drawing/2014/main" id="{2847509F-7CDD-5BB4-6FE7-FBED3A0874BC}"/>
               </a:ext>
             </a:extLst>
           </p:cNvPr>
@@ -7171,7 +7157,7 @@
           <p:cNvPr id="3" name="Rectangle 2">
             <a:extLst>
               <a:ext uri="{FF2B5EF4-FFF2-40B4-BE49-F238E27FC236}">
-                <a16:creationId xmlns="" xmlns:a16="http://schemas.microsoft.com/office/drawing/2014/main" id="{B64166FE-6558-DEB1-2917-D5A660DB9814}"/>
+                <a16:creationId xmlns:a16="http://schemas.microsoft.com/office/drawing/2014/main" id="{B64166FE-6558-DEB1-2917-D5A660DB9814}"/>
               </a:ext>
             </a:extLst>
           </p:cNvPr>
@@ -7231,7 +7217,7 @@
           <p:cNvPr id="18" name="Afbeelding 17">
             <a:extLst>
               <a:ext uri="{FF2B5EF4-FFF2-40B4-BE49-F238E27FC236}">
-                <a16:creationId xmlns="" xmlns:a16="http://schemas.microsoft.com/office/drawing/2014/main" id="{87D3ECC6-89CF-B3E4-A345-FCD4E7C4500D}"/>
+                <a16:creationId xmlns:a16="http://schemas.microsoft.com/office/drawing/2014/main" id="{87D3ECC6-89CF-B3E4-A345-FCD4E7C4500D}"/>
               </a:ext>
             </a:extLst>
           </p:cNvPr>
@@ -7261,7 +7247,7 @@
           <p:cNvPr id="20" name="Afbeelding 19">
             <a:extLst>
               <a:ext uri="{FF2B5EF4-FFF2-40B4-BE49-F238E27FC236}">
-                <a16:creationId xmlns="" xmlns:a16="http://schemas.microsoft.com/office/drawing/2014/main" id="{0F88C73D-DE89-E67D-AF33-5387C34A3A5F}"/>
+                <a16:creationId xmlns:a16="http://schemas.microsoft.com/office/drawing/2014/main" id="{0F88C73D-DE89-E67D-AF33-5387C34A3A5F}"/>
               </a:ext>
             </a:extLst>
           </p:cNvPr>
@@ -7291,7 +7277,7 @@
           <p:cNvPr id="26" name="Afbeelding 25">
             <a:extLst>
               <a:ext uri="{FF2B5EF4-FFF2-40B4-BE49-F238E27FC236}">
-                <a16:creationId xmlns="" xmlns:a16="http://schemas.microsoft.com/office/drawing/2014/main" id="{A3C7A71C-CAB7-B6DB-61CA-94369ED8371F}"/>
+                <a16:creationId xmlns:a16="http://schemas.microsoft.com/office/drawing/2014/main" id="{A3C7A71C-CAB7-B6DB-61CA-94369ED8371F}"/>
               </a:ext>
             </a:extLst>
           </p:cNvPr>
@@ -7321,7 +7307,7 @@
           <p:cNvPr id="28" name="Afbeelding 27">
             <a:extLst>
               <a:ext uri="{FF2B5EF4-FFF2-40B4-BE49-F238E27FC236}">
-                <a16:creationId xmlns="" xmlns:a16="http://schemas.microsoft.com/office/drawing/2014/main" id="{8F2B1E49-A7F2-3F1C-0E71-CA5AD464CEC8}"/>
+                <a16:creationId xmlns:a16="http://schemas.microsoft.com/office/drawing/2014/main" id="{8F2B1E49-A7F2-3F1C-0E71-CA5AD464CEC8}"/>
               </a:ext>
             </a:extLst>
           </p:cNvPr>
@@ -7351,7 +7337,7 @@
           <p:cNvPr id="30" name="Afbeelding 29">
             <a:extLst>
               <a:ext uri="{FF2B5EF4-FFF2-40B4-BE49-F238E27FC236}">
-                <a16:creationId xmlns="" xmlns:a16="http://schemas.microsoft.com/office/drawing/2014/main" id="{EDF6A779-1C3A-D2F8-75D2-3BC203BE335A}"/>
+                <a16:creationId xmlns:a16="http://schemas.microsoft.com/office/drawing/2014/main" id="{EDF6A779-1C3A-D2F8-75D2-3BC203BE335A}"/>
               </a:ext>
             </a:extLst>
           </p:cNvPr>
@@ -7381,7 +7367,7 @@
           <p:cNvPr id="32" name="Afbeelding 31">
             <a:extLst>
               <a:ext uri="{FF2B5EF4-FFF2-40B4-BE49-F238E27FC236}">
-                <a16:creationId xmlns="" xmlns:a16="http://schemas.microsoft.com/office/drawing/2014/main" id="{6465D1C0-223A-DDC4-6CC6-D86A6D9E5289}"/>
+                <a16:creationId xmlns:a16="http://schemas.microsoft.com/office/drawing/2014/main" id="{6465D1C0-223A-DDC4-6CC6-D86A6D9E5289}"/>
               </a:ext>
             </a:extLst>
           </p:cNvPr>
@@ -7411,7 +7397,7 @@
           <p:cNvPr id="19" name="Graphic 9">
             <a:extLst>
               <a:ext uri="{FF2B5EF4-FFF2-40B4-BE49-F238E27FC236}">
-                <a16:creationId xmlns="" xmlns:a16="http://schemas.microsoft.com/office/drawing/2014/main" id="{BA7F0A06-504A-1E32-9571-8A71324FF3C2}"/>
+                <a16:creationId xmlns:a16="http://schemas.microsoft.com/office/drawing/2014/main" id="{BA7F0A06-504A-1E32-9571-8A71324FF3C2}"/>
               </a:ext>
             </a:extLst>
           </p:cNvPr>
@@ -7424,7 +7410,7 @@
           <a:blip r:embed="rId9">
             <a:extLst>
               <a:ext uri="{96DAC541-7B7A-43D3-8B79-37D633B846F1}">
-                <asvg:svgBlip xmlns="" xmlns:asvg="http://schemas.microsoft.com/office/drawing/2016/SVG/main" r:embed="rId10"/>
+                <asvg:svgBlip xmlns:asvg="http://schemas.microsoft.com/office/drawing/2016/SVG/main" r:embed="rId10"/>
               </a:ext>
             </a:extLst>
           </a:blip>
@@ -7452,13 +7438,6 @@
   <p:clrMapOvr>
     <a:masterClrMapping/>
   </p:clrMapOvr>
-  <p:timing>
-    <p:tnLst>
-      <p:par>
-        <p:cTn id="1" dur="indefinite" restart="never" nodeType="tmRoot"/>
-      </p:par>
-    </p:tnLst>
-  </p:timing>
 </p:sld>
 </file>
 
@@ -7481,7 +7460,7 @@
         <p:cNvPr id="1" name="">
           <a:extLst>
             <a:ext uri="{FF2B5EF4-FFF2-40B4-BE49-F238E27FC236}">
-              <a16:creationId xmlns="" xmlns:a16="http://schemas.microsoft.com/office/drawing/2014/main" id="{6C8C8281-0EFA-A59E-63BF-7FDECFE6C2EF}"/>
+              <a16:creationId xmlns:a16="http://schemas.microsoft.com/office/drawing/2014/main" id="{6C8C8281-0EFA-A59E-63BF-7FDECFE6C2EF}"/>
             </a:ext>
           </a:extLst>
         </p:cNvPr>
@@ -7501,7 +7480,7 @@
           <p:cNvPr id="12" name="Rectangle 11">
             <a:extLst>
               <a:ext uri="{FF2B5EF4-FFF2-40B4-BE49-F238E27FC236}">
-                <a16:creationId xmlns="" xmlns:a16="http://schemas.microsoft.com/office/drawing/2014/main" id="{79725AA2-FCCE-F0EE-9655-B80A56D5C13E}"/>
+                <a16:creationId xmlns:a16="http://schemas.microsoft.com/office/drawing/2014/main" id="{79725AA2-FCCE-F0EE-9655-B80A56D5C13E}"/>
               </a:ext>
             </a:extLst>
           </p:cNvPr>
@@ -7564,7 +7543,7 @@
           <p:cNvPr id="2" name="000_topleftHeading">
             <a:extLst>
               <a:ext uri="{FF2B5EF4-FFF2-40B4-BE49-F238E27FC236}">
-                <a16:creationId xmlns="" xmlns:a16="http://schemas.microsoft.com/office/drawing/2014/main" id="{26A52BF9-B15A-F427-E0BE-FC3974804402}"/>
+                <a16:creationId xmlns:a16="http://schemas.microsoft.com/office/drawing/2014/main" id="{26A52BF9-B15A-F427-E0BE-FC3974804402}"/>
               </a:ext>
             </a:extLst>
           </p:cNvPr>
@@ -7588,16 +7567,12 @@
           <a:lstStyle/>
           <a:p>
             <a:r>
-              <a:rPr lang="en-US" dirty="0" smtClean="0">
+              <a:rPr lang="en-US" dirty="0">
                 <a:latin typeface="Yu Gothic UI Light" panose="020B0300000000000000" pitchFamily="34" charset="-128"/>
                 <a:ea typeface="Yu Gothic UI Light" panose="020B0300000000000000" pitchFamily="34" charset="-128"/>
               </a:rPr>
               <a:t>Results and evaluation</a:t>
             </a:r>
-            <a:endParaRPr lang="en-US" dirty="0">
-              <a:latin typeface="Yu Gothic UI Light" panose="020B0300000000000000" pitchFamily="34" charset="-128"/>
-              <a:ea typeface="Yu Gothic UI Light" panose="020B0300000000000000" pitchFamily="34" charset="-128"/>
-            </a:endParaRPr>
           </a:p>
           <a:p>
             <a:r>
@@ -7619,7 +7594,7 @@
           <p:cNvPr id="3" name="Rectangle 2">
             <a:extLst>
               <a:ext uri="{FF2B5EF4-FFF2-40B4-BE49-F238E27FC236}">
-                <a16:creationId xmlns="" xmlns:a16="http://schemas.microsoft.com/office/drawing/2014/main" id="{E9BD94A8-570C-27DA-3ADE-FC048B223CFE}"/>
+                <a16:creationId xmlns:a16="http://schemas.microsoft.com/office/drawing/2014/main" id="{E9BD94A8-570C-27DA-3ADE-FC048B223CFE}"/>
               </a:ext>
             </a:extLst>
           </p:cNvPr>
@@ -7678,7 +7653,7 @@
           <p:cNvPr id="4" name="Rectangle 3">
             <a:extLst>
               <a:ext uri="{FF2B5EF4-FFF2-40B4-BE49-F238E27FC236}">
-                <a16:creationId xmlns="" xmlns:a16="http://schemas.microsoft.com/office/drawing/2014/main" id="{4174E7CA-1771-94F4-663D-17D76134BDBA}"/>
+                <a16:creationId xmlns:a16="http://schemas.microsoft.com/office/drawing/2014/main" id="{4174E7CA-1771-94F4-663D-17D76134BDBA}"/>
               </a:ext>
             </a:extLst>
           </p:cNvPr>
@@ -7738,7 +7713,7 @@
           <p:cNvPr id="18" name="Rectangle 17">
             <a:extLst>
               <a:ext uri="{FF2B5EF4-FFF2-40B4-BE49-F238E27FC236}">
-                <a16:creationId xmlns="" xmlns:a16="http://schemas.microsoft.com/office/drawing/2014/main" id="{E6371D62-E22B-FCD8-DE91-C59FBB2A88FC}"/>
+                <a16:creationId xmlns:a16="http://schemas.microsoft.com/office/drawing/2014/main" id="{E6371D62-E22B-FCD8-DE91-C59FBB2A88FC}"/>
               </a:ext>
             </a:extLst>
           </p:cNvPr>
@@ -7798,7 +7773,7 @@
           <p:cNvPr id="5" name="Graphic 1">
             <a:extLst>
               <a:ext uri="{FF2B5EF4-FFF2-40B4-BE49-F238E27FC236}">
-                <a16:creationId xmlns="" xmlns:a16="http://schemas.microsoft.com/office/drawing/2014/main" id="{1E4444D7-C9B9-8E5D-0583-D26610B0BD22}"/>
+                <a16:creationId xmlns:a16="http://schemas.microsoft.com/office/drawing/2014/main" id="{1E4444D7-C9B9-8E5D-0583-D26610B0BD22}"/>
               </a:ext>
             </a:extLst>
           </p:cNvPr>
@@ -7811,7 +7786,7 @@
           <a:blip r:embed="rId2">
             <a:extLst>
               <a:ext uri="{96DAC541-7B7A-43D3-8B79-37D633B846F1}">
-                <asvg:svgBlip xmlns="" xmlns:asvg="http://schemas.microsoft.com/office/drawing/2016/SVG/main" r:embed="rId3"/>
+                <asvg:svgBlip xmlns:asvg="http://schemas.microsoft.com/office/drawing/2016/SVG/main" r:embed="rId3"/>
               </a:ext>
             </a:extLst>
           </a:blip>
@@ -7834,7 +7809,7 @@
           <p:cNvPr id="6" name="Graphic 1">
             <a:extLst>
               <a:ext uri="{FF2B5EF4-FFF2-40B4-BE49-F238E27FC236}">
-                <a16:creationId xmlns="" xmlns:a16="http://schemas.microsoft.com/office/drawing/2014/main" id="{FD23718E-A7E1-AAC4-CA27-55F141C556DE}"/>
+                <a16:creationId xmlns:a16="http://schemas.microsoft.com/office/drawing/2014/main" id="{FD23718E-A7E1-AAC4-CA27-55F141C556DE}"/>
               </a:ext>
             </a:extLst>
           </p:cNvPr>
@@ -7847,7 +7822,7 @@
           <a:blip r:embed="rId4">
             <a:extLst>
               <a:ext uri="{96DAC541-7B7A-43D3-8B79-37D633B846F1}">
-                <asvg:svgBlip xmlns="" xmlns:asvg="http://schemas.microsoft.com/office/drawing/2016/SVG/main" r:embed="rId5"/>
+                <asvg:svgBlip xmlns:asvg="http://schemas.microsoft.com/office/drawing/2016/SVG/main" r:embed="rId5"/>
               </a:ext>
             </a:extLst>
           </a:blip>
@@ -7870,7 +7845,7 @@
           <p:cNvPr id="7" name="Picture 6" descr="A close-up of a sign&#10;&#10;AI-generated content may be incorrect.">
             <a:extLst>
               <a:ext uri="{FF2B5EF4-FFF2-40B4-BE49-F238E27FC236}">
-                <a16:creationId xmlns="" xmlns:a16="http://schemas.microsoft.com/office/drawing/2014/main" id="{762529CA-2647-83B3-F5C3-055944DAF4EE}"/>
+                <a16:creationId xmlns:a16="http://schemas.microsoft.com/office/drawing/2014/main" id="{762529CA-2647-83B3-F5C3-055944DAF4EE}"/>
               </a:ext>
             </a:extLst>
           </p:cNvPr>
@@ -7911,7 +7886,7 @@
           <p:cNvPr id="8" name="Picture 7" descr="A close-up of a sign&#10;&#10;AI-generated content may be incorrect.">
             <a:extLst>
               <a:ext uri="{FF2B5EF4-FFF2-40B4-BE49-F238E27FC236}">
-                <a16:creationId xmlns="" xmlns:a16="http://schemas.microsoft.com/office/drawing/2014/main" id="{01025B97-2603-C621-774A-1DDFC94D7AD5}"/>
+                <a16:creationId xmlns:a16="http://schemas.microsoft.com/office/drawing/2014/main" id="{01025B97-2603-C621-774A-1DDFC94D7AD5}"/>
               </a:ext>
             </a:extLst>
           </p:cNvPr>
@@ -7952,7 +7927,7 @@
           <p:cNvPr id="10" name="Graphic 9">
             <a:extLst>
               <a:ext uri="{FF2B5EF4-FFF2-40B4-BE49-F238E27FC236}">
-                <a16:creationId xmlns="" xmlns:a16="http://schemas.microsoft.com/office/drawing/2014/main" id="{BA7F0A06-504A-1E32-9571-8A71324FF3C2}"/>
+                <a16:creationId xmlns:a16="http://schemas.microsoft.com/office/drawing/2014/main" id="{BA7F0A06-504A-1E32-9571-8A71324FF3C2}"/>
               </a:ext>
             </a:extLst>
           </p:cNvPr>
@@ -7965,7 +7940,7 @@
           <a:blip r:embed="rId7">
             <a:extLst>
               <a:ext uri="{96DAC541-7B7A-43D3-8B79-37D633B846F1}">
-                <asvg:svgBlip xmlns="" xmlns:asvg="http://schemas.microsoft.com/office/drawing/2016/SVG/main" r:embed="rId8"/>
+                <asvg:svgBlip xmlns:asvg="http://schemas.microsoft.com/office/drawing/2016/SVG/main" r:embed="rId8"/>
               </a:ext>
             </a:extLst>
           </a:blip>
@@ -7993,13 +7968,6 @@
   <p:clrMapOvr>
     <a:masterClrMapping/>
   </p:clrMapOvr>
-  <p:timing>
-    <p:tnLst>
-      <p:par>
-        <p:cTn id="1" dur="indefinite" restart="never" nodeType="tmRoot"/>
-      </p:par>
-    </p:tnLst>
-  </p:timing>
 </p:sld>
 </file>
 
@@ -8022,7 +7990,7 @@
         <p:cNvPr id="1" name="">
           <a:extLst>
             <a:ext uri="{FF2B5EF4-FFF2-40B4-BE49-F238E27FC236}">
-              <a16:creationId xmlns="" xmlns:a16="http://schemas.microsoft.com/office/drawing/2014/main" id="{BF375580-D8D2-F2B5-B5A0-13BE8D9FBBB8}"/>
+              <a16:creationId xmlns:a16="http://schemas.microsoft.com/office/drawing/2014/main" id="{BF375580-D8D2-F2B5-B5A0-13BE8D9FBBB8}"/>
             </a:ext>
           </a:extLst>
         </p:cNvPr>
@@ -8042,7 +8010,7 @@
           <p:cNvPr id="12" name="Rectangle 11">
             <a:extLst>
               <a:ext uri="{FF2B5EF4-FFF2-40B4-BE49-F238E27FC236}">
-                <a16:creationId xmlns="" xmlns:a16="http://schemas.microsoft.com/office/drawing/2014/main" id="{7A3B2F74-BFD2-C676-AEBB-B8E565564260}"/>
+                <a16:creationId xmlns:a16="http://schemas.microsoft.com/office/drawing/2014/main" id="{7A3B2F74-BFD2-C676-AEBB-B8E565564260}"/>
               </a:ext>
             </a:extLst>
           </p:cNvPr>
@@ -8105,7 +8073,7 @@
           <p:cNvPr id="2" name="000_topleftHeading">
             <a:extLst>
               <a:ext uri="{FF2B5EF4-FFF2-40B4-BE49-F238E27FC236}">
-                <a16:creationId xmlns="" xmlns:a16="http://schemas.microsoft.com/office/drawing/2014/main" id="{76F20FFC-06A5-C919-43B2-5935C8834466}"/>
+                <a16:creationId xmlns:a16="http://schemas.microsoft.com/office/drawing/2014/main" id="{76F20FFC-06A5-C919-43B2-5935C8834466}"/>
               </a:ext>
             </a:extLst>
           </p:cNvPr>
@@ -8129,16 +8097,12 @@
           <a:lstStyle/>
           <a:p>
             <a:r>
-              <a:rPr lang="en-US" dirty="0" smtClean="0">
+              <a:rPr lang="en-US" dirty="0">
                 <a:latin typeface="Yu Gothic UI Light" panose="020B0300000000000000" pitchFamily="34" charset="-128"/>
                 <a:ea typeface="Yu Gothic UI Light" panose="020B0300000000000000" pitchFamily="34" charset="-128"/>
               </a:rPr>
               <a:t>Results and evaluation</a:t>
             </a:r>
-            <a:endParaRPr lang="en-US" dirty="0">
-              <a:latin typeface="Yu Gothic UI Light" panose="020B0300000000000000" pitchFamily="34" charset="-128"/>
-              <a:ea typeface="Yu Gothic UI Light" panose="020B0300000000000000" pitchFamily="34" charset="-128"/>
-            </a:endParaRPr>
           </a:p>
           <a:p>
             <a:r>
@@ -8160,7 +8124,7 @@
           <p:cNvPr id="18" name="Rectangle 17">
             <a:extLst>
               <a:ext uri="{FF2B5EF4-FFF2-40B4-BE49-F238E27FC236}">
-                <a16:creationId xmlns="" xmlns:a16="http://schemas.microsoft.com/office/drawing/2014/main" id="{FE35EFB1-12EB-F1EE-69D5-28054043AB3C}"/>
+                <a16:creationId xmlns:a16="http://schemas.microsoft.com/office/drawing/2014/main" id="{FE35EFB1-12EB-F1EE-69D5-28054043AB3C}"/>
               </a:ext>
             </a:extLst>
           </p:cNvPr>
@@ -8220,7 +8184,7 @@
           <p:cNvPr id="7" name="Picture 6" descr="A close-up of a sign&#10;&#10;AI-generated content may be incorrect.">
             <a:extLst>
               <a:ext uri="{FF2B5EF4-FFF2-40B4-BE49-F238E27FC236}">
-                <a16:creationId xmlns="" xmlns:a16="http://schemas.microsoft.com/office/drawing/2014/main" id="{7419FCB9-B3A9-3652-BF9A-3AA72575F9CA}"/>
+                <a16:creationId xmlns:a16="http://schemas.microsoft.com/office/drawing/2014/main" id="{7419FCB9-B3A9-3652-BF9A-3AA72575F9CA}"/>
               </a:ext>
             </a:extLst>
           </p:cNvPr>
@@ -8261,7 +8225,7 @@
           <p:cNvPr id="9" name="Graphic 1">
             <a:extLst>
               <a:ext uri="{FF2B5EF4-FFF2-40B4-BE49-F238E27FC236}">
-                <a16:creationId xmlns="" xmlns:a16="http://schemas.microsoft.com/office/drawing/2014/main" id="{371D48DC-61D6-B900-376E-C04EF2D8C7DC}"/>
+                <a16:creationId xmlns:a16="http://schemas.microsoft.com/office/drawing/2014/main" id="{371D48DC-61D6-B900-376E-C04EF2D8C7DC}"/>
               </a:ext>
             </a:extLst>
           </p:cNvPr>
@@ -8274,7 +8238,7 @@
           <a:blip r:embed="rId3">
             <a:extLst>
               <a:ext uri="{96DAC541-7B7A-43D3-8B79-37D633B846F1}">
-                <asvg:svgBlip xmlns="" xmlns:asvg="http://schemas.microsoft.com/office/drawing/2016/SVG/main" r:embed="rId4"/>
+                <asvg:svgBlip xmlns:asvg="http://schemas.microsoft.com/office/drawing/2016/SVG/main" r:embed="rId4"/>
               </a:ext>
             </a:extLst>
           </a:blip>
@@ -8297,7 +8261,7 @@
           <p:cNvPr id="3" name="Graphic 2">
             <a:extLst>
               <a:ext uri="{FF2B5EF4-FFF2-40B4-BE49-F238E27FC236}">
-                <a16:creationId xmlns="" xmlns:a16="http://schemas.microsoft.com/office/drawing/2014/main" id="{55A179BE-EDB1-5C67-A4D4-9A1ECFCDBAC4}"/>
+                <a16:creationId xmlns:a16="http://schemas.microsoft.com/office/drawing/2014/main" id="{55A179BE-EDB1-5C67-A4D4-9A1ECFCDBAC4}"/>
               </a:ext>
             </a:extLst>
           </p:cNvPr>
@@ -8310,7 +8274,7 @@
           <a:blip r:embed="rId5">
             <a:extLst>
               <a:ext uri="{96DAC541-7B7A-43D3-8B79-37D633B846F1}">
-                <asvg:svgBlip xmlns="" xmlns:asvg="http://schemas.microsoft.com/office/drawing/2016/SVG/main" r:embed="rId6"/>
+                <asvg:svgBlip xmlns:asvg="http://schemas.microsoft.com/office/drawing/2016/SVG/main" r:embed="rId6"/>
               </a:ext>
             </a:extLst>
           </a:blip>
@@ -8338,13 +8302,6 @@
   <p:clrMapOvr>
     <a:masterClrMapping/>
   </p:clrMapOvr>
-  <p:timing>
-    <p:tnLst>
-      <p:par>
-        <p:cTn id="1" dur="indefinite" restart="never" nodeType="tmRoot"/>
-      </p:par>
-    </p:tnLst>
-  </p:timing>
 </p:sld>
 </file>
 
@@ -8367,7 +8324,7 @@
         <p:cNvPr id="1" name="">
           <a:extLst>
             <a:ext uri="{FF2B5EF4-FFF2-40B4-BE49-F238E27FC236}">
-              <a16:creationId xmlns="" xmlns:a16="http://schemas.microsoft.com/office/drawing/2014/main" id="{19AC6B90-169F-CFA8-8A10-83B1FED6D406}"/>
+              <a16:creationId xmlns:a16="http://schemas.microsoft.com/office/drawing/2014/main" id="{19AC6B90-169F-CFA8-8A10-83B1FED6D406}"/>
             </a:ext>
           </a:extLst>
         </p:cNvPr>
@@ -8387,7 +8344,7 @@
           <p:cNvPr id="12" name="Rectangle 11">
             <a:extLst>
               <a:ext uri="{FF2B5EF4-FFF2-40B4-BE49-F238E27FC236}">
-                <a16:creationId xmlns="" xmlns:a16="http://schemas.microsoft.com/office/drawing/2014/main" id="{7E6B50B4-9228-85BB-95A3-F3A53AE813F0}"/>
+                <a16:creationId xmlns:a16="http://schemas.microsoft.com/office/drawing/2014/main" id="{7E6B50B4-9228-85BB-95A3-F3A53AE813F0}"/>
               </a:ext>
             </a:extLst>
           </p:cNvPr>
@@ -8452,7 +8409,7 @@
           <p:cNvPr id="2" name="000_topleftHeading">
             <a:extLst>
               <a:ext uri="{FF2B5EF4-FFF2-40B4-BE49-F238E27FC236}">
-                <a16:creationId xmlns="" xmlns:a16="http://schemas.microsoft.com/office/drawing/2014/main" id="{0AE60394-73D8-03AB-855E-EAC9177CA36B}"/>
+                <a16:creationId xmlns:a16="http://schemas.microsoft.com/office/drawing/2014/main" id="{0AE60394-73D8-03AB-855E-EAC9177CA36B}"/>
               </a:ext>
             </a:extLst>
           </p:cNvPr>
@@ -8478,20 +8435,16 @@
           <a:lstStyle/>
           <a:p>
             <a:r>
-              <a:rPr lang="en-US" dirty="0" smtClean="0">
+              <a:rPr lang="en-US" dirty="0">
                 <a:latin typeface="Yu Gothic UI Light" panose="020B0300000000000000" pitchFamily="34" charset="-128"/>
                 <a:ea typeface="Yu Gothic UI Light" panose="020B0300000000000000" pitchFamily="34" charset="-128"/>
               </a:rPr>
               <a:t>Results and evaluation</a:t>
             </a:r>
-            <a:endParaRPr lang="en-US" dirty="0">
-              <a:latin typeface="Yu Gothic UI Light" panose="020B0300000000000000" pitchFamily="34" charset="-128"/>
-              <a:ea typeface="Yu Gothic UI Light" panose="020B0300000000000000" pitchFamily="34" charset="-128"/>
-            </a:endParaRPr>
-          </a:p>
-          <a:p>
-            <a:r>
-              <a:rPr lang="en-US" dirty="0" smtClean="0">
+          </a:p>
+          <a:p>
+            <a:r>
+              <a:rPr lang="en-US" dirty="0">
                 <a:latin typeface="Yu Gothic UI Light" panose="020B0300000000000000" pitchFamily="34" charset="-128"/>
                 <a:ea typeface="Yu Gothic UI Light" panose="020B0300000000000000" pitchFamily="34" charset="-128"/>
               </a:rPr>
@@ -8509,7 +8462,7 @@
           <p:cNvPr id="8" name="Rectangle 7">
             <a:extLst>
               <a:ext uri="{FF2B5EF4-FFF2-40B4-BE49-F238E27FC236}">
-                <a16:creationId xmlns="" xmlns:a16="http://schemas.microsoft.com/office/drawing/2014/main" id="{7E623D64-4643-27A7-5150-757296630DE1}"/>
+                <a16:creationId xmlns:a16="http://schemas.microsoft.com/office/drawing/2014/main" id="{7E623D64-4643-27A7-5150-757296630DE1}"/>
               </a:ext>
             </a:extLst>
           </p:cNvPr>
@@ -8568,7 +8521,7 @@
           <p:cNvPr id="9" name="Rectangle 8">
             <a:extLst>
               <a:ext uri="{FF2B5EF4-FFF2-40B4-BE49-F238E27FC236}">
-                <a16:creationId xmlns="" xmlns:a16="http://schemas.microsoft.com/office/drawing/2014/main" id="{48DD16C1-AB54-75E5-482E-042D97AAC93E}"/>
+                <a16:creationId xmlns:a16="http://schemas.microsoft.com/office/drawing/2014/main" id="{48DD16C1-AB54-75E5-482E-042D97AAC93E}"/>
               </a:ext>
             </a:extLst>
           </p:cNvPr>
@@ -8627,7 +8580,7 @@
           <p:cNvPr id="14" name="Graphic 1">
             <a:extLst>
               <a:ext uri="{FF2B5EF4-FFF2-40B4-BE49-F238E27FC236}">
-                <a16:creationId xmlns="" xmlns:a16="http://schemas.microsoft.com/office/drawing/2014/main" id="{D4604E01-FD5C-4018-6B30-A20D3E7559C3}"/>
+                <a16:creationId xmlns:a16="http://schemas.microsoft.com/office/drawing/2014/main" id="{D4604E01-FD5C-4018-6B30-A20D3E7559C3}"/>
               </a:ext>
             </a:extLst>
           </p:cNvPr>
@@ -8640,7 +8593,7 @@
           <a:blip r:embed="rId2">
             <a:extLst>
               <a:ext uri="{96DAC541-7B7A-43D3-8B79-37D633B846F1}">
-                <asvg:svgBlip xmlns="" xmlns:asvg="http://schemas.microsoft.com/office/drawing/2016/SVG/main" r:embed="rId3"/>
+                <asvg:svgBlip xmlns:asvg="http://schemas.microsoft.com/office/drawing/2016/SVG/main" r:embed="rId3"/>
               </a:ext>
             </a:extLst>
           </a:blip>
@@ -8663,7 +8616,7 @@
           <p:cNvPr id="4" name="Graphic 1">
             <a:extLst>
               <a:ext uri="{FF2B5EF4-FFF2-40B4-BE49-F238E27FC236}">
-                <a16:creationId xmlns="" xmlns:a16="http://schemas.microsoft.com/office/drawing/2014/main" id="{30E656DF-8420-E8F9-47BA-6BAAFB4200B3}"/>
+                <a16:creationId xmlns:a16="http://schemas.microsoft.com/office/drawing/2014/main" id="{30E656DF-8420-E8F9-47BA-6BAAFB4200B3}"/>
               </a:ext>
             </a:extLst>
           </p:cNvPr>
@@ -8676,7 +8629,7 @@
           <a:blip r:embed="rId4">
             <a:extLst>
               <a:ext uri="{96DAC541-7B7A-43D3-8B79-37D633B846F1}">
-                <asvg:svgBlip xmlns="" xmlns:asvg="http://schemas.microsoft.com/office/drawing/2016/SVG/main" r:embed="rId5"/>
+                <asvg:svgBlip xmlns:asvg="http://schemas.microsoft.com/office/drawing/2016/SVG/main" r:embed="rId5"/>
               </a:ext>
             </a:extLst>
           </a:blip>
@@ -8699,7 +8652,7 @@
           <p:cNvPr id="6" name="Graphic 1">
             <a:extLst>
               <a:ext uri="{FF2B5EF4-FFF2-40B4-BE49-F238E27FC236}">
-                <a16:creationId xmlns="" xmlns:a16="http://schemas.microsoft.com/office/drawing/2014/main" id="{2A994162-8489-272C-ED55-726B00A5432B}"/>
+                <a16:creationId xmlns:a16="http://schemas.microsoft.com/office/drawing/2014/main" id="{2A994162-8489-272C-ED55-726B00A5432B}"/>
               </a:ext>
             </a:extLst>
           </p:cNvPr>
@@ -8712,7 +8665,7 @@
           <a:blip r:embed="rId6">
             <a:extLst>
               <a:ext uri="{96DAC541-7B7A-43D3-8B79-37D633B846F1}">
-                <asvg:svgBlip xmlns="" xmlns:asvg="http://schemas.microsoft.com/office/drawing/2016/SVG/main" r:embed="rId7"/>
+                <asvg:svgBlip xmlns:asvg="http://schemas.microsoft.com/office/drawing/2016/SVG/main" r:embed="rId7"/>
               </a:ext>
             </a:extLst>
           </a:blip>
@@ -8735,7 +8688,7 @@
           <p:cNvPr id="7" name="Graphic 1">
             <a:extLst>
               <a:ext uri="{FF2B5EF4-FFF2-40B4-BE49-F238E27FC236}">
-                <a16:creationId xmlns="" xmlns:a16="http://schemas.microsoft.com/office/drawing/2014/main" id="{14FE4AE4-395A-C435-EDE0-AF2338FDED8B}"/>
+                <a16:creationId xmlns:a16="http://schemas.microsoft.com/office/drawing/2014/main" id="{14FE4AE4-395A-C435-EDE0-AF2338FDED8B}"/>
               </a:ext>
             </a:extLst>
           </p:cNvPr>
@@ -8748,7 +8701,7 @@
           <a:blip r:embed="rId8">
             <a:extLst>
               <a:ext uri="{96DAC541-7B7A-43D3-8B79-37D633B846F1}">
-                <asvg:svgBlip xmlns="" xmlns:asvg="http://schemas.microsoft.com/office/drawing/2016/SVG/main" r:embed="rId9"/>
+                <asvg:svgBlip xmlns:asvg="http://schemas.microsoft.com/office/drawing/2016/SVG/main" r:embed="rId9"/>
               </a:ext>
             </a:extLst>
           </a:blip>
@@ -8771,7 +8724,7 @@
           <p:cNvPr id="3" name="Graphic 2">
             <a:extLst>
               <a:ext uri="{FF2B5EF4-FFF2-40B4-BE49-F238E27FC236}">
-                <a16:creationId xmlns="" xmlns:a16="http://schemas.microsoft.com/office/drawing/2014/main" id="{597B0DDD-737F-4AE6-6EBB-6FF44F20E3A1}"/>
+                <a16:creationId xmlns:a16="http://schemas.microsoft.com/office/drawing/2014/main" id="{597B0DDD-737F-4AE6-6EBB-6FF44F20E3A1}"/>
               </a:ext>
             </a:extLst>
           </p:cNvPr>
@@ -8784,7 +8737,7 @@
           <a:blip r:embed="rId10">
             <a:extLst>
               <a:ext uri="{96DAC541-7B7A-43D3-8B79-37D633B846F1}">
-                <asvg:svgBlip xmlns="" xmlns:asvg="http://schemas.microsoft.com/office/drawing/2016/SVG/main" r:embed="rId11"/>
+                <asvg:svgBlip xmlns:asvg="http://schemas.microsoft.com/office/drawing/2016/SVG/main" r:embed="rId11"/>
               </a:ext>
             </a:extLst>
           </a:blip>
@@ -8812,13 +8765,6 @@
   <p:clrMapOvr>
     <a:masterClrMapping/>
   </p:clrMapOvr>
-  <p:timing>
-    <p:tnLst>
-      <p:par>
-        <p:cTn id="1" dur="indefinite" restart="never" nodeType="tmRoot"/>
-      </p:par>
-    </p:tnLst>
-  </p:timing>
 </p:sld>
 </file>
 
@@ -8841,7 +8787,7 @@
         <p:cNvPr id="1" name="">
           <a:extLst>
             <a:ext uri="{FF2B5EF4-FFF2-40B4-BE49-F238E27FC236}">
-              <a16:creationId xmlns="" xmlns:a16="http://schemas.microsoft.com/office/drawing/2014/main" id="{2F81E7CA-83D7-3A9B-83E6-162EFF23F89A}"/>
+              <a16:creationId xmlns:a16="http://schemas.microsoft.com/office/drawing/2014/main" id="{2F81E7CA-83D7-3A9B-83E6-162EFF23F89A}"/>
             </a:ext>
           </a:extLst>
         </p:cNvPr>
@@ -8861,7 +8807,7 @@
           <p:cNvPr id="12" name="Rectangle 11">
             <a:extLst>
               <a:ext uri="{FF2B5EF4-FFF2-40B4-BE49-F238E27FC236}">
-                <a16:creationId xmlns="" xmlns:a16="http://schemas.microsoft.com/office/drawing/2014/main" id="{95A32272-037D-230D-F69C-CB344E7D939B}"/>
+                <a16:creationId xmlns:a16="http://schemas.microsoft.com/office/drawing/2014/main" id="{95A32272-037D-230D-F69C-CB344E7D939B}"/>
               </a:ext>
             </a:extLst>
           </p:cNvPr>
@@ -8926,7 +8872,7 @@
           <p:cNvPr id="2" name="000_topleftHeading">
             <a:extLst>
               <a:ext uri="{FF2B5EF4-FFF2-40B4-BE49-F238E27FC236}">
-                <a16:creationId xmlns="" xmlns:a16="http://schemas.microsoft.com/office/drawing/2014/main" id="{6768F90E-EBEC-36C3-3EC6-3AFA1DB1BABE}"/>
+                <a16:creationId xmlns:a16="http://schemas.microsoft.com/office/drawing/2014/main" id="{6768F90E-EBEC-36C3-3EC6-3AFA1DB1BABE}"/>
               </a:ext>
             </a:extLst>
           </p:cNvPr>
@@ -8952,16 +8898,12 @@
           <a:lstStyle/>
           <a:p>
             <a:r>
-              <a:rPr lang="en-US" dirty="0" smtClean="0">
+              <a:rPr lang="en-US" dirty="0">
                 <a:latin typeface="Yu Gothic UI Light" panose="020B0300000000000000" pitchFamily="34" charset="-128"/>
                 <a:ea typeface="Yu Gothic UI Light" panose="020B0300000000000000" pitchFamily="34" charset="-128"/>
               </a:rPr>
               <a:t>Results and evaluation</a:t>
             </a:r>
-            <a:endParaRPr lang="en-US" dirty="0">
-              <a:latin typeface="Yu Gothic UI Light" panose="020B0300000000000000" pitchFamily="34" charset="-128"/>
-              <a:ea typeface="Yu Gothic UI Light" panose="020B0300000000000000" pitchFamily="34" charset="-128"/>
-            </a:endParaRPr>
           </a:p>
           <a:p>
             <a:r>
@@ -8983,7 +8925,7 @@
           <p:cNvPr id="8" name="Rectangle 7">
             <a:extLst>
               <a:ext uri="{FF2B5EF4-FFF2-40B4-BE49-F238E27FC236}">
-                <a16:creationId xmlns="" xmlns:a16="http://schemas.microsoft.com/office/drawing/2014/main" id="{8B6B4C70-4CB1-F5D4-2577-DF01463FD924}"/>
+                <a16:creationId xmlns:a16="http://schemas.microsoft.com/office/drawing/2014/main" id="{8B6B4C70-4CB1-F5D4-2577-DF01463FD924}"/>
               </a:ext>
             </a:extLst>
           </p:cNvPr>
@@ -9042,7 +8984,7 @@
           <p:cNvPr id="9" name="Rectangle 8">
             <a:extLst>
               <a:ext uri="{FF2B5EF4-FFF2-40B4-BE49-F238E27FC236}">
-                <a16:creationId xmlns="" xmlns:a16="http://schemas.microsoft.com/office/drawing/2014/main" id="{2282020B-C5CC-332F-5660-B3010186C279}"/>
+                <a16:creationId xmlns:a16="http://schemas.microsoft.com/office/drawing/2014/main" id="{2282020B-C5CC-332F-5660-B3010186C279}"/>
               </a:ext>
             </a:extLst>
           </p:cNvPr>
@@ -9101,7 +9043,7 @@
           <p:cNvPr id="3" name="Graphic 2">
             <a:extLst>
               <a:ext uri="{FF2B5EF4-FFF2-40B4-BE49-F238E27FC236}">
-                <a16:creationId xmlns="" xmlns:a16="http://schemas.microsoft.com/office/drawing/2014/main" id="{81A1DC0C-2273-B8FC-B2C9-D352390699F5}"/>
+                <a16:creationId xmlns:a16="http://schemas.microsoft.com/office/drawing/2014/main" id="{81A1DC0C-2273-B8FC-B2C9-D352390699F5}"/>
               </a:ext>
             </a:extLst>
           </p:cNvPr>
@@ -9114,7 +9056,7 @@
           <a:blip r:embed="rId2">
             <a:extLst>
               <a:ext uri="{96DAC541-7B7A-43D3-8B79-37D633B846F1}">
-                <asvg:svgBlip xmlns="" xmlns:asvg="http://schemas.microsoft.com/office/drawing/2016/SVG/main" r:embed="rId3"/>
+                <asvg:svgBlip xmlns:asvg="http://schemas.microsoft.com/office/drawing/2016/SVG/main" r:embed="rId3"/>
               </a:ext>
             </a:extLst>
           </a:blip>
@@ -9137,7 +9079,7 @@
           <p:cNvPr id="5" name="Picture 4">
             <a:extLst>
               <a:ext uri="{FF2B5EF4-FFF2-40B4-BE49-F238E27FC236}">
-                <a16:creationId xmlns="" xmlns:a16="http://schemas.microsoft.com/office/drawing/2014/main" id="{A7BF1E54-96C5-5BF4-3386-1B6ABFF9E005}"/>
+                <a16:creationId xmlns:a16="http://schemas.microsoft.com/office/drawing/2014/main" id="{A7BF1E54-96C5-5BF4-3386-1B6ABFF9E005}"/>
               </a:ext>
             </a:extLst>
           </p:cNvPr>
@@ -9178,7 +9120,7 @@
           <p:cNvPr id="10" name="Picture 9">
             <a:extLst>
               <a:ext uri="{FF2B5EF4-FFF2-40B4-BE49-F238E27FC236}">
-                <a16:creationId xmlns="" xmlns:a16="http://schemas.microsoft.com/office/drawing/2014/main" id="{2E8D64A2-05C4-7658-1BD9-6B71342ECC8E}"/>
+                <a16:creationId xmlns:a16="http://schemas.microsoft.com/office/drawing/2014/main" id="{2E8D64A2-05C4-7658-1BD9-6B71342ECC8E}"/>
               </a:ext>
             </a:extLst>
           </p:cNvPr>
@@ -9224,13 +9166,6 @@
   <p:clrMapOvr>
     <a:masterClrMapping/>
   </p:clrMapOvr>
-  <p:timing>
-    <p:tnLst>
-      <p:par>
-        <p:cTn id="1" dur="indefinite" restart="never" nodeType="tmRoot"/>
-      </p:par>
-    </p:tnLst>
-  </p:timing>
 </p:sld>
 </file>
 
@@ -9253,7 +9188,7 @@
         <p:cNvPr id="1" name="">
           <a:extLst>
             <a:ext uri="{FF2B5EF4-FFF2-40B4-BE49-F238E27FC236}">
-              <a16:creationId xmlns="" xmlns:a16="http://schemas.microsoft.com/office/drawing/2014/main" id="{86F24FA8-7EFA-8FC5-EF0B-0C36D1C34732}"/>
+              <a16:creationId xmlns:a16="http://schemas.microsoft.com/office/drawing/2014/main" id="{86F24FA8-7EFA-8FC5-EF0B-0C36D1C34732}"/>
             </a:ext>
           </a:extLst>
         </p:cNvPr>
@@ -9273,7 +9208,7 @@
           <p:cNvPr id="3" name="Group 2">
             <a:extLst>
               <a:ext uri="{FF2B5EF4-FFF2-40B4-BE49-F238E27FC236}">
-                <a16:creationId xmlns="" xmlns:a16="http://schemas.microsoft.com/office/drawing/2014/main" id="{437A8F56-C73E-3B6A-1A23-D36D2B7DC000}"/>
+                <a16:creationId xmlns:a16="http://schemas.microsoft.com/office/drawing/2014/main" id="{437A8F56-C73E-3B6A-1A23-D36D2B7DC000}"/>
               </a:ext>
             </a:extLst>
           </p:cNvPr>
@@ -9293,7 +9228,7 @@
             <p:cNvPr id="5" name="Rectangle 4">
               <a:extLst>
                 <a:ext uri="{FF2B5EF4-FFF2-40B4-BE49-F238E27FC236}">
-                  <a16:creationId xmlns="" xmlns:a16="http://schemas.microsoft.com/office/drawing/2014/main" id="{DCB99DF9-A9DC-802A-3C12-E0BA5B11581F}"/>
+                  <a16:creationId xmlns:a16="http://schemas.microsoft.com/office/drawing/2014/main" id="{DCB99DF9-A9DC-802A-3C12-E0BA5B11581F}"/>
                 </a:ext>
               </a:extLst>
             </p:cNvPr>
@@ -9357,7 +9292,7 @@
             <p:cNvPr id="6" name="Rectangle 5">
               <a:extLst>
                 <a:ext uri="{FF2B5EF4-FFF2-40B4-BE49-F238E27FC236}">
-                  <a16:creationId xmlns="" xmlns:a16="http://schemas.microsoft.com/office/drawing/2014/main" id="{52E5BB92-EE59-C83B-EE83-D9E19FA61AF0}"/>
+                  <a16:creationId xmlns:a16="http://schemas.microsoft.com/office/drawing/2014/main" id="{52E5BB92-EE59-C83B-EE83-D9E19FA61AF0}"/>
                 </a:ext>
               </a:extLst>
             </p:cNvPr>
@@ -9422,7 +9357,7 @@
           <p:cNvPr id="8" name="000_topleftHeading">
             <a:extLst>
               <a:ext uri="{FF2B5EF4-FFF2-40B4-BE49-F238E27FC236}">
-                <a16:creationId xmlns="" xmlns:a16="http://schemas.microsoft.com/office/drawing/2014/main" id="{E523ED40-0926-2F89-3476-0DA7C2BE0A11}"/>
+                <a16:creationId xmlns:a16="http://schemas.microsoft.com/office/drawing/2014/main" id="{E523ED40-0926-2F89-3476-0DA7C2BE0A11}"/>
               </a:ext>
             </a:extLst>
           </p:cNvPr>
@@ -9446,7 +9381,7 @@
           <a:lstStyle/>
           <a:p>
             <a:r>
-              <a:rPr lang="en-US" dirty="0" smtClean="0">
+              <a:rPr lang="en-US" dirty="0">
                 <a:latin typeface="Yu Gothic UI Light" panose="020B0300000000000000" pitchFamily="34" charset="-128"/>
                 <a:ea typeface="Yu Gothic UI Light" panose="020B0300000000000000" pitchFamily="34" charset="-128"/>
               </a:rPr>
@@ -9464,7 +9399,7 @@
           <p:cNvPr id="9" name="001_subtitle">
             <a:extLst>
               <a:ext uri="{FF2B5EF4-FFF2-40B4-BE49-F238E27FC236}">
-                <a16:creationId xmlns="" xmlns:a16="http://schemas.microsoft.com/office/drawing/2014/main" id="{A6AE533C-5B4F-8F93-C999-B358BF1053E4}"/>
+                <a16:creationId xmlns:a16="http://schemas.microsoft.com/office/drawing/2014/main" id="{A6AE533C-5B4F-8F93-C999-B358BF1053E4}"/>
               </a:ext>
             </a:extLst>
           </p:cNvPr>
@@ -9503,7 +9438,7 @@
           <p:cNvPr id="2" name="TextBox 1">
             <a:extLst>
               <a:ext uri="{FF2B5EF4-FFF2-40B4-BE49-F238E27FC236}">
-                <a16:creationId xmlns="" xmlns:a16="http://schemas.microsoft.com/office/drawing/2014/main" id="{E5F6B1BA-73E3-3089-C8E0-D47CAC7F3ADB}"/>
+                <a16:creationId xmlns:a16="http://schemas.microsoft.com/office/drawing/2014/main" id="{E5F6B1BA-73E3-3089-C8E0-D47CAC7F3ADB}"/>
               </a:ext>
             </a:extLst>
           </p:cNvPr>
@@ -9528,11 +9463,81 @@
           <a:p>
             <a:pPr lvl="0"/>
             <a:r>
-              <a:rPr lang="en-GB" dirty="0" smtClean="0">
+              <a:rPr lang="en-GB" dirty="0">
                 <a:latin typeface="Yu Gothic UI Light" panose="020B0300000000000000" pitchFamily="34" charset="-128"/>
                 <a:ea typeface="Yu Gothic UI Light" panose="020B0300000000000000" pitchFamily="34" charset="-128"/>
               </a:rPr>
               <a:t>Accuracy is high, around 0.95 for most combinations</a:t>
+            </a:r>
+          </a:p>
+        </p:txBody>
+      </p:sp>
+      <p:sp>
+        <p:nvSpPr>
+          <p:cNvPr id="4" name="TextBox 3">
+            <a:extLst>
+              <a:ext uri="{FF2B5EF4-FFF2-40B4-BE49-F238E27FC236}">
+                <a16:creationId xmlns:a16="http://schemas.microsoft.com/office/drawing/2014/main" id="{26AF226B-FF7A-BDA8-8095-D241C05639CF}"/>
+              </a:ext>
+            </a:extLst>
+          </p:cNvPr>
+          <p:cNvSpPr txBox="1"/>
+          <p:nvPr/>
+        </p:nvSpPr>
+        <p:spPr>
+          <a:xfrm>
+            <a:off x="1725377" y="2782852"/>
+            <a:ext cx="7461351" cy="646331"/>
+          </a:xfrm>
+          <a:prstGeom prst="rect">
+            <a:avLst/>
+          </a:prstGeom>
+          <a:noFill/>
+        </p:spPr>
+        <p:txBody>
+          <a:bodyPr wrap="square" rtlCol="0">
+            <a:spAutoFit/>
+          </a:bodyPr>
+          <a:lstStyle/>
+          <a:p>
+            <a:pPr lvl="0"/>
+            <a:r>
+              <a:rPr lang="en-GB" dirty="0">
+                <a:latin typeface="Yu Gothic UI Light" panose="020B0300000000000000" pitchFamily="34" charset="-128"/>
+                <a:ea typeface="Yu Gothic UI Light" panose="020B0300000000000000" pitchFamily="34" charset="-128"/>
+              </a:rPr>
+              <a:t>Accuracy is misleading due to unbalanced data:</a:t>
+            </a:r>
+          </a:p>
+          <a:p>
+            <a:pPr lvl="0"/>
+            <a:r>
+              <a:rPr lang="en-GB" dirty="0">
+                <a:latin typeface="Yu Gothic UI Light" panose="020B0300000000000000" pitchFamily="34" charset="-128"/>
+                <a:ea typeface="Yu Gothic UI Light" panose="020B0300000000000000" pitchFamily="34" charset="-128"/>
+              </a:rPr>
+              <a:t>- </a:t>
+            </a:r>
+            <a:r>
+              <a:rPr lang="en-US" dirty="0">
+                <a:latin typeface="Yu Gothic UI Light" panose="020B0300000000000000" pitchFamily="34" charset="-128"/>
+                <a:ea typeface="Yu Gothic UI Light" panose="020B0300000000000000" pitchFamily="34" charset="-128"/>
+              </a:rPr>
+              <a:t>assume “everything is </a:t>
+            </a:r>
+            <a:r>
+              <a:rPr lang="en-US" dirty="0" err="1">
+                <a:latin typeface="Yu Gothic UI Light" panose="020B0300000000000000" pitchFamily="34" charset="-128"/>
+                <a:ea typeface="Yu Gothic UI Light" panose="020B0300000000000000" pitchFamily="34" charset="-128"/>
+              </a:rPr>
+              <a:t>nTNBC</a:t>
+            </a:r>
+            <a:r>
+              <a:rPr lang="en-US" dirty="0">
+                <a:latin typeface="Yu Gothic UI Light" panose="020B0300000000000000" pitchFamily="34" charset="-128"/>
+                <a:ea typeface="Yu Gothic UI Light" panose="020B0300000000000000" pitchFamily="34" charset="-128"/>
+              </a:rPr>
+              <a:t>” = accuracy of 0.8843</a:t>
             </a:r>
             <a:endParaRPr lang="en-GB" dirty="0">
               <a:latin typeface="Yu Gothic UI Light" panose="020B0300000000000000" pitchFamily="34" charset="-128"/>
@@ -9543,10 +9548,10 @@
       </p:sp>
       <p:sp>
         <p:nvSpPr>
-          <p:cNvPr id="4" name="TextBox 3">
-            <a:extLst>
-              <a:ext uri="{FF2B5EF4-FFF2-40B4-BE49-F238E27FC236}">
-                <a16:creationId xmlns="" xmlns:a16="http://schemas.microsoft.com/office/drawing/2014/main" id="{26AF226B-FF7A-BDA8-8095-D241C05639CF}"/>
+          <p:cNvPr id="7" name="TextBox 6">
+            <a:extLst>
+              <a:ext uri="{FF2B5EF4-FFF2-40B4-BE49-F238E27FC236}">
+                <a16:creationId xmlns:a16="http://schemas.microsoft.com/office/drawing/2014/main" id="{5A455A23-768A-7A03-BCB2-F3DD8578FAB4}"/>
               </a:ext>
             </a:extLst>
           </p:cNvPr>
@@ -9555,8 +9560,8 @@
         </p:nvSpPr>
         <p:spPr>
           <a:xfrm>
-            <a:off x="1725377" y="2782852"/>
-            <a:ext cx="7461351" cy="646331"/>
+            <a:off x="1725377" y="3883423"/>
+            <a:ext cx="5453750" cy="369332"/>
           </a:xfrm>
           <a:prstGeom prst="rect">
             <a:avLst/>
@@ -9571,70 +9576,22 @@
           <a:p>
             <a:pPr lvl="0"/>
             <a:r>
-              <a:rPr lang="en-GB" dirty="0" smtClean="0">
-                <a:latin typeface="Yu Gothic UI Light" panose="020B0300000000000000" pitchFamily="34" charset="-128"/>
-                <a:ea typeface="Yu Gothic UI Light" panose="020B0300000000000000" pitchFamily="34" charset="-128"/>
-              </a:rPr>
-              <a:t>Accuracy is misleading due to </a:t>
-            </a:r>
-            <a:r>
-              <a:rPr lang="en-GB" dirty="0" smtClean="0">
-                <a:latin typeface="Yu Gothic UI Light" panose="020B0300000000000000" pitchFamily="34" charset="-128"/>
-                <a:ea typeface="Yu Gothic UI Light" panose="020B0300000000000000" pitchFamily="34" charset="-128"/>
-              </a:rPr>
-              <a:t>unbalanced data</a:t>
-            </a:r>
-            <a:r>
-              <a:rPr lang="en-GB" dirty="0" smtClean="0">
-                <a:latin typeface="Yu Gothic UI Light" panose="020B0300000000000000" pitchFamily="34" charset="-128"/>
-                <a:ea typeface="Yu Gothic UI Light" panose="020B0300000000000000" pitchFamily="34" charset="-128"/>
-              </a:rPr>
-              <a:t>:</a:t>
-            </a:r>
-          </a:p>
-          <a:p>
-            <a:pPr lvl="0"/>
-            <a:r>
-              <a:rPr lang="en-GB" dirty="0" smtClean="0">
-                <a:latin typeface="Yu Gothic UI Light" panose="020B0300000000000000" pitchFamily="34" charset="-128"/>
-                <a:ea typeface="Yu Gothic UI Light" panose="020B0300000000000000" pitchFamily="34" charset="-128"/>
-              </a:rPr>
-              <a:t>- </a:t>
-            </a:r>
-            <a:r>
-              <a:rPr lang="en-US" dirty="0" smtClean="0">
-                <a:latin typeface="Yu Gothic UI Light" panose="020B0300000000000000" pitchFamily="34" charset="-128"/>
-                <a:ea typeface="Yu Gothic UI Light" panose="020B0300000000000000" pitchFamily="34" charset="-128"/>
-              </a:rPr>
-              <a:t>assume “everything is </a:t>
-            </a:r>
-            <a:r>
-              <a:rPr lang="en-US" dirty="0" err="1" smtClean="0">
-                <a:latin typeface="Yu Gothic UI Light" panose="020B0300000000000000" pitchFamily="34" charset="-128"/>
-                <a:ea typeface="Yu Gothic UI Light" panose="020B0300000000000000" pitchFamily="34" charset="-128"/>
-              </a:rPr>
-              <a:t>nTNBC</a:t>
-            </a:r>
-            <a:r>
-              <a:rPr lang="en-US" dirty="0" smtClean="0">
-                <a:latin typeface="Yu Gothic UI Light" panose="020B0300000000000000" pitchFamily="34" charset="-128"/>
-                <a:ea typeface="Yu Gothic UI Light" panose="020B0300000000000000" pitchFamily="34" charset="-128"/>
-              </a:rPr>
-              <a:t>” = accuracy of 0.8843</a:t>
-            </a:r>
-            <a:endParaRPr lang="en-GB" dirty="0">
-              <a:latin typeface="Yu Gothic UI Light" panose="020B0300000000000000" pitchFamily="34" charset="-128"/>
-              <a:ea typeface="Yu Gothic UI Light" panose="020B0300000000000000" pitchFamily="34" charset="-128"/>
-            </a:endParaRPr>
-          </a:p>
-        </p:txBody>
-      </p:sp>
-      <p:sp>
-        <p:nvSpPr>
-          <p:cNvPr id="7" name="TextBox 6">
-            <a:extLst>
-              <a:ext uri="{FF2B5EF4-FFF2-40B4-BE49-F238E27FC236}">
-                <a16:creationId xmlns="" xmlns:a16="http://schemas.microsoft.com/office/drawing/2014/main" id="{5A455A23-768A-7A03-BCB2-F3DD8578FAB4}"/>
+              <a:rPr lang="en-GB" dirty="0">
+                <a:latin typeface="Yu Gothic UI Light" panose="020B0300000000000000" pitchFamily="34" charset="-128"/>
+                <a:ea typeface="Yu Gothic UI Light" panose="020B0300000000000000" pitchFamily="34" charset="-128"/>
+              </a:rPr>
+              <a:t>Important to consider other metrics</a:t>
+            </a:r>
+            <a:endParaRPr lang="x-none" dirty="0"/>
+          </a:p>
+        </p:txBody>
+      </p:sp>
+      <p:sp>
+        <p:nvSpPr>
+          <p:cNvPr id="10" name="TextBox 9">
+            <a:extLst>
+              <a:ext uri="{FF2B5EF4-FFF2-40B4-BE49-F238E27FC236}">
+                <a16:creationId xmlns:a16="http://schemas.microsoft.com/office/drawing/2014/main" id="{CF78D215-3266-DEC4-9C40-39CD48F034C1}"/>
               </a:ext>
             </a:extLst>
           </p:cNvPr>
@@ -9643,8 +9600,8 @@
         </p:nvSpPr>
         <p:spPr>
           <a:xfrm>
-            <a:off x="1725377" y="3883423"/>
-            <a:ext cx="5453750" cy="369332"/>
+            <a:off x="1725378" y="4822735"/>
+            <a:ext cx="5453749" cy="369332"/>
           </a:xfrm>
           <a:prstGeom prst="rect">
             <a:avLst/>
@@ -9657,48 +9614,8 @@
           </a:bodyPr>
           <a:lstStyle/>
           <a:p>
-            <a:pPr lvl="0"/>
-            <a:r>
-              <a:rPr lang="en-GB" dirty="0" smtClean="0">
-                <a:latin typeface="Yu Gothic UI Light" panose="020B0300000000000000" pitchFamily="34" charset="-128"/>
-                <a:ea typeface="Yu Gothic UI Light" panose="020B0300000000000000" pitchFamily="34" charset="-128"/>
-              </a:rPr>
-              <a:t>Important to consider other metrics</a:t>
-            </a:r>
-            <a:endParaRPr lang="x-none" dirty="0"/>
-          </a:p>
-        </p:txBody>
-      </p:sp>
-      <p:sp>
-        <p:nvSpPr>
-          <p:cNvPr id="10" name="TextBox 9">
-            <a:extLst>
-              <a:ext uri="{FF2B5EF4-FFF2-40B4-BE49-F238E27FC236}">
-                <a16:creationId xmlns="" xmlns:a16="http://schemas.microsoft.com/office/drawing/2014/main" id="{CF78D215-3266-DEC4-9C40-39CD48F034C1}"/>
-              </a:ext>
-            </a:extLst>
-          </p:cNvPr>
-          <p:cNvSpPr txBox="1"/>
-          <p:nvPr/>
-        </p:nvSpPr>
-        <p:spPr>
-          <a:xfrm>
-            <a:off x="1725378" y="4822735"/>
-            <a:ext cx="5453749" cy="369332"/>
-          </a:xfrm>
-          <a:prstGeom prst="rect">
-            <a:avLst/>
-          </a:prstGeom>
-          <a:noFill/>
-        </p:spPr>
-        <p:txBody>
-          <a:bodyPr wrap="square" rtlCol="0">
-            <a:spAutoFit/>
-          </a:bodyPr>
-          <a:lstStyle/>
-          <a:p>
-            <a:r>
-              <a:rPr lang="en-GB" dirty="0" smtClean="0">
+            <a:r>
+              <a:rPr lang="en-GB" dirty="0">
                 <a:latin typeface="Yu Gothic UI Light" panose="020B0300000000000000" pitchFamily="34" charset="-128"/>
                 <a:ea typeface="Yu Gothic UI Light" panose="020B0300000000000000" pitchFamily="34" charset="-128"/>
               </a:rPr>
@@ -9716,7 +9633,7 @@
           <p:cNvPr id="17" name="Graphic 3">
             <a:extLst>
               <a:ext uri="{FF2B5EF4-FFF2-40B4-BE49-F238E27FC236}">
-                <a16:creationId xmlns="" xmlns:a16="http://schemas.microsoft.com/office/drawing/2014/main" id="{4AE3E20A-B84B-1636-6212-061E86FF949C}"/>
+                <a16:creationId xmlns:a16="http://schemas.microsoft.com/office/drawing/2014/main" id="{4AE3E20A-B84B-1636-6212-061E86FF949C}"/>
               </a:ext>
             </a:extLst>
           </p:cNvPr>
@@ -9729,7 +9646,7 @@
           <a:blip r:embed="rId3">
             <a:extLst>
               <a:ext uri="{96DAC541-7B7A-43D3-8B79-37D633B846F1}">
-                <asvg:svgBlip xmlns="" xmlns:asvg="http://schemas.microsoft.com/office/drawing/2016/SVG/main" r:embed="rId4"/>
+                <asvg:svgBlip xmlns:asvg="http://schemas.microsoft.com/office/drawing/2016/SVG/main" r:embed="rId4"/>
               </a:ext>
             </a:extLst>
           </a:blip>
@@ -9757,13 +9674,6 @@
   <p:clrMapOvr>
     <a:masterClrMapping/>
   </p:clrMapOvr>
-  <p:timing>
-    <p:tnLst>
-      <p:par>
-        <p:cTn id="1" dur="indefinite" restart="never" nodeType="tmRoot"/>
-      </p:par>
-    </p:tnLst>
-  </p:timing>
 </p:sld>
 </file>
 
@@ -9786,7 +9696,7 @@
         <p:cNvPr id="1" name="">
           <a:extLst>
             <a:ext uri="{FF2B5EF4-FFF2-40B4-BE49-F238E27FC236}">
-              <a16:creationId xmlns="" xmlns:a16="http://schemas.microsoft.com/office/drawing/2014/main" id="{86F24FA8-7EFA-8FC5-EF0B-0C36D1C34732}"/>
+              <a16:creationId xmlns:a16="http://schemas.microsoft.com/office/drawing/2014/main" id="{86F24FA8-7EFA-8FC5-EF0B-0C36D1C34732}"/>
             </a:ext>
           </a:extLst>
         </p:cNvPr>
@@ -9806,7 +9716,7 @@
           <p:cNvPr id="8" name="000_topleftHeading">
             <a:extLst>
               <a:ext uri="{FF2B5EF4-FFF2-40B4-BE49-F238E27FC236}">
-                <a16:creationId xmlns="" xmlns:a16="http://schemas.microsoft.com/office/drawing/2014/main" id="{E523ED40-0926-2F89-3476-0DA7C2BE0A11}"/>
+                <a16:creationId xmlns:a16="http://schemas.microsoft.com/office/drawing/2014/main" id="{E523ED40-0926-2F89-3476-0DA7C2BE0A11}"/>
               </a:ext>
             </a:extLst>
           </p:cNvPr>
@@ -9830,7 +9740,7 @@
           <a:lstStyle/>
           <a:p>
             <a:r>
-              <a:rPr lang="en-US" dirty="0" smtClean="0">
+              <a:rPr lang="en-US" dirty="0">
                 <a:latin typeface="Yu Gothic UI Light" panose="020B0300000000000000" pitchFamily="34" charset="-128"/>
                 <a:ea typeface="Yu Gothic UI Light" panose="020B0300000000000000" pitchFamily="34" charset="-128"/>
               </a:rPr>
@@ -9848,7 +9758,7 @@
           <p:cNvPr id="9" name="001_subtitle">
             <a:extLst>
               <a:ext uri="{FF2B5EF4-FFF2-40B4-BE49-F238E27FC236}">
-                <a16:creationId xmlns="" xmlns:a16="http://schemas.microsoft.com/office/drawing/2014/main" id="{A6AE533C-5B4F-8F93-C999-B358BF1053E4}"/>
+                <a16:creationId xmlns:a16="http://schemas.microsoft.com/office/drawing/2014/main" id="{A6AE533C-5B4F-8F93-C999-B358BF1053E4}"/>
               </a:ext>
             </a:extLst>
           </p:cNvPr>
@@ -9887,7 +9797,7 @@
           <p:cNvPr id="2" name="TextBox 1">
             <a:extLst>
               <a:ext uri="{FF2B5EF4-FFF2-40B4-BE49-F238E27FC236}">
-                <a16:creationId xmlns="" xmlns:a16="http://schemas.microsoft.com/office/drawing/2014/main" id="{E5F6B1BA-73E3-3089-C8E0-D47CAC7F3ADB}"/>
+                <a16:creationId xmlns:a16="http://schemas.microsoft.com/office/drawing/2014/main" id="{E5F6B1BA-73E3-3089-C8E0-D47CAC7F3ADB}"/>
               </a:ext>
             </a:extLst>
           </p:cNvPr>
@@ -9912,16 +9822,12 @@
           <a:p>
             <a:pPr lvl="0"/>
             <a:r>
-              <a:rPr lang="en-GB" dirty="0" smtClean="0">
+              <a:rPr lang="en-GB" dirty="0">
                 <a:latin typeface="Yu Gothic UI Light" panose="020B0300000000000000" pitchFamily="34" charset="-128"/>
                 <a:ea typeface="Yu Gothic UI Light" panose="020B0300000000000000" pitchFamily="34" charset="-128"/>
               </a:rPr>
               <a:t>Literature based gives better accuracy than manual analysis</a:t>
             </a:r>
-            <a:endParaRPr lang="en-GB" dirty="0">
-              <a:latin typeface="Yu Gothic UI Light" panose="020B0300000000000000" pitchFamily="34" charset="-128"/>
-              <a:ea typeface="Yu Gothic UI Light" panose="020B0300000000000000" pitchFamily="34" charset="-128"/>
-            </a:endParaRPr>
           </a:p>
         </p:txBody>
       </p:sp>
@@ -9930,7 +9836,7 @@
           <p:cNvPr id="4" name="TextBox 3">
             <a:extLst>
               <a:ext uri="{FF2B5EF4-FFF2-40B4-BE49-F238E27FC236}">
-                <a16:creationId xmlns="" xmlns:a16="http://schemas.microsoft.com/office/drawing/2014/main" id="{26AF226B-FF7A-BDA8-8095-D241C05639CF}"/>
+                <a16:creationId xmlns:a16="http://schemas.microsoft.com/office/drawing/2014/main" id="{26AF226B-FF7A-BDA8-8095-D241C05639CF}"/>
               </a:ext>
             </a:extLst>
           </p:cNvPr>
@@ -9955,7 +9861,7 @@
           <a:p>
             <a:pPr lvl="0"/>
             <a:r>
-              <a:rPr lang="en-US" dirty="0" smtClean="0">
+              <a:rPr lang="en-US" dirty="0">
                 <a:latin typeface="Yu Gothic UI Light" panose="020B0300000000000000" pitchFamily="34" charset="-128"/>
                 <a:ea typeface="Yu Gothic UI Light" panose="020B0300000000000000" pitchFamily="34" charset="-128"/>
               </a:rPr>
@@ -9965,7 +9871,7 @@
           <a:p>
             <a:pPr lvl="0"/>
             <a:r>
-              <a:rPr lang="en-US" dirty="0" smtClean="0">
+              <a:rPr lang="en-US" dirty="0">
                 <a:latin typeface="Yu Gothic UI Light" panose="020B0300000000000000" pitchFamily="34" charset="-128"/>
                 <a:ea typeface="Yu Gothic UI Light" panose="020B0300000000000000" pitchFamily="34" charset="-128"/>
               </a:rPr>
@@ -9986,7 +9892,7 @@
           <p:cNvPr id="7" name="TextBox 6">
             <a:extLst>
               <a:ext uri="{FF2B5EF4-FFF2-40B4-BE49-F238E27FC236}">
-                <a16:creationId xmlns="" xmlns:a16="http://schemas.microsoft.com/office/drawing/2014/main" id="{5A455A23-768A-7A03-BCB2-F3DD8578FAB4}"/>
+                <a16:creationId xmlns:a16="http://schemas.microsoft.com/office/drawing/2014/main" id="{5A455A23-768A-7A03-BCB2-F3DD8578FAB4}"/>
               </a:ext>
             </a:extLst>
           </p:cNvPr>
@@ -10011,23 +9917,12 @@
           <a:p>
             <a:pPr lvl="0"/>
             <a:r>
-              <a:rPr lang="en-GB" dirty="0" smtClean="0">
-                <a:latin typeface="Yu Gothic UI Light" panose="020B0300000000000000" pitchFamily="34" charset="-128"/>
-                <a:ea typeface="Yu Gothic UI Light" panose="020B0300000000000000" pitchFamily="34" charset="-128"/>
-              </a:rPr>
-              <a:t>Use of 297 genes referenced in literature, reduced by LASSO, gives best results, though RFE </a:t>
-            </a:r>
-            <a:r>
-              <a:rPr lang="en-GB" dirty="0" smtClean="0">
-                <a:latin typeface="Yu Gothic UI Light" panose="020B0300000000000000" pitchFamily="34" charset="-128"/>
-                <a:ea typeface="Yu Gothic UI Light" panose="020B0300000000000000" pitchFamily="34" charset="-128"/>
-              </a:rPr>
-              <a:t>is similar</a:t>
-            </a:r>
-            <a:endParaRPr lang="en-GB" dirty="0" smtClean="0">
-              <a:latin typeface="Yu Gothic UI Light" panose="020B0300000000000000" pitchFamily="34" charset="-128"/>
-              <a:ea typeface="Yu Gothic UI Light" panose="020B0300000000000000" pitchFamily="34" charset="-128"/>
-            </a:endParaRPr>
+              <a:rPr lang="en-GB" dirty="0">
+                <a:latin typeface="Yu Gothic UI Light" panose="020B0300000000000000" pitchFamily="34" charset="-128"/>
+                <a:ea typeface="Yu Gothic UI Light" panose="020B0300000000000000" pitchFamily="34" charset="-128"/>
+              </a:rPr>
+              <a:t>Use of 297 genes referenced in literature, reduced by LASSO, gives best results, though RFE is similar</a:t>
+            </a:r>
           </a:p>
         </p:txBody>
       </p:sp>
@@ -10036,7 +9931,7 @@
           <p:cNvPr id="10" name="TextBox 9">
             <a:extLst>
               <a:ext uri="{FF2B5EF4-FFF2-40B4-BE49-F238E27FC236}">
-                <a16:creationId xmlns="" xmlns:a16="http://schemas.microsoft.com/office/drawing/2014/main" id="{CF78D215-3266-DEC4-9C40-39CD48F034C1}"/>
+                <a16:creationId xmlns:a16="http://schemas.microsoft.com/office/drawing/2014/main" id="{CF78D215-3266-DEC4-9C40-39CD48F034C1}"/>
               </a:ext>
             </a:extLst>
           </p:cNvPr>
@@ -10060,7 +9955,7 @@
           <a:lstStyle/>
           <a:p>
             <a:r>
-              <a:rPr lang="en-GB" dirty="0" smtClean="0">
+              <a:rPr lang="en-GB" dirty="0">
                 <a:latin typeface="Yu Gothic UI Light" panose="020B0300000000000000" pitchFamily="34" charset="-128"/>
                 <a:ea typeface="Yu Gothic UI Light" panose="020B0300000000000000" pitchFamily="34" charset="-128"/>
               </a:rPr>
@@ -10078,7 +9973,7 @@
           <p:cNvPr id="17" name="Graphic 3">
             <a:extLst>
               <a:ext uri="{FF2B5EF4-FFF2-40B4-BE49-F238E27FC236}">
-                <a16:creationId xmlns="" xmlns:a16="http://schemas.microsoft.com/office/drawing/2014/main" id="{4AE3E20A-B84B-1636-6212-061E86FF949C}"/>
+                <a16:creationId xmlns:a16="http://schemas.microsoft.com/office/drawing/2014/main" id="{4AE3E20A-B84B-1636-6212-061E86FF949C}"/>
               </a:ext>
             </a:extLst>
           </p:cNvPr>
@@ -10091,7 +9986,7 @@
           <a:blip r:embed="rId3">
             <a:extLst>
               <a:ext uri="{96DAC541-7B7A-43D3-8B79-37D633B846F1}">
-                <asvg:svgBlip xmlns="" xmlns:asvg="http://schemas.microsoft.com/office/drawing/2016/SVG/main" r:embed="rId4"/>
+                <asvg:svgBlip xmlns:asvg="http://schemas.microsoft.com/office/drawing/2016/SVG/main" r:embed="rId4"/>
               </a:ext>
             </a:extLst>
           </a:blip>
@@ -10114,7 +10009,7 @@
           <p:cNvPr id="12" name="Picture 11" descr="A diagram of a gene&#10;&#10;AI-generated content may be incorrect.">
             <a:extLst>
               <a:ext uri="{FF2B5EF4-FFF2-40B4-BE49-F238E27FC236}">
-                <a16:creationId xmlns="" xmlns:a16="http://schemas.microsoft.com/office/drawing/2014/main" id="{F87D44CA-0A78-108E-AB90-0810BEF991ED}"/>
+                <a16:creationId xmlns:a16="http://schemas.microsoft.com/office/drawing/2014/main" id="{F87D44CA-0A78-108E-AB90-0810BEF991ED}"/>
               </a:ext>
             </a:extLst>
           </p:cNvPr>
@@ -10150,7 +10045,7 @@
           <p:cNvPr id="13" name="TextBox 12">
             <a:extLst>
               <a:ext uri="{FF2B5EF4-FFF2-40B4-BE49-F238E27FC236}">
-                <a16:creationId xmlns="" xmlns:a16="http://schemas.microsoft.com/office/drawing/2014/main" id="{85C4C44A-80AD-0A49-D4B2-61F9E7A66D61}"/>
+                <a16:creationId xmlns:a16="http://schemas.microsoft.com/office/drawing/2014/main" id="{85C4C44A-80AD-0A49-D4B2-61F9E7A66D61}"/>
               </a:ext>
             </a:extLst>
           </p:cNvPr>
@@ -10198,13 +10093,6 @@
   <p:clrMapOvr>
     <a:masterClrMapping/>
   </p:clrMapOvr>
-  <p:timing>
-    <p:tnLst>
-      <p:par>
-        <p:cTn id="1" dur="indefinite" restart="never" nodeType="tmRoot"/>
-      </p:par>
-    </p:tnLst>
-  </p:timing>
 </p:sld>
 </file>
 
@@ -10227,7 +10115,7 @@
         <p:cNvPr id="1" name="">
           <a:extLst>
             <a:ext uri="{FF2B5EF4-FFF2-40B4-BE49-F238E27FC236}">
-              <a16:creationId xmlns="" xmlns:a16="http://schemas.microsoft.com/office/drawing/2014/main" id="{86F24FA8-7EFA-8FC5-EF0B-0C36D1C34732}"/>
+              <a16:creationId xmlns:a16="http://schemas.microsoft.com/office/drawing/2014/main" id="{86F24FA8-7EFA-8FC5-EF0B-0C36D1C34732}"/>
             </a:ext>
           </a:extLst>
         </p:cNvPr>
@@ -10247,7 +10135,7 @@
           <p:cNvPr id="8" name="000_topleftHeading">
             <a:extLst>
               <a:ext uri="{FF2B5EF4-FFF2-40B4-BE49-F238E27FC236}">
-                <a16:creationId xmlns="" xmlns:a16="http://schemas.microsoft.com/office/drawing/2014/main" id="{E523ED40-0926-2F89-3476-0DA7C2BE0A11}"/>
+                <a16:creationId xmlns:a16="http://schemas.microsoft.com/office/drawing/2014/main" id="{E523ED40-0926-2F89-3476-0DA7C2BE0A11}"/>
               </a:ext>
             </a:extLst>
           </p:cNvPr>
@@ -10271,7 +10159,7 @@
           <a:lstStyle/>
           <a:p>
             <a:r>
-              <a:rPr lang="en-US" dirty="0" smtClean="0">
+              <a:rPr lang="en-US" dirty="0">
                 <a:latin typeface="Yu Gothic UI Light" panose="020B0300000000000000" pitchFamily="34" charset="-128"/>
                 <a:ea typeface="Yu Gothic UI Light" panose="020B0300000000000000" pitchFamily="34" charset="-128"/>
               </a:rPr>
@@ -10289,7 +10177,7 @@
           <p:cNvPr id="9" name="001_subtitle">
             <a:extLst>
               <a:ext uri="{FF2B5EF4-FFF2-40B4-BE49-F238E27FC236}">
-                <a16:creationId xmlns="" xmlns:a16="http://schemas.microsoft.com/office/drawing/2014/main" id="{A6AE533C-5B4F-8F93-C999-B358BF1053E4}"/>
+                <a16:creationId xmlns:a16="http://schemas.microsoft.com/office/drawing/2014/main" id="{A6AE533C-5B4F-8F93-C999-B358BF1053E4}"/>
               </a:ext>
             </a:extLst>
           </p:cNvPr>
@@ -10329,7 +10217,7 @@
           <p:cNvPr id="2" name="TextBox 1">
             <a:extLst>
               <a:ext uri="{FF2B5EF4-FFF2-40B4-BE49-F238E27FC236}">
-                <a16:creationId xmlns="" xmlns:a16="http://schemas.microsoft.com/office/drawing/2014/main" id="{E5F6B1BA-73E3-3089-C8E0-D47CAC7F3ADB}"/>
+                <a16:creationId xmlns:a16="http://schemas.microsoft.com/office/drawing/2014/main" id="{E5F6B1BA-73E3-3089-C8E0-D47CAC7F3ADB}"/>
               </a:ext>
             </a:extLst>
           </p:cNvPr>
@@ -10354,16 +10242,12 @@
           <a:p>
             <a:pPr lvl="0"/>
             <a:r>
-              <a:rPr lang="en-GB" dirty="0" smtClean="0">
+              <a:rPr lang="en-GB" dirty="0">
                 <a:latin typeface="Yu Gothic UI Light" panose="020B0300000000000000" pitchFamily="34" charset="-128"/>
                 <a:ea typeface="Yu Gothic UI Light" panose="020B0300000000000000" pitchFamily="34" charset="-128"/>
               </a:rPr>
               <a:t>Algorithms give similar results, Random Forest slightly better</a:t>
             </a:r>
-            <a:endParaRPr lang="en-GB" dirty="0">
-              <a:latin typeface="Yu Gothic UI Light" panose="020B0300000000000000" pitchFamily="34" charset="-128"/>
-              <a:ea typeface="Yu Gothic UI Light" panose="020B0300000000000000" pitchFamily="34" charset="-128"/>
-            </a:endParaRPr>
           </a:p>
         </p:txBody>
       </p:sp>
@@ -10372,7 +10256,7 @@
           <p:cNvPr id="7" name="TextBox 6">
             <a:extLst>
               <a:ext uri="{FF2B5EF4-FFF2-40B4-BE49-F238E27FC236}">
-                <a16:creationId xmlns="" xmlns:a16="http://schemas.microsoft.com/office/drawing/2014/main" id="{5A455A23-768A-7A03-BCB2-F3DD8578FAB4}"/>
+                <a16:creationId xmlns:a16="http://schemas.microsoft.com/office/drawing/2014/main" id="{5A455A23-768A-7A03-BCB2-F3DD8578FAB4}"/>
               </a:ext>
             </a:extLst>
           </p:cNvPr>
@@ -10397,7 +10281,7 @@
           <a:p>
             <a:pPr lvl="0"/>
             <a:r>
-              <a:rPr lang="en-GB" dirty="0" smtClean="0">
+              <a:rPr lang="en-GB" dirty="0">
                 <a:latin typeface="Yu Gothic UI Light" panose="020B0300000000000000" pitchFamily="34" charset="-128"/>
                 <a:ea typeface="Yu Gothic UI Light" panose="020B0300000000000000" pitchFamily="34" charset="-128"/>
               </a:rPr>
@@ -10411,7 +10295,7 @@
           <p:cNvPr id="17" name="Graphic 3">
             <a:extLst>
               <a:ext uri="{FF2B5EF4-FFF2-40B4-BE49-F238E27FC236}">
-                <a16:creationId xmlns="" xmlns:a16="http://schemas.microsoft.com/office/drawing/2014/main" id="{4AE3E20A-B84B-1636-6212-061E86FF949C}"/>
+                <a16:creationId xmlns:a16="http://schemas.microsoft.com/office/drawing/2014/main" id="{4AE3E20A-B84B-1636-6212-061E86FF949C}"/>
               </a:ext>
             </a:extLst>
           </p:cNvPr>
@@ -10424,7 +10308,7 @@
           <a:blip r:embed="rId3">
             <a:extLst>
               <a:ext uri="{96DAC541-7B7A-43D3-8B79-37D633B846F1}">
-                <asvg:svgBlip xmlns="" xmlns:asvg="http://schemas.microsoft.com/office/drawing/2016/SVG/main" r:embed="rId4"/>
+                <asvg:svgBlip xmlns:asvg="http://schemas.microsoft.com/office/drawing/2016/SVG/main" r:embed="rId4"/>
               </a:ext>
             </a:extLst>
           </a:blip>
@@ -10447,7 +10331,7 @@
           <p:cNvPr id="13" name="TextBox 12">
             <a:extLst>
               <a:ext uri="{FF2B5EF4-FFF2-40B4-BE49-F238E27FC236}">
-                <a16:creationId xmlns="" xmlns:a16="http://schemas.microsoft.com/office/drawing/2014/main" id="{85C4C44A-80AD-0A49-D4B2-61F9E7A66D61}"/>
+                <a16:creationId xmlns:a16="http://schemas.microsoft.com/office/drawing/2014/main" id="{85C4C44A-80AD-0A49-D4B2-61F9E7A66D61}"/>
               </a:ext>
             </a:extLst>
           </p:cNvPr>
@@ -10490,7 +10374,7 @@
           <p:cNvPr id="11" name="Picture 10" descr="A computer monitor and a machine&#10;&#10;AI-generated content may be incorrect.">
             <a:extLst>
               <a:ext uri="{FF2B5EF4-FFF2-40B4-BE49-F238E27FC236}">
-                <a16:creationId xmlns="" xmlns:a16="http://schemas.microsoft.com/office/drawing/2014/main" id="{1F1E104F-E4EF-4E96-52AB-9286CD7BE017}"/>
+                <a16:creationId xmlns:a16="http://schemas.microsoft.com/office/drawing/2014/main" id="{1F1E104F-E4EF-4E96-52AB-9286CD7BE017}"/>
               </a:ext>
             </a:extLst>
           </p:cNvPr>
@@ -10526,7 +10410,7 @@
           <p:cNvPr id="14" name="TextBox 13">
             <a:extLst>
               <a:ext uri="{FF2B5EF4-FFF2-40B4-BE49-F238E27FC236}">
-                <a16:creationId xmlns="" xmlns:a16="http://schemas.microsoft.com/office/drawing/2014/main" id="{CF78D215-3266-DEC4-9C40-39CD48F034C1}"/>
+                <a16:creationId xmlns:a16="http://schemas.microsoft.com/office/drawing/2014/main" id="{CF78D215-3266-DEC4-9C40-39CD48F034C1}"/>
               </a:ext>
             </a:extLst>
           </p:cNvPr>
@@ -10550,7 +10434,7 @@
           <a:lstStyle/>
           <a:p>
             <a:r>
-              <a:rPr lang="en-GB" dirty="0" smtClean="0">
+              <a:rPr lang="en-GB" dirty="0">
                 <a:latin typeface="Yu Gothic UI Light" panose="020B0300000000000000" pitchFamily="34" charset="-128"/>
                 <a:ea typeface="Yu Gothic UI Light" panose="020B0300000000000000" pitchFamily="34" charset="-128"/>
               </a:rPr>
@@ -10558,7 +10442,7 @@
             </a:r>
           </a:p>
           <a:p>
-            <a:endParaRPr lang="en-GB" dirty="0" smtClean="0">
+            <a:endParaRPr lang="en-GB" dirty="0">
               <a:latin typeface="Yu Gothic UI Light" panose="020B0300000000000000" pitchFamily="34" charset="-128"/>
               <a:ea typeface="Yu Gothic UI Light" panose="020B0300000000000000" pitchFamily="34" charset="-128"/>
             </a:endParaRPr>
@@ -10569,7 +10453,7 @@
               <a:buChar char="-"/>
             </a:pPr>
             <a:r>
-              <a:rPr lang="en-GB" dirty="0" smtClean="0">
+              <a:rPr lang="en-GB" dirty="0">
                 <a:latin typeface="Yu Gothic UI Light" panose="020B0300000000000000" pitchFamily="34" charset="-128"/>
                 <a:ea typeface="Yu Gothic UI Light" panose="020B0300000000000000" pitchFamily="34" charset="-128"/>
               </a:rPr>
@@ -10586,14 +10470,7 @@
                 <a:latin typeface="Yu Gothic UI Light" panose="020B0300000000000000" pitchFamily="34" charset="-128"/>
                 <a:ea typeface="Yu Gothic UI Light" panose="020B0300000000000000" pitchFamily="34" charset="-128"/>
               </a:rPr>
-              <a:t>R</a:t>
-            </a:r>
-            <a:r>
-              <a:rPr lang="en-GB" dirty="0" smtClean="0">
-                <a:latin typeface="Yu Gothic UI Light" panose="020B0300000000000000" pitchFamily="34" charset="-128"/>
-                <a:ea typeface="Yu Gothic UI Light" panose="020B0300000000000000" pitchFamily="34" charset="-128"/>
-              </a:rPr>
-              <a:t>ecall 95.65%</a:t>
+              <a:t>Recall 95.65%</a:t>
             </a:r>
           </a:p>
           <a:p>
@@ -10602,18 +10479,11 @@
               <a:buChar char="-"/>
             </a:pPr>
             <a:r>
-              <a:rPr lang="en-GB" dirty="0" smtClean="0">
-                <a:latin typeface="Yu Gothic UI Light" panose="020B0300000000000000" pitchFamily="34" charset="-128"/>
-                <a:ea typeface="Yu Gothic UI Light" panose="020B0300000000000000" pitchFamily="34" charset="-128"/>
-              </a:rPr>
-              <a:t>F1-score </a:t>
-            </a:r>
-            <a:r>
               <a:rPr lang="en-GB" dirty="0">
                 <a:latin typeface="Yu Gothic UI Light" panose="020B0300000000000000" pitchFamily="34" charset="-128"/>
                 <a:ea typeface="Yu Gothic UI Light" panose="020B0300000000000000" pitchFamily="34" charset="-128"/>
               </a:rPr>
-              <a:t>of 84.62%. </a:t>
+              <a:t>F1-score of 84.62%. </a:t>
             </a:r>
             <a:endParaRPr lang="x-none" dirty="0">
               <a:latin typeface="Yu Gothic UI Light" panose="020B0300000000000000" pitchFamily="34" charset="-128"/>
@@ -10632,13 +10502,6 @@
   <p:clrMapOvr>
     <a:masterClrMapping/>
   </p:clrMapOvr>
-  <p:timing>
-    <p:tnLst>
-      <p:par>
-        <p:cTn id="1" dur="indefinite" restart="never" nodeType="tmRoot"/>
-      </p:par>
-    </p:tnLst>
-  </p:timing>
 </p:sld>
 </file>
 
@@ -10661,7 +10524,7 @@
         <p:cNvPr id="1" name="">
           <a:extLst>
             <a:ext uri="{FF2B5EF4-FFF2-40B4-BE49-F238E27FC236}">
-              <a16:creationId xmlns="" xmlns:a16="http://schemas.microsoft.com/office/drawing/2014/main" id="{86F24FA8-7EFA-8FC5-EF0B-0C36D1C34732}"/>
+              <a16:creationId xmlns:a16="http://schemas.microsoft.com/office/drawing/2014/main" id="{86F24FA8-7EFA-8FC5-EF0B-0C36D1C34732}"/>
             </a:ext>
           </a:extLst>
         </p:cNvPr>
@@ -10681,7 +10544,7 @@
           <p:cNvPr id="8" name="000_topleftHeading">
             <a:extLst>
               <a:ext uri="{FF2B5EF4-FFF2-40B4-BE49-F238E27FC236}">
-                <a16:creationId xmlns="" xmlns:a16="http://schemas.microsoft.com/office/drawing/2014/main" id="{E523ED40-0926-2F89-3476-0DA7C2BE0A11}"/>
+                <a16:creationId xmlns:a16="http://schemas.microsoft.com/office/drawing/2014/main" id="{E523ED40-0926-2F89-3476-0DA7C2BE0A11}"/>
               </a:ext>
             </a:extLst>
           </p:cNvPr>
@@ -10705,7 +10568,7 @@
           <a:lstStyle/>
           <a:p>
             <a:r>
-              <a:rPr lang="en-US" dirty="0" smtClean="0">
+              <a:rPr lang="en-US" dirty="0">
                 <a:latin typeface="Yu Gothic UI Light" panose="020B0300000000000000" pitchFamily="34" charset="-128"/>
                 <a:ea typeface="Yu Gothic UI Light" panose="020B0300000000000000" pitchFamily="34" charset="-128"/>
               </a:rPr>
@@ -10723,7 +10586,7 @@
           <p:cNvPr id="9" name="001_subtitle">
             <a:extLst>
               <a:ext uri="{FF2B5EF4-FFF2-40B4-BE49-F238E27FC236}">
-                <a16:creationId xmlns="" xmlns:a16="http://schemas.microsoft.com/office/drawing/2014/main" id="{A6AE533C-5B4F-8F93-C999-B358BF1053E4}"/>
+                <a16:creationId xmlns:a16="http://schemas.microsoft.com/office/drawing/2014/main" id="{A6AE533C-5B4F-8F93-C999-B358BF1053E4}"/>
               </a:ext>
             </a:extLst>
           </p:cNvPr>
@@ -10765,7 +10628,7 @@
           <p:cNvPr id="2" name="TextBox 1">
             <a:extLst>
               <a:ext uri="{FF2B5EF4-FFF2-40B4-BE49-F238E27FC236}">
-                <a16:creationId xmlns="" xmlns:a16="http://schemas.microsoft.com/office/drawing/2014/main" id="{E5F6B1BA-73E3-3089-C8E0-D47CAC7F3ADB}"/>
+                <a16:creationId xmlns:a16="http://schemas.microsoft.com/office/drawing/2014/main" id="{E5F6B1BA-73E3-3089-C8E0-D47CAC7F3ADB}"/>
               </a:ext>
             </a:extLst>
           </p:cNvPr>
@@ -10790,30 +10653,12 @@
           <a:p>
             <a:pPr lvl="0"/>
             <a:r>
-              <a:rPr lang="en-GB" dirty="0" smtClean="0">
-                <a:latin typeface="Yu Gothic UI Light" panose="020B0300000000000000" pitchFamily="34" charset="-128"/>
-                <a:ea typeface="Yu Gothic UI Light" panose="020B0300000000000000" pitchFamily="34" charset="-128"/>
-              </a:rPr>
-              <a:t>Privacy: patient data not saved in repository</a:t>
-            </a:r>
-            <a:r>
               <a:rPr lang="en-GB" dirty="0">
                 <a:latin typeface="Yu Gothic UI Light" panose="020B0300000000000000" pitchFamily="34" charset="-128"/>
                 <a:ea typeface="Yu Gothic UI Light" panose="020B0300000000000000" pitchFamily="34" charset="-128"/>
               </a:rPr>
-              <a:t>, instead provided instructions </a:t>
-            </a:r>
-            <a:r>
-              <a:rPr lang="en-GB" dirty="0" smtClean="0">
-                <a:latin typeface="Yu Gothic UI Light" panose="020B0300000000000000" pitchFamily="34" charset="-128"/>
-                <a:ea typeface="Yu Gothic UI Light" panose="020B0300000000000000" pitchFamily="34" charset="-128"/>
-              </a:rPr>
-              <a:t>to acquire</a:t>
-            </a:r>
-            <a:endParaRPr lang="en-GB" dirty="0">
-              <a:latin typeface="Yu Gothic UI Light" panose="020B0300000000000000" pitchFamily="34" charset="-128"/>
-              <a:ea typeface="Yu Gothic UI Light" panose="020B0300000000000000" pitchFamily="34" charset="-128"/>
-            </a:endParaRPr>
+              <a:t>Privacy: patient data not saved in repository, instead provided instructions to acquire</a:t>
+            </a:r>
           </a:p>
         </p:txBody>
       </p:sp>
@@ -10822,7 +10667,7 @@
           <p:cNvPr id="7" name="TextBox 6">
             <a:extLst>
               <a:ext uri="{FF2B5EF4-FFF2-40B4-BE49-F238E27FC236}">
-                <a16:creationId xmlns="" xmlns:a16="http://schemas.microsoft.com/office/drawing/2014/main" id="{5A455A23-768A-7A03-BCB2-F3DD8578FAB4}"/>
+                <a16:creationId xmlns:a16="http://schemas.microsoft.com/office/drawing/2014/main" id="{5A455A23-768A-7A03-BCB2-F3DD8578FAB4}"/>
               </a:ext>
             </a:extLst>
           </p:cNvPr>
@@ -10847,35 +10692,21 @@
           <a:p>
             <a:pPr lvl="0"/>
             <a:r>
-              <a:rPr lang="en-GB" dirty="0" smtClean="0">
-                <a:latin typeface="Yu Gothic UI Light" panose="020B0300000000000000" pitchFamily="34" charset="-128"/>
-                <a:ea typeface="Yu Gothic UI Light" panose="020B0300000000000000" pitchFamily="34" charset="-128"/>
-              </a:rPr>
-              <a:t>Fairness/Bias: clinical data such as race, age, etc. was never part of </a:t>
-            </a:r>
-            <a:r>
-              <a:rPr lang="en-GB" dirty="0" smtClean="0">
-                <a:latin typeface="Yu Gothic UI Light" panose="020B0300000000000000" pitchFamily="34" charset="-128"/>
-                <a:ea typeface="Yu Gothic UI Light" panose="020B0300000000000000" pitchFamily="34" charset="-128"/>
-              </a:rPr>
-              <a:t>training </a:t>
-            </a:r>
-            <a:r>
-              <a:rPr lang="en-GB" dirty="0" smtClean="0">
-                <a:latin typeface="Yu Gothic UI Light" panose="020B0300000000000000" pitchFamily="34" charset="-128"/>
-                <a:ea typeface="Yu Gothic UI Light" panose="020B0300000000000000" pitchFamily="34" charset="-128"/>
-              </a:rPr>
-              <a:t>data, only RNA-</a:t>
-            </a:r>
-            <a:r>
-              <a:rPr lang="en-GB" dirty="0" err="1" smtClean="0">
+              <a:rPr lang="en-GB" dirty="0">
+                <a:latin typeface="Yu Gothic UI Light" panose="020B0300000000000000" pitchFamily="34" charset="-128"/>
+                <a:ea typeface="Yu Gothic UI Light" panose="020B0300000000000000" pitchFamily="34" charset="-128"/>
+              </a:rPr>
+              <a:t>Fairness/Bias: clinical data such as race, age, etc. was never part of training data, only RNA-</a:t>
+            </a:r>
+            <a:r>
+              <a:rPr lang="en-GB" dirty="0" err="1">
                 <a:latin typeface="Yu Gothic UI Light" panose="020B0300000000000000" pitchFamily="34" charset="-128"/>
                 <a:ea typeface="Yu Gothic UI Light" panose="020B0300000000000000" pitchFamily="34" charset="-128"/>
               </a:rPr>
               <a:t>seq</a:t>
             </a:r>
             <a:r>
-              <a:rPr lang="en-GB" dirty="0" smtClean="0">
+              <a:rPr lang="en-GB" dirty="0">
                 <a:latin typeface="Yu Gothic UI Light" panose="020B0300000000000000" pitchFamily="34" charset="-128"/>
                 <a:ea typeface="Yu Gothic UI Light" panose="020B0300000000000000" pitchFamily="34" charset="-128"/>
               </a:rPr>
@@ -10889,7 +10720,7 @@
           <p:cNvPr id="17" name="Graphic 3">
             <a:extLst>
               <a:ext uri="{FF2B5EF4-FFF2-40B4-BE49-F238E27FC236}">
-                <a16:creationId xmlns="" xmlns:a16="http://schemas.microsoft.com/office/drawing/2014/main" id="{4AE3E20A-B84B-1636-6212-061E86FF949C}"/>
+                <a16:creationId xmlns:a16="http://schemas.microsoft.com/office/drawing/2014/main" id="{4AE3E20A-B84B-1636-6212-061E86FF949C}"/>
               </a:ext>
             </a:extLst>
           </p:cNvPr>
@@ -10902,7 +10733,7 @@
           <a:blip r:embed="rId3">
             <a:extLst>
               <a:ext uri="{96DAC541-7B7A-43D3-8B79-37D633B846F1}">
-                <asvg:svgBlip xmlns="" xmlns:asvg="http://schemas.microsoft.com/office/drawing/2016/SVG/main" r:embed="rId4"/>
+                <asvg:svgBlip xmlns:asvg="http://schemas.microsoft.com/office/drawing/2016/SVG/main" r:embed="rId4"/>
               </a:ext>
             </a:extLst>
           </a:blip>
@@ -10925,7 +10756,7 @@
           <p:cNvPr id="13" name="TextBox 12">
             <a:extLst>
               <a:ext uri="{FF2B5EF4-FFF2-40B4-BE49-F238E27FC236}">
-                <a16:creationId xmlns="" xmlns:a16="http://schemas.microsoft.com/office/drawing/2014/main" id="{85C4C44A-80AD-0A49-D4B2-61F9E7A66D61}"/>
+                <a16:creationId xmlns:a16="http://schemas.microsoft.com/office/drawing/2014/main" id="{85C4C44A-80AD-0A49-D4B2-61F9E7A66D61}"/>
               </a:ext>
             </a:extLst>
           </p:cNvPr>
@@ -10968,7 +10799,7 @@
           <p:cNvPr id="14" name="TextBox 13">
             <a:extLst>
               <a:ext uri="{FF2B5EF4-FFF2-40B4-BE49-F238E27FC236}">
-                <a16:creationId xmlns="" xmlns:a16="http://schemas.microsoft.com/office/drawing/2014/main" id="{CF78D215-3266-DEC4-9C40-39CD48F034C1}"/>
+                <a16:creationId xmlns:a16="http://schemas.microsoft.com/office/drawing/2014/main" id="{CF78D215-3266-DEC4-9C40-39CD48F034C1}"/>
               </a:ext>
             </a:extLst>
           </p:cNvPr>
@@ -10992,7 +10823,7 @@
           <a:lstStyle/>
           <a:p>
             <a:r>
-              <a:rPr lang="en-GB" dirty="0" smtClean="0">
+              <a:rPr lang="en-GB" dirty="0">
                 <a:latin typeface="Yu Gothic UI Light" panose="020B0300000000000000" pitchFamily="34" charset="-128"/>
                 <a:ea typeface="Yu Gothic UI Light" panose="020B0300000000000000" pitchFamily="34" charset="-128"/>
               </a:rPr>
@@ -11001,25 +10832,11 @@
           </a:p>
           <a:p>
             <a:r>
-              <a:rPr lang="en-US" dirty="0" smtClean="0">
-                <a:latin typeface="Yu Gothic UI Light" panose="020B0300000000000000" pitchFamily="34" charset="-128"/>
-                <a:ea typeface="Yu Gothic UI Light" panose="020B0300000000000000" pitchFamily="34" charset="-128"/>
-              </a:rPr>
-              <a:t>LASSO-selected features backed up by literature and </a:t>
-            </a:r>
-            <a:r>
-              <a:rPr lang="en-US" dirty="0" smtClean="0">
-                <a:latin typeface="Yu Gothic UI Light" panose="020B0300000000000000" pitchFamily="34" charset="-128"/>
-                <a:ea typeface="Yu Gothic UI Light" panose="020B0300000000000000" pitchFamily="34" charset="-128"/>
-              </a:rPr>
-              <a:t>interpretable through </a:t>
-            </a:r>
-            <a:r>
-              <a:rPr lang="en-US" dirty="0" smtClean="0">
-                <a:latin typeface="Yu Gothic UI Light" panose="020B0300000000000000" pitchFamily="34" charset="-128"/>
-                <a:ea typeface="Yu Gothic UI Light" panose="020B0300000000000000" pitchFamily="34" charset="-128"/>
-              </a:rPr>
-              <a:t>SHAP/LIME</a:t>
+              <a:rPr lang="en-US" dirty="0">
+                <a:latin typeface="Yu Gothic UI Light" panose="020B0300000000000000" pitchFamily="34" charset="-128"/>
+                <a:ea typeface="Yu Gothic UI Light" panose="020B0300000000000000" pitchFamily="34" charset="-128"/>
+              </a:rPr>
+              <a:t>LASSO-selected features backed up by literature and interpretable through SHAP/LIME</a:t>
             </a:r>
             <a:endParaRPr lang="x-none" dirty="0">
               <a:latin typeface="Yu Gothic UI Light" panose="020B0300000000000000" pitchFamily="34" charset="-128"/>
@@ -11033,7 +10850,7 @@
           <p:cNvPr id="10" name="Picture 9" descr="A heart with a pulse line in the middle of hands&#10;&#10;AI-generated content may be incorrect.">
             <a:extLst>
               <a:ext uri="{FF2B5EF4-FFF2-40B4-BE49-F238E27FC236}">
-                <a16:creationId xmlns="" xmlns:a16="http://schemas.microsoft.com/office/drawing/2014/main" id="{3FE351CC-FD39-5EFB-891F-28A87EB2FDC9}"/>
+                <a16:creationId xmlns:a16="http://schemas.microsoft.com/office/drawing/2014/main" id="{3FE351CC-FD39-5EFB-891F-28A87EB2FDC9}"/>
               </a:ext>
             </a:extLst>
           </p:cNvPr>
@@ -11074,13 +10891,6 @@
   <p:clrMapOvr>
     <a:masterClrMapping/>
   </p:clrMapOvr>
-  <p:timing>
-    <p:tnLst>
-      <p:par>
-        <p:cTn id="1" dur="indefinite" restart="never" nodeType="tmRoot"/>
-      </p:par>
-    </p:tnLst>
-  </p:timing>
 </p:sld>
 </file>
 
@@ -11117,7 +10927,7 @@
           <p:cNvPr id="2" name="000_topleftHeading">
             <a:extLst>
               <a:ext uri="{FF2B5EF4-FFF2-40B4-BE49-F238E27FC236}">
-                <a16:creationId xmlns="" xmlns:a16="http://schemas.microsoft.com/office/drawing/2014/main" id="{1D13DE1B-4EEE-602A-EBB4-D8092E1FEC05}"/>
+                <a16:creationId xmlns:a16="http://schemas.microsoft.com/office/drawing/2014/main" id="{1D13DE1B-4EEE-602A-EBB4-D8092E1FEC05}"/>
               </a:ext>
             </a:extLst>
           </p:cNvPr>
@@ -11159,7 +10969,7 @@
           <p:cNvPr id="29" name="Group 28">
             <a:extLst>
               <a:ext uri="{FF2B5EF4-FFF2-40B4-BE49-F238E27FC236}">
-                <a16:creationId xmlns="" xmlns:a16="http://schemas.microsoft.com/office/drawing/2014/main" id="{2BC65C69-117B-52D6-BC1E-1900F4CE9108}"/>
+                <a16:creationId xmlns:a16="http://schemas.microsoft.com/office/drawing/2014/main" id="{2BC65C69-117B-52D6-BC1E-1900F4CE9108}"/>
               </a:ext>
             </a:extLst>
           </p:cNvPr>
@@ -11179,7 +10989,7 @@
             <p:cNvPr id="7" name="TextBox 6">
               <a:extLst>
                 <a:ext uri="{FF2B5EF4-FFF2-40B4-BE49-F238E27FC236}">
-                  <a16:creationId xmlns="" xmlns:a16="http://schemas.microsoft.com/office/drawing/2014/main" id="{315B1000-BF76-B41E-EA78-4C1E1FCE9790}"/>
+                  <a16:creationId xmlns:a16="http://schemas.microsoft.com/office/drawing/2014/main" id="{315B1000-BF76-B41E-EA78-4C1E1FCE9790}"/>
                 </a:ext>
               </a:extLst>
             </p:cNvPr>
@@ -11203,7 +11013,7 @@
             <a:lstStyle/>
             <a:p>
               <a:r>
-                <a:rPr lang="en-US" dirty="0" smtClean="0">
+                <a:rPr lang="en-US" dirty="0">
                   <a:latin typeface="Yu Gothic UI Light" panose="020B0300000000000000" pitchFamily="34" charset="-128"/>
                   <a:ea typeface="Yu Gothic UI Light" panose="020B0300000000000000" pitchFamily="34" charset="-128"/>
                 </a:rPr>
@@ -11218,7 +11028,7 @@
             <p:cNvPr id="12" name="Graphic 11">
               <a:extLst>
                 <a:ext uri="{FF2B5EF4-FFF2-40B4-BE49-F238E27FC236}">
-                  <a16:creationId xmlns="" xmlns:a16="http://schemas.microsoft.com/office/drawing/2014/main" id="{3BF297DA-7353-12FC-22E1-9733431A3D8B}"/>
+                  <a16:creationId xmlns:a16="http://schemas.microsoft.com/office/drawing/2014/main" id="{3BF297DA-7353-12FC-22E1-9733431A3D8B}"/>
                 </a:ext>
               </a:extLst>
             </p:cNvPr>
@@ -11231,7 +11041,7 @@
             <a:blip r:embed="rId2">
               <a:extLst>
                 <a:ext uri="{96DAC541-7B7A-43D3-8B79-37D633B846F1}">
-                  <asvg:svgBlip xmlns="" xmlns:asvg="http://schemas.microsoft.com/office/drawing/2016/SVG/main" r:embed="rId3"/>
+                  <asvg:svgBlip xmlns:asvg="http://schemas.microsoft.com/office/drawing/2016/SVG/main" r:embed="rId3"/>
                 </a:ext>
               </a:extLst>
             </a:blip>
@@ -11255,7 +11065,7 @@
           <p:cNvPr id="30" name="Group 29">
             <a:extLst>
               <a:ext uri="{FF2B5EF4-FFF2-40B4-BE49-F238E27FC236}">
-                <a16:creationId xmlns="" xmlns:a16="http://schemas.microsoft.com/office/drawing/2014/main" id="{743B2AF8-896F-2A80-C8B1-8076366E0CC6}"/>
+                <a16:creationId xmlns:a16="http://schemas.microsoft.com/office/drawing/2014/main" id="{743B2AF8-896F-2A80-C8B1-8076366E0CC6}"/>
               </a:ext>
             </a:extLst>
           </p:cNvPr>
@@ -11275,7 +11085,7 @@
             <p:cNvPr id="3" name="TextBox 2">
               <a:extLst>
                 <a:ext uri="{FF2B5EF4-FFF2-40B4-BE49-F238E27FC236}">
-                  <a16:creationId xmlns="" xmlns:a16="http://schemas.microsoft.com/office/drawing/2014/main" id="{A7F286B6-B78D-14E0-8B6F-89149AFBA6E2}"/>
+                  <a16:creationId xmlns:a16="http://schemas.microsoft.com/office/drawing/2014/main" id="{A7F286B6-B78D-14E0-8B6F-89149AFBA6E2}"/>
                 </a:ext>
               </a:extLst>
             </p:cNvPr>
@@ -11299,7 +11109,7 @@
             <a:lstStyle/>
             <a:p>
               <a:r>
-                <a:rPr lang="en-US" dirty="0" smtClean="0">
+                <a:rPr lang="en-US" dirty="0">
                   <a:latin typeface="Yu Gothic UI Light" panose="020B0300000000000000" pitchFamily="34" charset="-128"/>
                   <a:ea typeface="Yu Gothic UI Light" panose="020B0300000000000000" pitchFamily="34" charset="-128"/>
                 </a:rPr>
@@ -11314,7 +11124,7 @@
             <p:cNvPr id="13" name="Graphic 12">
               <a:extLst>
                 <a:ext uri="{FF2B5EF4-FFF2-40B4-BE49-F238E27FC236}">
-                  <a16:creationId xmlns="" xmlns:a16="http://schemas.microsoft.com/office/drawing/2014/main" id="{93DC22A1-E066-6592-9FCA-732E9F98E7BD}"/>
+                  <a16:creationId xmlns:a16="http://schemas.microsoft.com/office/drawing/2014/main" id="{93DC22A1-E066-6592-9FCA-732E9F98E7BD}"/>
                 </a:ext>
               </a:extLst>
             </p:cNvPr>
@@ -11327,7 +11137,7 @@
             <a:blip r:embed="rId4">
               <a:extLst>
                 <a:ext uri="{96DAC541-7B7A-43D3-8B79-37D633B846F1}">
-                  <asvg:svgBlip xmlns="" xmlns:asvg="http://schemas.microsoft.com/office/drawing/2016/SVG/main" r:embed="rId5"/>
+                  <asvg:svgBlip xmlns:asvg="http://schemas.microsoft.com/office/drawing/2016/SVG/main" r:embed="rId5"/>
                 </a:ext>
               </a:extLst>
             </a:blip>
@@ -11351,7 +11161,7 @@
           <p:cNvPr id="27" name="Group 26">
             <a:extLst>
               <a:ext uri="{FF2B5EF4-FFF2-40B4-BE49-F238E27FC236}">
-                <a16:creationId xmlns="" xmlns:a16="http://schemas.microsoft.com/office/drawing/2014/main" id="{A2A59121-0A0E-9D50-458B-307FCBDCBA77}"/>
+                <a16:creationId xmlns:a16="http://schemas.microsoft.com/office/drawing/2014/main" id="{A2A59121-0A0E-9D50-458B-307FCBDCBA77}"/>
               </a:ext>
             </a:extLst>
           </p:cNvPr>
@@ -11371,7 +11181,7 @@
             <p:cNvPr id="11" name="TextBox 10">
               <a:extLst>
                 <a:ext uri="{FF2B5EF4-FFF2-40B4-BE49-F238E27FC236}">
-                  <a16:creationId xmlns="" xmlns:a16="http://schemas.microsoft.com/office/drawing/2014/main" id="{2735E230-C232-7CD6-5A40-DFECC1C7E053}"/>
+                  <a16:creationId xmlns:a16="http://schemas.microsoft.com/office/drawing/2014/main" id="{2735E230-C232-7CD6-5A40-DFECC1C7E053}"/>
                 </a:ext>
               </a:extLst>
             </p:cNvPr>
@@ -11395,7 +11205,7 @@
             <a:lstStyle/>
             <a:p>
               <a:r>
-                <a:rPr lang="en-US" dirty="0" smtClean="0">
+                <a:rPr lang="en-US" dirty="0">
                   <a:latin typeface="Yu Gothic UI Light" panose="020B0300000000000000" pitchFamily="34" charset="-128"/>
                   <a:ea typeface="Yu Gothic UI Light" panose="020B0300000000000000" pitchFamily="34" charset="-128"/>
                 </a:rPr>
@@ -11410,7 +11220,7 @@
             <p:cNvPr id="14" name="Graphic 13">
               <a:extLst>
                 <a:ext uri="{FF2B5EF4-FFF2-40B4-BE49-F238E27FC236}">
-                  <a16:creationId xmlns="" xmlns:a16="http://schemas.microsoft.com/office/drawing/2014/main" id="{9275D7E7-3A07-32F7-AE1E-79DB7E4DC997}"/>
+                  <a16:creationId xmlns:a16="http://schemas.microsoft.com/office/drawing/2014/main" id="{9275D7E7-3A07-32F7-AE1E-79DB7E4DC997}"/>
                 </a:ext>
               </a:extLst>
             </p:cNvPr>
@@ -11423,7 +11233,7 @@
             <a:blip r:embed="rId6">
               <a:extLst>
                 <a:ext uri="{96DAC541-7B7A-43D3-8B79-37D633B846F1}">
-                  <asvg:svgBlip xmlns="" xmlns:asvg="http://schemas.microsoft.com/office/drawing/2016/SVG/main" r:embed="rId7"/>
+                  <asvg:svgBlip xmlns:asvg="http://schemas.microsoft.com/office/drawing/2016/SVG/main" r:embed="rId7"/>
                 </a:ext>
               </a:extLst>
             </a:blip>
@@ -11447,7 +11257,7 @@
           <p:cNvPr id="26" name="Group 25">
             <a:extLst>
               <a:ext uri="{FF2B5EF4-FFF2-40B4-BE49-F238E27FC236}">
-                <a16:creationId xmlns="" xmlns:a16="http://schemas.microsoft.com/office/drawing/2014/main" id="{FF2B3F74-442A-16A2-C3E6-B11EEE2D9652}"/>
+                <a16:creationId xmlns:a16="http://schemas.microsoft.com/office/drawing/2014/main" id="{FF2B3F74-442A-16A2-C3E6-B11EEE2D9652}"/>
               </a:ext>
             </a:extLst>
           </p:cNvPr>
@@ -11467,7 +11277,7 @@
             <p:cNvPr id="9" name="TextBox 8">
               <a:extLst>
                 <a:ext uri="{FF2B5EF4-FFF2-40B4-BE49-F238E27FC236}">
-                  <a16:creationId xmlns="" xmlns:a16="http://schemas.microsoft.com/office/drawing/2014/main" id="{854F3205-9763-CF0C-1D1A-34FEEE9AC886}"/>
+                  <a16:creationId xmlns:a16="http://schemas.microsoft.com/office/drawing/2014/main" id="{854F3205-9763-CF0C-1D1A-34FEEE9AC886}"/>
                 </a:ext>
               </a:extLst>
             </p:cNvPr>
@@ -11491,7 +11301,7 @@
             <a:lstStyle/>
             <a:p>
               <a:r>
-                <a:rPr lang="en-US" dirty="0" smtClean="0">
+                <a:rPr lang="en-US" dirty="0">
                   <a:latin typeface="Yu Gothic UI Light" panose="020B0300000000000000" pitchFamily="34" charset="-128"/>
                   <a:ea typeface="Yu Gothic UI Light" panose="020B0300000000000000" pitchFamily="34" charset="-128"/>
                 </a:rPr>
@@ -11506,7 +11316,7 @@
             <p:cNvPr id="22" name="Graphic 21">
               <a:extLst>
                 <a:ext uri="{FF2B5EF4-FFF2-40B4-BE49-F238E27FC236}">
-                  <a16:creationId xmlns="" xmlns:a16="http://schemas.microsoft.com/office/drawing/2014/main" id="{70EEA702-97FD-17BF-420A-60F0D92AA2D7}"/>
+                  <a16:creationId xmlns:a16="http://schemas.microsoft.com/office/drawing/2014/main" id="{70EEA702-97FD-17BF-420A-60F0D92AA2D7}"/>
                 </a:ext>
               </a:extLst>
             </p:cNvPr>
@@ -11519,7 +11329,7 @@
             <a:blip r:embed="rId8">
               <a:extLst>
                 <a:ext uri="{96DAC541-7B7A-43D3-8B79-37D633B846F1}">
-                  <asvg:svgBlip xmlns="" xmlns:asvg="http://schemas.microsoft.com/office/drawing/2016/SVG/main" r:embed="rId9"/>
+                  <asvg:svgBlip xmlns:asvg="http://schemas.microsoft.com/office/drawing/2016/SVG/main" r:embed="rId9"/>
                 </a:ext>
               </a:extLst>
             </a:blip>
@@ -11543,7 +11353,7 @@
           <p:cNvPr id="28" name="Group 27">
             <a:extLst>
               <a:ext uri="{FF2B5EF4-FFF2-40B4-BE49-F238E27FC236}">
-                <a16:creationId xmlns="" xmlns:a16="http://schemas.microsoft.com/office/drawing/2014/main" id="{BB16C64E-29B8-0A3D-9BE8-DA2D72721E1B}"/>
+                <a16:creationId xmlns:a16="http://schemas.microsoft.com/office/drawing/2014/main" id="{BB16C64E-29B8-0A3D-9BE8-DA2D72721E1B}"/>
               </a:ext>
             </a:extLst>
           </p:cNvPr>
@@ -11563,7 +11373,7 @@
             <p:cNvPr id="5" name="TextBox 4">
               <a:extLst>
                 <a:ext uri="{FF2B5EF4-FFF2-40B4-BE49-F238E27FC236}">
-                  <a16:creationId xmlns="" xmlns:a16="http://schemas.microsoft.com/office/drawing/2014/main" id="{A3FE0719-8C40-98EB-48A7-F837A7D651C3}"/>
+                  <a16:creationId xmlns:a16="http://schemas.microsoft.com/office/drawing/2014/main" id="{A3FE0719-8C40-98EB-48A7-F837A7D651C3}"/>
                 </a:ext>
               </a:extLst>
             </p:cNvPr>
@@ -11587,16 +11397,12 @@
             <a:lstStyle/>
             <a:p>
               <a:r>
-                <a:rPr lang="en-US" dirty="0" smtClean="0">
+                <a:rPr lang="en-US" dirty="0">
                   <a:latin typeface="Yu Gothic UI Light" panose="020B0300000000000000" pitchFamily="34" charset="-128"/>
                   <a:ea typeface="Yu Gothic UI Light" panose="020B0300000000000000" pitchFamily="34" charset="-128"/>
                 </a:rPr>
                 <a:t>Introduction and objective</a:t>
               </a:r>
-              <a:endParaRPr lang="en-US" dirty="0">
-                <a:latin typeface="Yu Gothic UI Light" panose="020B0300000000000000" pitchFamily="34" charset="-128"/>
-                <a:ea typeface="Yu Gothic UI Light" panose="020B0300000000000000" pitchFamily="34" charset="-128"/>
-              </a:endParaRPr>
             </a:p>
           </p:txBody>
         </p:sp>
@@ -11605,7 +11411,7 @@
             <p:cNvPr id="25" name="Graphic 24">
               <a:extLst>
                 <a:ext uri="{FF2B5EF4-FFF2-40B4-BE49-F238E27FC236}">
-                  <a16:creationId xmlns="" xmlns:a16="http://schemas.microsoft.com/office/drawing/2014/main" id="{6802C625-8F4D-E911-D540-8E70FCCE6FAF}"/>
+                  <a16:creationId xmlns:a16="http://schemas.microsoft.com/office/drawing/2014/main" id="{6802C625-8F4D-E911-D540-8E70FCCE6FAF}"/>
                 </a:ext>
               </a:extLst>
             </p:cNvPr>
@@ -11618,7 +11424,7 @@
             <a:blip r:embed="rId10">
               <a:extLst>
                 <a:ext uri="{96DAC541-7B7A-43D3-8B79-37D633B846F1}">
-                  <asvg:svgBlip xmlns="" xmlns:asvg="http://schemas.microsoft.com/office/drawing/2016/SVG/main" r:embed="rId11"/>
+                  <asvg:svgBlip xmlns:asvg="http://schemas.microsoft.com/office/drawing/2016/SVG/main" r:embed="rId11"/>
                 </a:ext>
               </a:extLst>
             </a:blip>
@@ -11642,7 +11448,7 @@
           <p:cNvPr id="18" name="Graphic 11">
             <a:extLst>
               <a:ext uri="{FF2B5EF4-FFF2-40B4-BE49-F238E27FC236}">
-                <a16:creationId xmlns="" xmlns:a16="http://schemas.microsoft.com/office/drawing/2014/main" id="{51FE1894-2C86-4687-B1B9-8541E0A12D03}"/>
+                <a16:creationId xmlns:a16="http://schemas.microsoft.com/office/drawing/2014/main" id="{51FE1894-2C86-4687-B1B9-8541E0A12D03}"/>
               </a:ext>
             </a:extLst>
           </p:cNvPr>
@@ -11655,7 +11461,7 @@
           <a:blip r:embed="rId10">
             <a:extLst>
               <a:ext uri="{96DAC541-7B7A-43D3-8B79-37D633B846F1}">
-                <asvg:svgBlip xmlns="" xmlns:asvg="http://schemas.microsoft.com/office/drawing/2016/SVG/main" r:embed="rId12"/>
+                <asvg:svgBlip xmlns:asvg="http://schemas.microsoft.com/office/drawing/2016/SVG/main" r:embed="rId11"/>
               </a:ext>
             </a:extLst>
           </a:blip>
@@ -11683,13 +11489,6 @@
   <p:clrMapOvr>
     <a:masterClrMapping/>
   </p:clrMapOvr>
-  <p:timing>
-    <p:tnLst>
-      <p:par>
-        <p:cTn id="1" dur="indefinite" restart="never" nodeType="tmRoot"/>
-      </p:par>
-    </p:tnLst>
-  </p:timing>
 </p:sld>
 </file>
 
@@ -11712,7 +11511,7 @@
         <p:cNvPr id="1" name="">
           <a:extLst>
             <a:ext uri="{FF2B5EF4-FFF2-40B4-BE49-F238E27FC236}">
-              <a16:creationId xmlns="" xmlns:a16="http://schemas.microsoft.com/office/drawing/2014/main" id="{1128BB88-8665-F5FE-F35A-D89FFA2BFFB5}"/>
+              <a16:creationId xmlns:a16="http://schemas.microsoft.com/office/drawing/2014/main" id="{1128BB88-8665-F5FE-F35A-D89FFA2BFFB5}"/>
             </a:ext>
           </a:extLst>
         </p:cNvPr>
@@ -11732,7 +11531,7 @@
           <p:cNvPr id="3" name="TextBox 2">
             <a:extLst>
               <a:ext uri="{FF2B5EF4-FFF2-40B4-BE49-F238E27FC236}">
-                <a16:creationId xmlns="" xmlns:a16="http://schemas.microsoft.com/office/drawing/2014/main" id="{C5CEF2F7-993F-4108-A12C-688C9F6D8F64}"/>
+                <a16:creationId xmlns:a16="http://schemas.microsoft.com/office/drawing/2014/main" id="{C5CEF2F7-993F-4108-A12C-688C9F6D8F64}"/>
               </a:ext>
             </a:extLst>
           </p:cNvPr>
@@ -11792,7 +11591,7 @@
           <p:cNvPr id="8" name="TextBox 7">
             <a:extLst>
               <a:ext uri="{FF2B5EF4-FFF2-40B4-BE49-F238E27FC236}">
-                <a16:creationId xmlns="" xmlns:a16="http://schemas.microsoft.com/office/drawing/2014/main" id="{B21F9A73-2B8E-D748-BE37-060DC98B40AA}"/>
+                <a16:creationId xmlns:a16="http://schemas.microsoft.com/office/drawing/2014/main" id="{B21F9A73-2B8E-D748-BE37-060DC98B40AA}"/>
               </a:ext>
             </a:extLst>
           </p:cNvPr>
@@ -11990,13 +11789,6 @@
   <p:clrMapOvr>
     <a:masterClrMapping/>
   </p:clrMapOvr>
-  <p:timing>
-    <p:tnLst>
-      <p:par>
-        <p:cTn id="1" dur="indefinite" restart="never" nodeType="tmRoot"/>
-      </p:par>
-    </p:tnLst>
-  </p:timing>
 </p:sld>
 </file>
 
@@ -12019,7 +11811,7 @@
         <p:cNvPr id="1" name="">
           <a:extLst>
             <a:ext uri="{FF2B5EF4-FFF2-40B4-BE49-F238E27FC236}">
-              <a16:creationId xmlns="" xmlns:a16="http://schemas.microsoft.com/office/drawing/2014/main" id="{B87164C2-D41C-2FCA-1008-ABBA3B51CFEE}"/>
+              <a16:creationId xmlns:a16="http://schemas.microsoft.com/office/drawing/2014/main" id="{B87164C2-D41C-2FCA-1008-ABBA3B51CFEE}"/>
             </a:ext>
           </a:extLst>
         </p:cNvPr>
@@ -12039,7 +11831,7 @@
           <p:cNvPr id="4" name="000_topleftHeading">
             <a:extLst>
               <a:ext uri="{FF2B5EF4-FFF2-40B4-BE49-F238E27FC236}">
-                <a16:creationId xmlns="" xmlns:a16="http://schemas.microsoft.com/office/drawing/2014/main" id="{48EE58FE-C40D-220C-5D97-06350A15A19D}"/>
+                <a16:creationId xmlns:a16="http://schemas.microsoft.com/office/drawing/2014/main" id="{48EE58FE-C40D-220C-5D97-06350A15A19D}"/>
               </a:ext>
             </a:extLst>
           </p:cNvPr>
@@ -12063,7 +11855,7 @@
           <a:lstStyle/>
           <a:p>
             <a:r>
-              <a:rPr lang="en-US" dirty="0" smtClean="0">
+              <a:rPr lang="en-US" dirty="0">
                 <a:latin typeface="Yu Gothic UI Light" panose="020B0300000000000000" pitchFamily="34" charset="-128"/>
                 <a:ea typeface="Yu Gothic UI Light" panose="020B0300000000000000" pitchFamily="34" charset="-128"/>
               </a:rPr>
@@ -12081,7 +11873,7 @@
           <p:cNvPr id="13" name="001_subtitle">
             <a:extLst>
               <a:ext uri="{FF2B5EF4-FFF2-40B4-BE49-F238E27FC236}">
-                <a16:creationId xmlns="" xmlns:a16="http://schemas.microsoft.com/office/drawing/2014/main" id="{C03F2CE7-378E-A3F7-6650-39236EFA3435}"/>
+                <a16:creationId xmlns:a16="http://schemas.microsoft.com/office/drawing/2014/main" id="{C03F2CE7-378E-A3F7-6650-39236EFA3435}"/>
               </a:ext>
             </a:extLst>
           </p:cNvPr>
@@ -12109,14 +11901,7 @@
                 <a:latin typeface="Yu Gothic UI Light" panose="020B0300000000000000" pitchFamily="34" charset="-128"/>
                 <a:ea typeface="Yu Gothic UI Light" panose="020B0300000000000000" pitchFamily="34" charset="-128"/>
               </a:rPr>
-              <a:t>TNBC o</a:t>
-            </a:r>
-            <a:r>
-              <a:rPr lang="en-US" dirty="0" smtClean="0">
-                <a:latin typeface="Yu Gothic UI Light" panose="020B0300000000000000" pitchFamily="34" charset="-128"/>
-                <a:ea typeface="Yu Gothic UI Light" panose="020B0300000000000000" pitchFamily="34" charset="-128"/>
-              </a:rPr>
-              <a:t>verview</a:t>
+              <a:t>TNBC overview</a:t>
             </a:r>
             <a:endParaRPr lang="x-none" dirty="0">
               <a:latin typeface="Yu Gothic UI Light" panose="020B0300000000000000" pitchFamily="34" charset="-128"/>
@@ -12130,7 +11915,7 @@
           <p:cNvPr id="6" name="Picture 5">
             <a:extLst>
               <a:ext uri="{FF2B5EF4-FFF2-40B4-BE49-F238E27FC236}">
-                <a16:creationId xmlns="" xmlns:a16="http://schemas.microsoft.com/office/drawing/2014/main" id="{457C985D-0930-CBD2-22E1-D3DFD2C2B25C}"/>
+                <a16:creationId xmlns:a16="http://schemas.microsoft.com/office/drawing/2014/main" id="{457C985D-0930-CBD2-22E1-D3DFD2C2B25C}"/>
               </a:ext>
             </a:extLst>
           </p:cNvPr>
@@ -12160,7 +11945,7 @@
           <p:cNvPr id="7" name="TextBox 6">
             <a:extLst>
               <a:ext uri="{FF2B5EF4-FFF2-40B4-BE49-F238E27FC236}">
-                <a16:creationId xmlns="" xmlns:a16="http://schemas.microsoft.com/office/drawing/2014/main" id="{CD8A7F9D-5F87-BFE2-BF4F-D508712969E7}"/>
+                <a16:creationId xmlns:a16="http://schemas.microsoft.com/office/drawing/2014/main" id="{CD8A7F9D-5F87-BFE2-BF4F-D508712969E7}"/>
               </a:ext>
             </a:extLst>
           </p:cNvPr>
@@ -12185,18 +11970,11 @@
           <a:p>
             <a:pPr algn="ctr"/>
             <a:r>
-              <a:rPr lang="en-US" dirty="0" smtClean="0">
-                <a:latin typeface="Yu Gothic UI Light" panose="020B0300000000000000" pitchFamily="34" charset="-128"/>
-                <a:ea typeface="Yu Gothic UI Light" panose="020B0300000000000000" pitchFamily="34" charset="-128"/>
-              </a:rPr>
-              <a:t>2.3 million </a:t>
-            </a:r>
-            <a:r>
               <a:rPr lang="en-US" dirty="0">
                 <a:latin typeface="Yu Gothic UI Light" panose="020B0300000000000000" pitchFamily="34" charset="-128"/>
                 <a:ea typeface="Yu Gothic UI Light" panose="020B0300000000000000" pitchFamily="34" charset="-128"/>
               </a:rPr>
-              <a:t>cases of breast cancer worldwide in 2022</a:t>
+              <a:t>2.3 million cases of breast cancer worldwide in 2022</a:t>
             </a:r>
             <a:endParaRPr lang="x-none" dirty="0">
               <a:latin typeface="Yu Gothic UI Light" panose="020B0300000000000000" pitchFamily="34" charset="-128"/>
@@ -12210,7 +11988,7 @@
           <p:cNvPr id="9" name="Picture 8">
             <a:extLst>
               <a:ext uri="{FF2B5EF4-FFF2-40B4-BE49-F238E27FC236}">
-                <a16:creationId xmlns="" xmlns:a16="http://schemas.microsoft.com/office/drawing/2014/main" id="{6D22F24C-92AB-A244-CD81-F4FC64AB4726}"/>
+                <a16:creationId xmlns:a16="http://schemas.microsoft.com/office/drawing/2014/main" id="{6D22F24C-92AB-A244-CD81-F4FC64AB4726}"/>
               </a:ext>
             </a:extLst>
           </p:cNvPr>
@@ -12240,7 +12018,7 @@
           <p:cNvPr id="21" name="TextBox 20">
             <a:extLst>
               <a:ext uri="{FF2B5EF4-FFF2-40B4-BE49-F238E27FC236}">
-                <a16:creationId xmlns="" xmlns:a16="http://schemas.microsoft.com/office/drawing/2014/main" id="{D6D8C3A3-AE04-C9DB-6446-E6AE4C74380F}"/>
+                <a16:creationId xmlns:a16="http://schemas.microsoft.com/office/drawing/2014/main" id="{D6D8C3A3-AE04-C9DB-6446-E6AE4C74380F}"/>
               </a:ext>
             </a:extLst>
           </p:cNvPr>
@@ -12282,7 +12060,7 @@
           <p:cNvPr id="22" name="TextBox 21">
             <a:extLst>
               <a:ext uri="{FF2B5EF4-FFF2-40B4-BE49-F238E27FC236}">
-                <a16:creationId xmlns="" xmlns:a16="http://schemas.microsoft.com/office/drawing/2014/main" id="{DD83068B-957B-A284-CE08-9DC3B5EDF18B}"/>
+                <a16:creationId xmlns:a16="http://schemas.microsoft.com/office/drawing/2014/main" id="{DD83068B-957B-A284-CE08-9DC3B5EDF18B}"/>
               </a:ext>
             </a:extLst>
           </p:cNvPr>
@@ -12324,7 +12102,7 @@
           <p:cNvPr id="23" name="TextBox 22">
             <a:extLst>
               <a:ext uri="{FF2B5EF4-FFF2-40B4-BE49-F238E27FC236}">
-                <a16:creationId xmlns="" xmlns:a16="http://schemas.microsoft.com/office/drawing/2014/main" id="{9D5A2168-842E-B78F-743D-7F6039984B10}"/>
+                <a16:creationId xmlns:a16="http://schemas.microsoft.com/office/drawing/2014/main" id="{9D5A2168-842E-B78F-743D-7F6039984B10}"/>
               </a:ext>
             </a:extLst>
           </p:cNvPr>
@@ -12348,18 +12126,11 @@
           <a:lstStyle/>
           <a:p>
             <a:r>
-              <a:rPr lang="en-US" dirty="0" smtClean="0">
-                <a:latin typeface="Yu Gothic UI Light" panose="020B0300000000000000" pitchFamily="34" charset="-128"/>
-                <a:ea typeface="Yu Gothic UI Light" panose="020B0300000000000000" pitchFamily="34" charset="-128"/>
-              </a:rPr>
-              <a:t>PR </a:t>
-            </a:r>
-            <a:r>
               <a:rPr lang="en-US" dirty="0">
                 <a:latin typeface="Yu Gothic UI Light" panose="020B0300000000000000" pitchFamily="34" charset="-128"/>
                 <a:ea typeface="Yu Gothic UI Light" panose="020B0300000000000000" pitchFamily="34" charset="-128"/>
               </a:rPr>
-              <a:t>(PGR)</a:t>
+              <a:t>PR (PGR)</a:t>
             </a:r>
             <a:endParaRPr lang="x-none" dirty="0">
               <a:latin typeface="Yu Gothic UI Light" panose="020B0300000000000000" pitchFamily="34" charset="-128"/>
@@ -12373,7 +12144,7 @@
           <p:cNvPr id="2" name="TextBox 1">
             <a:extLst>
               <a:ext uri="{FF2B5EF4-FFF2-40B4-BE49-F238E27FC236}">
-                <a16:creationId xmlns="" xmlns:a16="http://schemas.microsoft.com/office/drawing/2014/main" id="{B9C3F6F5-2B3D-20FF-7F25-4678F946C9B1}"/>
+                <a16:creationId xmlns:a16="http://schemas.microsoft.com/office/drawing/2014/main" id="{B9C3F6F5-2B3D-20FF-7F25-4678F946C9B1}"/>
               </a:ext>
             </a:extLst>
           </p:cNvPr>
@@ -12416,7 +12187,7 @@
           <p:cNvPr id="5" name="Picture 4">
             <a:extLst>
               <a:ext uri="{FF2B5EF4-FFF2-40B4-BE49-F238E27FC236}">
-                <a16:creationId xmlns="" xmlns:a16="http://schemas.microsoft.com/office/drawing/2014/main" id="{78D2D0A0-6BFF-9CEB-B877-2E4DBDE4D7CB}"/>
+                <a16:creationId xmlns:a16="http://schemas.microsoft.com/office/drawing/2014/main" id="{78D2D0A0-6BFF-9CEB-B877-2E4DBDE4D7CB}"/>
               </a:ext>
             </a:extLst>
           </p:cNvPr>
@@ -12446,7 +12217,7 @@
           <p:cNvPr id="10" name="Picture 9">
             <a:extLst>
               <a:ext uri="{FF2B5EF4-FFF2-40B4-BE49-F238E27FC236}">
-                <a16:creationId xmlns="" xmlns:a16="http://schemas.microsoft.com/office/drawing/2014/main" id="{EC2FFC4F-61A3-5B8F-94FB-24EB841434A2}"/>
+                <a16:creationId xmlns:a16="http://schemas.microsoft.com/office/drawing/2014/main" id="{EC2FFC4F-61A3-5B8F-94FB-24EB841434A2}"/>
               </a:ext>
             </a:extLst>
           </p:cNvPr>
@@ -12476,7 +12247,7 @@
           <p:cNvPr id="14" name="Picture 13">
             <a:extLst>
               <a:ext uri="{FF2B5EF4-FFF2-40B4-BE49-F238E27FC236}">
-                <a16:creationId xmlns="" xmlns:a16="http://schemas.microsoft.com/office/drawing/2014/main" id="{D3B4051F-A01B-4EE2-AD4E-F303C1E88E0A}"/>
+                <a16:creationId xmlns:a16="http://schemas.microsoft.com/office/drawing/2014/main" id="{D3B4051F-A01B-4EE2-AD4E-F303C1E88E0A}"/>
               </a:ext>
             </a:extLst>
           </p:cNvPr>
@@ -12506,7 +12277,7 @@
           <p:cNvPr id="16" name="TextBox 15">
             <a:extLst>
               <a:ext uri="{FF2B5EF4-FFF2-40B4-BE49-F238E27FC236}">
-                <a16:creationId xmlns="" xmlns:a16="http://schemas.microsoft.com/office/drawing/2014/main" id="{98FE7D55-CFF1-79C2-5AFB-8F788B855B10}"/>
+                <a16:creationId xmlns:a16="http://schemas.microsoft.com/office/drawing/2014/main" id="{98FE7D55-CFF1-79C2-5AFB-8F788B855B10}"/>
               </a:ext>
             </a:extLst>
           </p:cNvPr>
@@ -12558,7 +12329,7 @@
           <p:cNvPr id="18" name="TextBox 17">
             <a:extLst>
               <a:ext uri="{FF2B5EF4-FFF2-40B4-BE49-F238E27FC236}">
-                <a16:creationId xmlns="" xmlns:a16="http://schemas.microsoft.com/office/drawing/2014/main" id="{4D432AF5-4A2E-B1E0-5BC3-97CFC52D8BDD}"/>
+                <a16:creationId xmlns:a16="http://schemas.microsoft.com/office/drawing/2014/main" id="{4D432AF5-4A2E-B1E0-5BC3-97CFC52D8BDD}"/>
               </a:ext>
             </a:extLst>
           </p:cNvPr>
@@ -12597,7 +12368,7 @@
           <p:cNvPr id="20" name="Picture 19">
             <a:extLst>
               <a:ext uri="{FF2B5EF4-FFF2-40B4-BE49-F238E27FC236}">
-                <a16:creationId xmlns="" xmlns:a16="http://schemas.microsoft.com/office/drawing/2014/main" id="{085BEDD4-1EAF-8971-21BA-52B2B42BAB84}"/>
+                <a16:creationId xmlns:a16="http://schemas.microsoft.com/office/drawing/2014/main" id="{085BEDD4-1EAF-8971-21BA-52B2B42BAB84}"/>
               </a:ext>
             </a:extLst>
           </p:cNvPr>
@@ -12627,7 +12398,7 @@
           <p:cNvPr id="24" name="Picture 23">
             <a:extLst>
               <a:ext uri="{FF2B5EF4-FFF2-40B4-BE49-F238E27FC236}">
-                <a16:creationId xmlns="" xmlns:a16="http://schemas.microsoft.com/office/drawing/2014/main" id="{0BCE0AE4-3AD8-821D-5E7E-0523305AEF52}"/>
+                <a16:creationId xmlns:a16="http://schemas.microsoft.com/office/drawing/2014/main" id="{0BCE0AE4-3AD8-821D-5E7E-0523305AEF52}"/>
               </a:ext>
             </a:extLst>
           </p:cNvPr>
@@ -12657,7 +12428,7 @@
           <p:cNvPr id="25" name="Picture 24">
             <a:extLst>
               <a:ext uri="{FF2B5EF4-FFF2-40B4-BE49-F238E27FC236}">
-                <a16:creationId xmlns="" xmlns:a16="http://schemas.microsoft.com/office/drawing/2014/main" id="{6892F983-C8B7-5155-483E-864F74306E6C}"/>
+                <a16:creationId xmlns:a16="http://schemas.microsoft.com/office/drawing/2014/main" id="{6892F983-C8B7-5155-483E-864F74306E6C}"/>
               </a:ext>
             </a:extLst>
           </p:cNvPr>
@@ -12687,7 +12458,7 @@
           <p:cNvPr id="26" name="Picture 25">
             <a:extLst>
               <a:ext uri="{FF2B5EF4-FFF2-40B4-BE49-F238E27FC236}">
-                <a16:creationId xmlns="" xmlns:a16="http://schemas.microsoft.com/office/drawing/2014/main" id="{C4D724D3-3F46-F6B2-2095-82D851E38BE5}"/>
+                <a16:creationId xmlns:a16="http://schemas.microsoft.com/office/drawing/2014/main" id="{C4D724D3-3F46-F6B2-2095-82D851E38BE5}"/>
               </a:ext>
             </a:extLst>
           </p:cNvPr>
@@ -12717,7 +12488,7 @@
           <p:cNvPr id="27" name="Picture 26">
             <a:extLst>
               <a:ext uri="{FF2B5EF4-FFF2-40B4-BE49-F238E27FC236}">
-                <a16:creationId xmlns="" xmlns:a16="http://schemas.microsoft.com/office/drawing/2014/main" id="{D2398007-7F32-8F28-853A-66818E3FE7A4}"/>
+                <a16:creationId xmlns:a16="http://schemas.microsoft.com/office/drawing/2014/main" id="{D2398007-7F32-8F28-853A-66818E3FE7A4}"/>
               </a:ext>
             </a:extLst>
           </p:cNvPr>
@@ -12747,7 +12518,7 @@
           <p:cNvPr id="28" name="Picture 27">
             <a:extLst>
               <a:ext uri="{FF2B5EF4-FFF2-40B4-BE49-F238E27FC236}">
-                <a16:creationId xmlns="" xmlns:a16="http://schemas.microsoft.com/office/drawing/2014/main" id="{D7DB3654-0E46-0362-794B-B14B26F343A2}"/>
+                <a16:creationId xmlns:a16="http://schemas.microsoft.com/office/drawing/2014/main" id="{D7DB3654-0E46-0362-794B-B14B26F343A2}"/>
               </a:ext>
             </a:extLst>
           </p:cNvPr>
@@ -12777,7 +12548,7 @@
           <p:cNvPr id="30" name="Picture 29">
             <a:extLst>
               <a:ext uri="{FF2B5EF4-FFF2-40B4-BE49-F238E27FC236}">
-                <a16:creationId xmlns="" xmlns:a16="http://schemas.microsoft.com/office/drawing/2014/main" id="{4C97E7D4-E4A0-6900-5D94-C4D3D2BA8CF6}"/>
+                <a16:creationId xmlns:a16="http://schemas.microsoft.com/office/drawing/2014/main" id="{4C97E7D4-E4A0-6900-5D94-C4D3D2BA8CF6}"/>
               </a:ext>
             </a:extLst>
           </p:cNvPr>
@@ -12807,7 +12578,7 @@
           <p:cNvPr id="31" name="Picture 30">
             <a:extLst>
               <a:ext uri="{FF2B5EF4-FFF2-40B4-BE49-F238E27FC236}">
-                <a16:creationId xmlns="" xmlns:a16="http://schemas.microsoft.com/office/drawing/2014/main" id="{A1762CEA-A5CE-BFA1-C5CE-03B9C4D96A61}"/>
+                <a16:creationId xmlns:a16="http://schemas.microsoft.com/office/drawing/2014/main" id="{A1762CEA-A5CE-BFA1-C5CE-03B9C4D96A61}"/>
               </a:ext>
             </a:extLst>
           </p:cNvPr>
@@ -12837,7 +12608,7 @@
           <p:cNvPr id="32" name="Picture 31">
             <a:extLst>
               <a:ext uri="{FF2B5EF4-FFF2-40B4-BE49-F238E27FC236}">
-                <a16:creationId xmlns="" xmlns:a16="http://schemas.microsoft.com/office/drawing/2014/main" id="{9BCAB659-615E-AB3A-C1AC-404D38C2DC9B}"/>
+                <a16:creationId xmlns:a16="http://schemas.microsoft.com/office/drawing/2014/main" id="{9BCAB659-615E-AB3A-C1AC-404D38C2DC9B}"/>
               </a:ext>
             </a:extLst>
           </p:cNvPr>
@@ -12867,7 +12638,7 @@
           <p:cNvPr id="33" name="TextBox 32">
             <a:extLst>
               <a:ext uri="{FF2B5EF4-FFF2-40B4-BE49-F238E27FC236}">
-                <a16:creationId xmlns="" xmlns:a16="http://schemas.microsoft.com/office/drawing/2014/main" id="{B95DE2EE-FD79-0475-E838-DD0A6DB16FFF}"/>
+                <a16:creationId xmlns:a16="http://schemas.microsoft.com/office/drawing/2014/main" id="{B95DE2EE-FD79-0475-E838-DD0A6DB16FFF}"/>
               </a:ext>
             </a:extLst>
           </p:cNvPr>
@@ -12909,7 +12680,7 @@
           <p:cNvPr id="34" name="TextBox 33">
             <a:extLst>
               <a:ext uri="{FF2B5EF4-FFF2-40B4-BE49-F238E27FC236}">
-                <a16:creationId xmlns="" xmlns:a16="http://schemas.microsoft.com/office/drawing/2014/main" id="{1344BA10-1561-C0AD-79BB-2F31DABE354A}"/>
+                <a16:creationId xmlns:a16="http://schemas.microsoft.com/office/drawing/2014/main" id="{1344BA10-1561-C0AD-79BB-2F31DABE354A}"/>
               </a:ext>
             </a:extLst>
           </p:cNvPr>
@@ -12951,7 +12722,7 @@
           <p:cNvPr id="35" name="TextBox 34">
             <a:extLst>
               <a:ext uri="{FF2B5EF4-FFF2-40B4-BE49-F238E27FC236}">
-                <a16:creationId xmlns="" xmlns:a16="http://schemas.microsoft.com/office/drawing/2014/main" id="{203585AE-0AF2-BE48-BB06-3F3CD804BA87}"/>
+                <a16:creationId xmlns:a16="http://schemas.microsoft.com/office/drawing/2014/main" id="{203585AE-0AF2-BE48-BB06-3F3CD804BA87}"/>
               </a:ext>
             </a:extLst>
           </p:cNvPr>
@@ -12993,7 +12764,7 @@
           <p:cNvPr id="3" name="TextBox 2">
             <a:extLst>
               <a:ext uri="{FF2B5EF4-FFF2-40B4-BE49-F238E27FC236}">
-                <a16:creationId xmlns="" xmlns:a16="http://schemas.microsoft.com/office/drawing/2014/main" id="{A0FF0C68-E75F-4023-6ED4-DC4AF3C7F513}"/>
+                <a16:creationId xmlns:a16="http://schemas.microsoft.com/office/drawing/2014/main" id="{A0FF0C68-E75F-4023-6ED4-DC4AF3C7F513}"/>
               </a:ext>
             </a:extLst>
           </p:cNvPr>
@@ -13046,7 +12817,7 @@
           <p:cNvPr id="8" name="TextBox 7">
             <a:extLst>
               <a:ext uri="{FF2B5EF4-FFF2-40B4-BE49-F238E27FC236}">
-                <a16:creationId xmlns="" xmlns:a16="http://schemas.microsoft.com/office/drawing/2014/main" id="{458292D9-A17F-67BB-C1EF-57C47F32A03A}"/>
+                <a16:creationId xmlns:a16="http://schemas.microsoft.com/office/drawing/2014/main" id="{458292D9-A17F-67BB-C1EF-57C47F32A03A}"/>
               </a:ext>
             </a:extLst>
           </p:cNvPr>
@@ -13089,7 +12860,7 @@
           <p:cNvPr id="37" name="Graphic 11">
             <a:extLst>
               <a:ext uri="{FF2B5EF4-FFF2-40B4-BE49-F238E27FC236}">
-                <a16:creationId xmlns="" xmlns:a16="http://schemas.microsoft.com/office/drawing/2014/main" id="{51FE1894-2C86-4687-B1B9-8541E0A12D03}"/>
+                <a16:creationId xmlns:a16="http://schemas.microsoft.com/office/drawing/2014/main" id="{51FE1894-2C86-4687-B1B9-8541E0A12D03}"/>
               </a:ext>
             </a:extLst>
           </p:cNvPr>
@@ -13102,7 +12873,7 @@
           <a:blip r:embed="rId9">
             <a:extLst>
               <a:ext uri="{96DAC541-7B7A-43D3-8B79-37D633B846F1}">
-                <asvg:svgBlip xmlns="" xmlns:asvg="http://schemas.microsoft.com/office/drawing/2016/SVG/main" r:embed="rId10"/>
+                <asvg:svgBlip xmlns:asvg="http://schemas.microsoft.com/office/drawing/2016/SVG/main" r:embed="rId10"/>
               </a:ext>
             </a:extLst>
           </a:blip>
@@ -13130,13 +12901,6 @@
   <p:clrMapOvr>
     <a:masterClrMapping/>
   </p:clrMapOvr>
-  <p:timing>
-    <p:tnLst>
-      <p:par>
-        <p:cTn id="1" dur="indefinite" restart="never" nodeType="tmRoot"/>
-      </p:par>
-    </p:tnLst>
-  </p:timing>
 </p:sld>
 </file>
 
@@ -13159,7 +12923,7 @@
         <p:cNvPr id="1" name="">
           <a:extLst>
             <a:ext uri="{FF2B5EF4-FFF2-40B4-BE49-F238E27FC236}">
-              <a16:creationId xmlns="" xmlns:a16="http://schemas.microsoft.com/office/drawing/2014/main" id="{86F24FA8-7EFA-8FC5-EF0B-0C36D1C34732}"/>
+              <a16:creationId xmlns:a16="http://schemas.microsoft.com/office/drawing/2014/main" id="{86F24FA8-7EFA-8FC5-EF0B-0C36D1C34732}"/>
             </a:ext>
           </a:extLst>
         </p:cNvPr>
@@ -13179,7 +12943,7 @@
           <p:cNvPr id="3" name="Group 2">
             <a:extLst>
               <a:ext uri="{FF2B5EF4-FFF2-40B4-BE49-F238E27FC236}">
-                <a16:creationId xmlns="" xmlns:a16="http://schemas.microsoft.com/office/drawing/2014/main" id="{437A8F56-C73E-3B6A-1A23-D36D2B7DC000}"/>
+                <a16:creationId xmlns:a16="http://schemas.microsoft.com/office/drawing/2014/main" id="{437A8F56-C73E-3B6A-1A23-D36D2B7DC000}"/>
               </a:ext>
             </a:extLst>
           </p:cNvPr>
@@ -13199,7 +12963,7 @@
             <p:cNvPr id="5" name="Rectangle 4">
               <a:extLst>
                 <a:ext uri="{FF2B5EF4-FFF2-40B4-BE49-F238E27FC236}">
-                  <a16:creationId xmlns="" xmlns:a16="http://schemas.microsoft.com/office/drawing/2014/main" id="{DCB99DF9-A9DC-802A-3C12-E0BA5B11581F}"/>
+                  <a16:creationId xmlns:a16="http://schemas.microsoft.com/office/drawing/2014/main" id="{DCB99DF9-A9DC-802A-3C12-E0BA5B11581F}"/>
                 </a:ext>
               </a:extLst>
             </p:cNvPr>
@@ -13263,7 +13027,7 @@
             <p:cNvPr id="6" name="Rectangle 5">
               <a:extLst>
                 <a:ext uri="{FF2B5EF4-FFF2-40B4-BE49-F238E27FC236}">
-                  <a16:creationId xmlns="" xmlns:a16="http://schemas.microsoft.com/office/drawing/2014/main" id="{52E5BB92-EE59-C83B-EE83-D9E19FA61AF0}"/>
+                  <a16:creationId xmlns:a16="http://schemas.microsoft.com/office/drawing/2014/main" id="{52E5BB92-EE59-C83B-EE83-D9E19FA61AF0}"/>
                 </a:ext>
               </a:extLst>
             </p:cNvPr>
@@ -13328,7 +13092,7 @@
           <p:cNvPr id="8" name="000_topleftHeading">
             <a:extLst>
               <a:ext uri="{FF2B5EF4-FFF2-40B4-BE49-F238E27FC236}">
-                <a16:creationId xmlns="" xmlns:a16="http://schemas.microsoft.com/office/drawing/2014/main" id="{E523ED40-0926-2F89-3476-0DA7C2BE0A11}"/>
+                <a16:creationId xmlns:a16="http://schemas.microsoft.com/office/drawing/2014/main" id="{E523ED40-0926-2F89-3476-0DA7C2BE0A11}"/>
               </a:ext>
             </a:extLst>
           </p:cNvPr>
@@ -13352,7 +13116,7 @@
           <a:lstStyle/>
           <a:p>
             <a:r>
-              <a:rPr lang="en-US" dirty="0" smtClean="0">
+              <a:rPr lang="en-US" dirty="0">
                 <a:latin typeface="Yu Gothic UI Light" panose="020B0300000000000000" pitchFamily="34" charset="-128"/>
                 <a:ea typeface="Yu Gothic UI Light" panose="020B0300000000000000" pitchFamily="34" charset="-128"/>
               </a:rPr>
@@ -13370,7 +13134,7 @@
           <p:cNvPr id="9" name="001_subtitle">
             <a:extLst>
               <a:ext uri="{FF2B5EF4-FFF2-40B4-BE49-F238E27FC236}">
-                <a16:creationId xmlns="" xmlns:a16="http://schemas.microsoft.com/office/drawing/2014/main" id="{A6AE533C-5B4F-8F93-C999-B358BF1053E4}"/>
+                <a16:creationId xmlns:a16="http://schemas.microsoft.com/office/drawing/2014/main" id="{A6AE533C-5B4F-8F93-C999-B358BF1053E4}"/>
               </a:ext>
             </a:extLst>
           </p:cNvPr>
@@ -13394,7 +13158,7 @@
           <a:lstStyle/>
           <a:p>
             <a:r>
-              <a:rPr lang="en-US" dirty="0" smtClean="0">
+              <a:rPr lang="en-US" dirty="0">
                 <a:latin typeface="Yu Gothic UI Light" panose="020B0300000000000000" pitchFamily="34" charset="-128"/>
                 <a:ea typeface="Yu Gothic UI Light" panose="020B0300000000000000" pitchFamily="34" charset="-128"/>
               </a:rPr>
@@ -13412,7 +13176,7 @@
           <p:cNvPr id="2" name="TextBox 1">
             <a:extLst>
               <a:ext uri="{FF2B5EF4-FFF2-40B4-BE49-F238E27FC236}">
-                <a16:creationId xmlns="" xmlns:a16="http://schemas.microsoft.com/office/drawing/2014/main" id="{E5F6B1BA-73E3-3089-C8E0-D47CAC7F3ADB}"/>
+                <a16:creationId xmlns:a16="http://schemas.microsoft.com/office/drawing/2014/main" id="{E5F6B1BA-73E3-3089-C8E0-D47CAC7F3ADB}"/>
               </a:ext>
             </a:extLst>
           </p:cNvPr>
@@ -13437,30 +13201,12 @@
           <a:p>
             <a:pPr lvl="0"/>
             <a:r>
-              <a:rPr lang="en-GB" dirty="0" smtClean="0">
-                <a:latin typeface="Yu Gothic UI Light" panose="020B0300000000000000" pitchFamily="34" charset="-128"/>
-                <a:ea typeface="Yu Gothic UI Light" panose="020B0300000000000000" pitchFamily="34" charset="-128"/>
-              </a:rPr>
-              <a:t>How accurately can TNBC </a:t>
-            </a:r>
-            <a:r>
               <a:rPr lang="en-GB" dirty="0">
                 <a:latin typeface="Yu Gothic UI Light" panose="020B0300000000000000" pitchFamily="34" charset="-128"/>
                 <a:ea typeface="Yu Gothic UI Light" panose="020B0300000000000000" pitchFamily="34" charset="-128"/>
               </a:rPr>
-              <a:t>status </a:t>
-            </a:r>
-            <a:r>
-              <a:rPr lang="en-GB" dirty="0" smtClean="0">
-                <a:latin typeface="Yu Gothic UI Light" panose="020B0300000000000000" pitchFamily="34" charset="-128"/>
-                <a:ea typeface="Yu Gothic UI Light" panose="020B0300000000000000" pitchFamily="34" charset="-128"/>
-              </a:rPr>
-              <a:t>be predicted?</a:t>
-            </a:r>
-            <a:endParaRPr lang="en-GB" dirty="0">
-              <a:latin typeface="Yu Gothic UI Light" panose="020B0300000000000000" pitchFamily="34" charset="-128"/>
-              <a:ea typeface="Yu Gothic UI Light" panose="020B0300000000000000" pitchFamily="34" charset="-128"/>
-            </a:endParaRPr>
+              <a:t>How accurately can TNBC status be predicted?</a:t>
+            </a:r>
           </a:p>
         </p:txBody>
       </p:sp>
@@ -13469,7 +13215,7 @@
           <p:cNvPr id="4" name="TextBox 3">
             <a:extLst>
               <a:ext uri="{FF2B5EF4-FFF2-40B4-BE49-F238E27FC236}">
-                <a16:creationId xmlns="" xmlns:a16="http://schemas.microsoft.com/office/drawing/2014/main" id="{26AF226B-FF7A-BDA8-8095-D241C05639CF}"/>
+                <a16:creationId xmlns:a16="http://schemas.microsoft.com/office/drawing/2014/main" id="{26AF226B-FF7A-BDA8-8095-D241C05639CF}"/>
               </a:ext>
             </a:extLst>
           </p:cNvPr>
@@ -13508,7 +13254,7 @@
           <p:cNvPr id="7" name="TextBox 6">
             <a:extLst>
               <a:ext uri="{FF2B5EF4-FFF2-40B4-BE49-F238E27FC236}">
-                <a16:creationId xmlns="" xmlns:a16="http://schemas.microsoft.com/office/drawing/2014/main" id="{5A455A23-768A-7A03-BCB2-F3DD8578FAB4}"/>
+                <a16:creationId xmlns:a16="http://schemas.microsoft.com/office/drawing/2014/main" id="{5A455A23-768A-7A03-BCB2-F3DD8578FAB4}"/>
               </a:ext>
             </a:extLst>
           </p:cNvPr>
@@ -13548,7 +13294,7 @@
           <p:cNvPr id="10" name="TextBox 9">
             <a:extLst>
               <a:ext uri="{FF2B5EF4-FFF2-40B4-BE49-F238E27FC236}">
-                <a16:creationId xmlns="" xmlns:a16="http://schemas.microsoft.com/office/drawing/2014/main" id="{CF78D215-3266-DEC4-9C40-39CD48F034C1}"/>
+                <a16:creationId xmlns:a16="http://schemas.microsoft.com/office/drawing/2014/main" id="{CF78D215-3266-DEC4-9C40-39CD48F034C1}"/>
               </a:ext>
             </a:extLst>
           </p:cNvPr>
@@ -13572,25 +13318,11 @@
           <a:lstStyle/>
           <a:p>
             <a:r>
-              <a:rPr lang="en-GB" dirty="0" smtClean="0">
-                <a:latin typeface="Yu Gothic UI Light" panose="020B0300000000000000" pitchFamily="34" charset="-128"/>
-                <a:ea typeface="Yu Gothic UI Light" panose="020B0300000000000000" pitchFamily="34" charset="-128"/>
-              </a:rPr>
-              <a:t>Can we meet </a:t>
-            </a:r>
-            <a:r>
               <a:rPr lang="en-GB" dirty="0">
                 <a:latin typeface="Yu Gothic UI Light" panose="020B0300000000000000" pitchFamily="34" charset="-128"/>
                 <a:ea typeface="Yu Gothic UI Light" panose="020B0300000000000000" pitchFamily="34" charset="-128"/>
               </a:rPr>
-              <a:t>important ethical </a:t>
-            </a:r>
-            <a:r>
-              <a:rPr lang="en-GB" dirty="0" smtClean="0">
-                <a:latin typeface="Yu Gothic UI Light" panose="020B0300000000000000" pitchFamily="34" charset="-128"/>
-                <a:ea typeface="Yu Gothic UI Light" panose="020B0300000000000000" pitchFamily="34" charset="-128"/>
-              </a:rPr>
-              <a:t>principles?</a:t>
+              <a:t>Can we meet important ethical principles?</a:t>
             </a:r>
             <a:endParaRPr lang="x-none" dirty="0">
               <a:latin typeface="Yu Gothic UI Light" panose="020B0300000000000000" pitchFamily="34" charset="-128"/>
@@ -13604,7 +13336,7 @@
           <p:cNvPr id="14" name="Picture 13" descr="A diagram of a gene&#10;&#10;AI-generated content may be incorrect.">
             <a:extLst>
               <a:ext uri="{FF2B5EF4-FFF2-40B4-BE49-F238E27FC236}">
-                <a16:creationId xmlns="" xmlns:a16="http://schemas.microsoft.com/office/drawing/2014/main" id="{F87D44CA-0A78-108E-AB90-0810BEF991ED}"/>
+                <a16:creationId xmlns:a16="http://schemas.microsoft.com/office/drawing/2014/main" id="{F87D44CA-0A78-108E-AB90-0810BEF991ED}"/>
               </a:ext>
             </a:extLst>
           </p:cNvPr>
@@ -13640,7 +13372,7 @@
           <p:cNvPr id="16" name="TextBox 15">
             <a:extLst>
               <a:ext uri="{FF2B5EF4-FFF2-40B4-BE49-F238E27FC236}">
-                <a16:creationId xmlns="" xmlns:a16="http://schemas.microsoft.com/office/drawing/2014/main" id="{85C4C44A-80AD-0A49-D4B2-61F9E7A66D61}"/>
+                <a16:creationId xmlns:a16="http://schemas.microsoft.com/office/drawing/2014/main" id="{85C4C44A-80AD-0A49-D4B2-61F9E7A66D61}"/>
               </a:ext>
             </a:extLst>
           </p:cNvPr>
@@ -13683,7 +13415,7 @@
           <p:cNvPr id="18" name="Picture 17" descr="A computer monitor and a machine&#10;&#10;AI-generated content may be incorrect.">
             <a:extLst>
               <a:ext uri="{FF2B5EF4-FFF2-40B4-BE49-F238E27FC236}">
-                <a16:creationId xmlns="" xmlns:a16="http://schemas.microsoft.com/office/drawing/2014/main" id="{1F1E104F-E4EF-4E96-52AB-9286CD7BE017}"/>
+                <a16:creationId xmlns:a16="http://schemas.microsoft.com/office/drawing/2014/main" id="{1F1E104F-E4EF-4E96-52AB-9286CD7BE017}"/>
               </a:ext>
             </a:extLst>
           </p:cNvPr>
@@ -13719,7 +13451,7 @@
           <p:cNvPr id="20" name="Picture 19" descr="A heart with a pulse line in the middle of hands&#10;&#10;AI-generated content may be incorrect.">
             <a:extLst>
               <a:ext uri="{FF2B5EF4-FFF2-40B4-BE49-F238E27FC236}">
-                <a16:creationId xmlns="" xmlns:a16="http://schemas.microsoft.com/office/drawing/2014/main" id="{3FE351CC-FD39-5EFB-891F-28A87EB2FDC9}"/>
+                <a16:creationId xmlns:a16="http://schemas.microsoft.com/office/drawing/2014/main" id="{3FE351CC-FD39-5EFB-891F-28A87EB2FDC9}"/>
               </a:ext>
             </a:extLst>
           </p:cNvPr>
@@ -13755,7 +13487,7 @@
           <p:cNvPr id="12" name="Graphic 11">
             <a:extLst>
               <a:ext uri="{FF2B5EF4-FFF2-40B4-BE49-F238E27FC236}">
-                <a16:creationId xmlns="" xmlns:a16="http://schemas.microsoft.com/office/drawing/2014/main" id="{51FE1894-2C86-4687-B1B9-8541E0A12D03}"/>
+                <a16:creationId xmlns:a16="http://schemas.microsoft.com/office/drawing/2014/main" id="{51FE1894-2C86-4687-B1B9-8541E0A12D03}"/>
               </a:ext>
             </a:extLst>
           </p:cNvPr>
@@ -13768,7 +13500,7 @@
           <a:blip r:embed="rId6">
             <a:extLst>
               <a:ext uri="{96DAC541-7B7A-43D3-8B79-37D633B846F1}">
-                <asvg:svgBlip xmlns="" xmlns:asvg="http://schemas.microsoft.com/office/drawing/2016/SVG/main" r:embed="rId7"/>
+                <asvg:svgBlip xmlns:asvg="http://schemas.microsoft.com/office/drawing/2016/SVG/main" r:embed="rId7"/>
               </a:ext>
             </a:extLst>
           </a:blip>
@@ -13796,13 +13528,6 @@
   <p:clrMapOvr>
     <a:masterClrMapping/>
   </p:clrMapOvr>
-  <p:timing>
-    <p:tnLst>
-      <p:par>
-        <p:cTn id="1" dur="indefinite" restart="never" nodeType="tmRoot"/>
-      </p:par>
-    </p:tnLst>
-  </p:timing>
 </p:sld>
 </file>
 
@@ -13825,7 +13550,7 @@
         <p:cNvPr id="1" name="">
           <a:extLst>
             <a:ext uri="{FF2B5EF4-FFF2-40B4-BE49-F238E27FC236}">
-              <a16:creationId xmlns="" xmlns:a16="http://schemas.microsoft.com/office/drawing/2014/main" id="{A2E99F46-8EA4-E740-23AC-B431B35D34F6}"/>
+              <a16:creationId xmlns:a16="http://schemas.microsoft.com/office/drawing/2014/main" id="{A2E99F46-8EA4-E740-23AC-B431B35D34F6}"/>
             </a:ext>
           </a:extLst>
         </p:cNvPr>
@@ -13845,7 +13570,7 @@
           <p:cNvPr id="2" name="000_topleftHeading">
             <a:extLst>
               <a:ext uri="{FF2B5EF4-FFF2-40B4-BE49-F238E27FC236}">
-                <a16:creationId xmlns="" xmlns:a16="http://schemas.microsoft.com/office/drawing/2014/main" id="{DDC5835A-94A0-B436-C872-3815CCE7AE9B}"/>
+                <a16:creationId xmlns:a16="http://schemas.microsoft.com/office/drawing/2014/main" id="{DDC5835A-94A0-B436-C872-3815CCE7AE9B}"/>
               </a:ext>
             </a:extLst>
           </p:cNvPr>
@@ -13869,7 +13594,7 @@
           <a:lstStyle/>
           <a:p>
             <a:r>
-              <a:rPr lang="en-US" dirty="0" smtClean="0">
+              <a:rPr lang="en-US" dirty="0">
                 <a:latin typeface="Yu Gothic UI Light" panose="020B0300000000000000" pitchFamily="34" charset="-128"/>
                 <a:ea typeface="Yu Gothic UI Light" panose="020B0300000000000000" pitchFamily="34" charset="-128"/>
               </a:rPr>
@@ -13887,7 +13612,7 @@
           <p:cNvPr id="3" name="001_subtitle">
             <a:extLst>
               <a:ext uri="{FF2B5EF4-FFF2-40B4-BE49-F238E27FC236}">
-                <a16:creationId xmlns="" xmlns:a16="http://schemas.microsoft.com/office/drawing/2014/main" id="{82AAF958-0411-EDB0-CDE7-B40ED132E551}"/>
+                <a16:creationId xmlns:a16="http://schemas.microsoft.com/office/drawing/2014/main" id="{82AAF958-0411-EDB0-CDE7-B40ED132E551}"/>
               </a:ext>
             </a:extLst>
           </p:cNvPr>
@@ -13911,7 +13636,7 @@
           <a:lstStyle/>
           <a:p>
             <a:r>
-              <a:rPr lang="en-US" dirty="0" smtClean="0">
+              <a:rPr lang="en-US" dirty="0">
                 <a:latin typeface="Yu Gothic UI Light" panose="020B0300000000000000" pitchFamily="34" charset="-128"/>
                 <a:ea typeface="Yu Gothic UI Light" panose="020B0300000000000000" pitchFamily="34" charset="-128"/>
               </a:rPr>
@@ -13929,7 +13654,7 @@
           <p:cNvPr id="6" name="Rectangle 5">
             <a:extLst>
               <a:ext uri="{FF2B5EF4-FFF2-40B4-BE49-F238E27FC236}">
-                <a16:creationId xmlns="" xmlns:a16="http://schemas.microsoft.com/office/drawing/2014/main" id="{9FC5198B-AF93-C12A-676A-1E5913E7B3DD}"/>
+                <a16:creationId xmlns:a16="http://schemas.microsoft.com/office/drawing/2014/main" id="{9FC5198B-AF93-C12A-676A-1E5913E7B3DD}"/>
               </a:ext>
             </a:extLst>
           </p:cNvPr>
@@ -13989,7 +13714,7 @@
           <p:cNvPr id="7" name="Rectangle 6">
             <a:extLst>
               <a:ext uri="{FF2B5EF4-FFF2-40B4-BE49-F238E27FC236}">
-                <a16:creationId xmlns="" xmlns:a16="http://schemas.microsoft.com/office/drawing/2014/main" id="{FBF8FB31-BD45-EA64-10A5-B2374FA6528D}"/>
+                <a16:creationId xmlns:a16="http://schemas.microsoft.com/office/drawing/2014/main" id="{FBF8FB31-BD45-EA64-10A5-B2374FA6528D}"/>
               </a:ext>
             </a:extLst>
           </p:cNvPr>
@@ -14104,7 +13829,7 @@
           <p:cNvPr id="8" name="Rectangle 7">
             <a:extLst>
               <a:ext uri="{FF2B5EF4-FFF2-40B4-BE49-F238E27FC236}">
-                <a16:creationId xmlns="" xmlns:a16="http://schemas.microsoft.com/office/drawing/2014/main" id="{8276DC9E-386E-2D60-678C-85B4347BB7EF}"/>
+                <a16:creationId xmlns:a16="http://schemas.microsoft.com/office/drawing/2014/main" id="{8276DC9E-386E-2D60-678C-85B4347BB7EF}"/>
               </a:ext>
             </a:extLst>
           </p:cNvPr>
@@ -14259,7 +13984,7 @@
           <p:cNvPr id="9" name="Rectangle 8">
             <a:extLst>
               <a:ext uri="{FF2B5EF4-FFF2-40B4-BE49-F238E27FC236}">
-                <a16:creationId xmlns="" xmlns:a16="http://schemas.microsoft.com/office/drawing/2014/main" id="{DD152BAF-A611-B847-BD65-75AAD9B87AC9}"/>
+                <a16:creationId xmlns:a16="http://schemas.microsoft.com/office/drawing/2014/main" id="{DD152BAF-A611-B847-BD65-75AAD9B87AC9}"/>
               </a:ext>
             </a:extLst>
           </p:cNvPr>
@@ -14340,7 +14065,7 @@
           <p:cNvPr id="10" name="Rectangle 9">
             <a:extLst>
               <a:ext uri="{FF2B5EF4-FFF2-40B4-BE49-F238E27FC236}">
-                <a16:creationId xmlns="" xmlns:a16="http://schemas.microsoft.com/office/drawing/2014/main" id="{CCDF3F1C-A937-BA95-0EBA-58DC029AC73C}"/>
+                <a16:creationId xmlns:a16="http://schemas.microsoft.com/office/drawing/2014/main" id="{CCDF3F1C-A937-BA95-0EBA-58DC029AC73C}"/>
               </a:ext>
             </a:extLst>
           </p:cNvPr>
@@ -14467,7 +14192,7 @@
           <p:cNvPr id="11" name="Arrow: Pentagon 10">
             <a:extLst>
               <a:ext uri="{FF2B5EF4-FFF2-40B4-BE49-F238E27FC236}">
-                <a16:creationId xmlns="" xmlns:a16="http://schemas.microsoft.com/office/drawing/2014/main" id="{0B3C0082-5815-21C1-CDB5-8B405C623BFC}"/>
+                <a16:creationId xmlns:a16="http://schemas.microsoft.com/office/drawing/2014/main" id="{0B3C0082-5815-21C1-CDB5-8B405C623BFC}"/>
               </a:ext>
             </a:extLst>
           </p:cNvPr>
@@ -14531,7 +14256,7 @@
           <p:cNvPr id="12" name="Arrow: Chevron 11">
             <a:extLst>
               <a:ext uri="{FF2B5EF4-FFF2-40B4-BE49-F238E27FC236}">
-                <a16:creationId xmlns="" xmlns:a16="http://schemas.microsoft.com/office/drawing/2014/main" id="{856A4177-4DEF-3A1A-29FF-5AF84A4358EB}"/>
+                <a16:creationId xmlns:a16="http://schemas.microsoft.com/office/drawing/2014/main" id="{856A4177-4DEF-3A1A-29FF-5AF84A4358EB}"/>
               </a:ext>
             </a:extLst>
           </p:cNvPr>
@@ -14601,7 +14326,7 @@
           <p:cNvPr id="14" name="Arrow: Chevron 13">
             <a:extLst>
               <a:ext uri="{FF2B5EF4-FFF2-40B4-BE49-F238E27FC236}">
-                <a16:creationId xmlns="" xmlns:a16="http://schemas.microsoft.com/office/drawing/2014/main" id="{0DBFF9A0-DBE5-AF76-2652-9D141BD0B2F0}"/>
+                <a16:creationId xmlns:a16="http://schemas.microsoft.com/office/drawing/2014/main" id="{0DBFF9A0-DBE5-AF76-2652-9D141BD0B2F0}"/>
               </a:ext>
             </a:extLst>
           </p:cNvPr>
@@ -14684,7 +14409,7 @@
           <p:cNvPr id="15" name="Arrow: Chevron 14">
             <a:extLst>
               <a:ext uri="{FF2B5EF4-FFF2-40B4-BE49-F238E27FC236}">
-                <a16:creationId xmlns="" xmlns:a16="http://schemas.microsoft.com/office/drawing/2014/main" id="{52D907F3-60D3-C8C2-EA77-BA32E7D3593C}"/>
+                <a16:creationId xmlns:a16="http://schemas.microsoft.com/office/drawing/2014/main" id="{52D907F3-60D3-C8C2-EA77-BA32E7D3593C}"/>
               </a:ext>
             </a:extLst>
           </p:cNvPr>
@@ -14749,7 +14474,7 @@
           <p:cNvPr id="18" name="Freeform: Shape 17">
             <a:extLst>
               <a:ext uri="{FF2B5EF4-FFF2-40B4-BE49-F238E27FC236}">
-                <a16:creationId xmlns="" xmlns:a16="http://schemas.microsoft.com/office/drawing/2014/main" id="{E18FE809-1B71-2669-98A5-B9C8B63233D0}"/>
+                <a16:creationId xmlns:a16="http://schemas.microsoft.com/office/drawing/2014/main" id="{E18FE809-1B71-2669-98A5-B9C8B63233D0}"/>
               </a:ext>
             </a:extLst>
           </p:cNvPr>
@@ -14906,7 +14631,7 @@
           <p:cNvPr id="16" name="Graphic 2">
             <a:extLst>
               <a:ext uri="{FF2B5EF4-FFF2-40B4-BE49-F238E27FC236}">
-                <a16:creationId xmlns="" xmlns:a16="http://schemas.microsoft.com/office/drawing/2014/main" id="{31A682CE-98B8-82B0-76EB-B2AF7E6B2BC9}"/>
+                <a16:creationId xmlns:a16="http://schemas.microsoft.com/office/drawing/2014/main" id="{31A682CE-98B8-82B0-76EB-B2AF7E6B2BC9}"/>
               </a:ext>
             </a:extLst>
           </p:cNvPr>
@@ -14919,7 +14644,7 @@
           <a:blip r:embed="rId2">
             <a:extLst>
               <a:ext uri="{96DAC541-7B7A-43D3-8B79-37D633B846F1}">
-                <asvg:svgBlip xmlns="" xmlns:asvg="http://schemas.microsoft.com/office/drawing/2016/SVG/main" r:embed="rId5"/>
+                <asvg:svgBlip xmlns:asvg="http://schemas.microsoft.com/office/drawing/2016/SVG/main" r:embed="rId3"/>
               </a:ext>
             </a:extLst>
           </a:blip>
@@ -14947,13 +14672,6 @@
   <p:clrMapOvr>
     <a:masterClrMapping/>
   </p:clrMapOvr>
-  <p:timing>
-    <p:tnLst>
-      <p:par>
-        <p:cTn id="1" dur="indefinite" restart="never" nodeType="tmRoot"/>
-      </p:par>
-    </p:tnLst>
-  </p:timing>
 </p:sld>
 </file>
 
@@ -14976,7 +14694,7 @@
         <p:cNvPr id="1" name="">
           <a:extLst>
             <a:ext uri="{FF2B5EF4-FFF2-40B4-BE49-F238E27FC236}">
-              <a16:creationId xmlns="" xmlns:a16="http://schemas.microsoft.com/office/drawing/2014/main" id="{CE852C78-503F-F3AA-6C7F-EC5E0B961EFB}"/>
+              <a16:creationId xmlns:a16="http://schemas.microsoft.com/office/drawing/2014/main" id="{CE852C78-503F-F3AA-6C7F-EC5E0B961EFB}"/>
             </a:ext>
           </a:extLst>
         </p:cNvPr>
@@ -14996,7 +14714,7 @@
           <p:cNvPr id="2" name="000_topleftHeading">
             <a:extLst>
               <a:ext uri="{FF2B5EF4-FFF2-40B4-BE49-F238E27FC236}">
-                <a16:creationId xmlns="" xmlns:a16="http://schemas.microsoft.com/office/drawing/2014/main" id="{36D8FCB8-AFFB-4F90-DCEA-A6C847C96038}"/>
+                <a16:creationId xmlns:a16="http://schemas.microsoft.com/office/drawing/2014/main" id="{36D8FCB8-AFFB-4F90-DCEA-A6C847C96038}"/>
               </a:ext>
             </a:extLst>
           </p:cNvPr>
@@ -15020,7 +14738,7 @@
           <a:lstStyle/>
           <a:p>
             <a:r>
-              <a:rPr lang="en-US" dirty="0" smtClean="0">
+              <a:rPr lang="en-US" dirty="0">
                 <a:latin typeface="Yu Gothic UI Light" panose="020B0300000000000000" pitchFamily="34" charset="-128"/>
                 <a:ea typeface="Yu Gothic UI Light" panose="020B0300000000000000" pitchFamily="34" charset="-128"/>
               </a:rPr>
@@ -15038,7 +14756,7 @@
           <p:cNvPr id="3" name="001_subtitle">
             <a:extLst>
               <a:ext uri="{FF2B5EF4-FFF2-40B4-BE49-F238E27FC236}">
-                <a16:creationId xmlns="" xmlns:a16="http://schemas.microsoft.com/office/drawing/2014/main" id="{22205EC9-C620-51CF-59B4-C781FA24C816}"/>
+                <a16:creationId xmlns:a16="http://schemas.microsoft.com/office/drawing/2014/main" id="{22205EC9-C620-51CF-59B4-C781FA24C816}"/>
               </a:ext>
             </a:extLst>
           </p:cNvPr>
@@ -15080,7 +14798,7 @@
           <p:cNvPr id="4" name="Rectangle 3">
             <a:extLst>
               <a:ext uri="{FF2B5EF4-FFF2-40B4-BE49-F238E27FC236}">
-                <a16:creationId xmlns="" xmlns:a16="http://schemas.microsoft.com/office/drawing/2014/main" id="{DA404B48-8CAD-85A6-C66C-AC9CABB20B34}"/>
+                <a16:creationId xmlns:a16="http://schemas.microsoft.com/office/drawing/2014/main" id="{DA404B48-8CAD-85A6-C66C-AC9CABB20B34}"/>
               </a:ext>
             </a:extLst>
           </p:cNvPr>
@@ -15153,7 +14871,7 @@
           <p:cNvPr id="17" name="Rectangle 16">
             <a:extLst>
               <a:ext uri="{FF2B5EF4-FFF2-40B4-BE49-F238E27FC236}">
-                <a16:creationId xmlns="" xmlns:a16="http://schemas.microsoft.com/office/drawing/2014/main" id="{AAFAE932-9F02-CB1A-7AC9-467F43DC7525}"/>
+                <a16:creationId xmlns:a16="http://schemas.microsoft.com/office/drawing/2014/main" id="{AAFAE932-9F02-CB1A-7AC9-467F43DC7525}"/>
               </a:ext>
             </a:extLst>
           </p:cNvPr>
@@ -15217,7 +14935,7 @@
           <p:cNvPr id="20" name="Rectangle 19">
             <a:extLst>
               <a:ext uri="{FF2B5EF4-FFF2-40B4-BE49-F238E27FC236}">
-                <a16:creationId xmlns="" xmlns:a16="http://schemas.microsoft.com/office/drawing/2014/main" id="{C2B4B9B0-2E14-2FFF-2E32-451FE71E38FC}"/>
+                <a16:creationId xmlns:a16="http://schemas.microsoft.com/office/drawing/2014/main" id="{C2B4B9B0-2E14-2FFF-2E32-451FE71E38FC}"/>
               </a:ext>
             </a:extLst>
           </p:cNvPr>
@@ -15276,19 +14994,8 @@
                 <a:latin typeface="Yu Gothic UI Light" panose="020B0300000000000000" pitchFamily="34" charset="-128"/>
                 <a:ea typeface="Yu Gothic UI Light" panose="020B0300000000000000" pitchFamily="34" charset="-128"/>
               </a:rPr>
-              <a:t>Breast cancer (BC</a:t>
-            </a:r>
-            <a:r>
-              <a:rPr lang="en-US" dirty="0" smtClean="0">
-                <a:latin typeface="Yu Gothic UI Light" panose="020B0300000000000000" pitchFamily="34" charset="-128"/>
-                <a:ea typeface="Yu Gothic UI Light" panose="020B0300000000000000" pitchFamily="34" charset="-128"/>
-              </a:rPr>
-              <a:t>)</a:t>
-            </a:r>
-            <a:endParaRPr lang="en-US" dirty="0">
-              <a:latin typeface="Yu Gothic UI Light" panose="020B0300000000000000" pitchFamily="34" charset="-128"/>
-              <a:ea typeface="Yu Gothic UI Light" panose="020B0300000000000000" pitchFamily="34" charset="-128"/>
-            </a:endParaRPr>
+              <a:t>Breast cancer (BC)</a:t>
+            </a:r>
           </a:p>
           <a:p>
             <a:r>
@@ -15296,14 +15003,7 @@
                 <a:latin typeface="Yu Gothic UI Light" panose="020B0300000000000000" pitchFamily="34" charset="-128"/>
                 <a:ea typeface="Yu Gothic UI Light" panose="020B0300000000000000" pitchFamily="34" charset="-128"/>
               </a:rPr>
-              <a:t>Triple-Negative Breast Cancer (TNBC</a:t>
-            </a:r>
-            <a:r>
-              <a:rPr lang="en-US" dirty="0" smtClean="0">
-                <a:latin typeface="Yu Gothic UI Light" panose="020B0300000000000000" pitchFamily="34" charset="-128"/>
-                <a:ea typeface="Yu Gothic UI Light" panose="020B0300000000000000" pitchFamily="34" charset="-128"/>
-              </a:rPr>
-              <a:t>)</a:t>
+              <a:t>Triple-Negative Breast Cancer (TNBC)</a:t>
             </a:r>
             <a:endParaRPr lang="x-none" dirty="0">
               <a:latin typeface="Yu Gothic UI Light" panose="020B0300000000000000" pitchFamily="34" charset="-128"/>
@@ -15317,7 +15017,7 @@
           <p:cNvPr id="25" name="Rectangle 24">
             <a:extLst>
               <a:ext uri="{FF2B5EF4-FFF2-40B4-BE49-F238E27FC236}">
-                <a16:creationId xmlns="" xmlns:a16="http://schemas.microsoft.com/office/drawing/2014/main" id="{B54CC5F5-8B77-098F-B586-3F82B2FC8B1C}"/>
+                <a16:creationId xmlns:a16="http://schemas.microsoft.com/office/drawing/2014/main" id="{B54CC5F5-8B77-098F-B586-3F82B2FC8B1C}"/>
               </a:ext>
             </a:extLst>
           </p:cNvPr>
@@ -15377,7 +15077,7 @@
           <p:cNvPr id="27" name="Rectangle 26">
             <a:extLst>
               <a:ext uri="{FF2B5EF4-FFF2-40B4-BE49-F238E27FC236}">
-                <a16:creationId xmlns="" xmlns:a16="http://schemas.microsoft.com/office/drawing/2014/main" id="{E30D7BDB-1F4C-E757-F5A6-7DE3156A113C}"/>
+                <a16:creationId xmlns:a16="http://schemas.microsoft.com/office/drawing/2014/main" id="{E30D7BDB-1F4C-E757-F5A6-7DE3156A113C}"/>
               </a:ext>
             </a:extLst>
           </p:cNvPr>
@@ -15437,7 +15137,7 @@
           <p:cNvPr id="28" name="Rectangle 27">
             <a:extLst>
               <a:ext uri="{FF2B5EF4-FFF2-40B4-BE49-F238E27FC236}">
-                <a16:creationId xmlns="" xmlns:a16="http://schemas.microsoft.com/office/drawing/2014/main" id="{EBF09AF1-F58B-8B6F-15A2-6A1FEDF6EEEE}"/>
+                <a16:creationId xmlns:a16="http://schemas.microsoft.com/office/drawing/2014/main" id="{EBF09AF1-F58B-8B6F-15A2-6A1FEDF6EEEE}"/>
               </a:ext>
             </a:extLst>
           </p:cNvPr>
@@ -15497,7 +15197,7 @@
           <p:cNvPr id="11" name="Graphic 2">
             <a:extLst>
               <a:ext uri="{FF2B5EF4-FFF2-40B4-BE49-F238E27FC236}">
-                <a16:creationId xmlns="" xmlns:a16="http://schemas.microsoft.com/office/drawing/2014/main" id="{31A682CE-98B8-82B0-76EB-B2AF7E6B2BC9}"/>
+                <a16:creationId xmlns:a16="http://schemas.microsoft.com/office/drawing/2014/main" id="{31A682CE-98B8-82B0-76EB-B2AF7E6B2BC9}"/>
               </a:ext>
             </a:extLst>
           </p:cNvPr>
@@ -15510,7 +15210,7 @@
           <a:blip r:embed="rId2">
             <a:extLst>
               <a:ext uri="{96DAC541-7B7A-43D3-8B79-37D633B846F1}">
-                <asvg:svgBlip xmlns="" xmlns:asvg="http://schemas.microsoft.com/office/drawing/2016/SVG/main" r:embed="rId5"/>
+                <asvg:svgBlip xmlns:asvg="http://schemas.microsoft.com/office/drawing/2016/SVG/main" r:embed="rId3"/>
               </a:ext>
             </a:extLst>
           </a:blip>
@@ -15538,13 +15238,6 @@
   <p:clrMapOvr>
     <a:masterClrMapping/>
   </p:clrMapOvr>
-  <p:timing>
-    <p:tnLst>
-      <p:par>
-        <p:cTn id="1" dur="indefinite" restart="never" nodeType="tmRoot"/>
-      </p:par>
-    </p:tnLst>
-  </p:timing>
 </p:sld>
 </file>
 
@@ -15567,7 +15260,7 @@
         <p:cNvPr id="1" name="">
           <a:extLst>
             <a:ext uri="{FF2B5EF4-FFF2-40B4-BE49-F238E27FC236}">
-              <a16:creationId xmlns="" xmlns:a16="http://schemas.microsoft.com/office/drawing/2014/main" id="{F5F3E35A-BFAF-2BD7-387D-AF09A74FCFD9}"/>
+              <a16:creationId xmlns:a16="http://schemas.microsoft.com/office/drawing/2014/main" id="{F5F3E35A-BFAF-2BD7-387D-AF09A74FCFD9}"/>
             </a:ext>
           </a:extLst>
         </p:cNvPr>
@@ -15587,7 +15280,7 @@
           <p:cNvPr id="2" name="000_topleftHeading">
             <a:extLst>
               <a:ext uri="{FF2B5EF4-FFF2-40B4-BE49-F238E27FC236}">
-                <a16:creationId xmlns="" xmlns:a16="http://schemas.microsoft.com/office/drawing/2014/main" id="{AC06D787-211C-AB95-EC22-9FCE0990CCA5}"/>
+                <a16:creationId xmlns:a16="http://schemas.microsoft.com/office/drawing/2014/main" id="{AC06D787-211C-AB95-EC22-9FCE0990CCA5}"/>
               </a:ext>
             </a:extLst>
           </p:cNvPr>
@@ -15611,7 +15304,7 @@
           <a:lstStyle/>
           <a:p>
             <a:r>
-              <a:rPr lang="en-US" dirty="0" smtClean="0">
+              <a:rPr lang="en-US" dirty="0">
                 <a:latin typeface="Yu Gothic UI Light" panose="020B0300000000000000" pitchFamily="34" charset="-128"/>
                 <a:ea typeface="Yu Gothic UI Light" panose="020B0300000000000000" pitchFamily="34" charset="-128"/>
               </a:rPr>
@@ -15629,7 +15322,7 @@
           <p:cNvPr id="7" name="Rectangle 6">
             <a:extLst>
               <a:ext uri="{FF2B5EF4-FFF2-40B4-BE49-F238E27FC236}">
-                <a16:creationId xmlns="" xmlns:a16="http://schemas.microsoft.com/office/drawing/2014/main" id="{F64BE28E-9795-DCAA-732E-9790215E237B}"/>
+                <a16:creationId xmlns:a16="http://schemas.microsoft.com/office/drawing/2014/main" id="{F64BE28E-9795-DCAA-732E-9790215E237B}"/>
               </a:ext>
             </a:extLst>
           </p:cNvPr>
@@ -15798,7 +15491,7 @@
           <p:cNvPr id="8" name="Rectangle 7">
             <a:extLst>
               <a:ext uri="{FF2B5EF4-FFF2-40B4-BE49-F238E27FC236}">
-                <a16:creationId xmlns="" xmlns:a16="http://schemas.microsoft.com/office/drawing/2014/main" id="{AD536F55-81AF-1CFD-1E80-77BC55812D39}"/>
+                <a16:creationId xmlns:a16="http://schemas.microsoft.com/office/drawing/2014/main" id="{AD536F55-81AF-1CFD-1E80-77BC55812D39}"/>
               </a:ext>
             </a:extLst>
           </p:cNvPr>
@@ -15860,7 +15553,7 @@
           <p:cNvPr id="6" name="Rectangle 5">
             <a:extLst>
               <a:ext uri="{FF2B5EF4-FFF2-40B4-BE49-F238E27FC236}">
-                <a16:creationId xmlns="" xmlns:a16="http://schemas.microsoft.com/office/drawing/2014/main" id="{58DF7C3F-03C0-D0B0-0C62-14319F921916}"/>
+                <a16:creationId xmlns:a16="http://schemas.microsoft.com/office/drawing/2014/main" id="{58DF7C3F-03C0-D0B0-0C62-14319F921916}"/>
               </a:ext>
             </a:extLst>
           </p:cNvPr>
@@ -15918,7 +15611,7 @@
           <p:cNvPr id="9" name="Rectangle 8">
             <a:extLst>
               <a:ext uri="{FF2B5EF4-FFF2-40B4-BE49-F238E27FC236}">
-                <a16:creationId xmlns="" xmlns:a16="http://schemas.microsoft.com/office/drawing/2014/main" id="{08894AE5-32FF-7BB1-6680-83F81DE2FD6A}"/>
+                <a16:creationId xmlns:a16="http://schemas.microsoft.com/office/drawing/2014/main" id="{08894AE5-32FF-7BB1-6680-83F81DE2FD6A}"/>
               </a:ext>
             </a:extLst>
           </p:cNvPr>
@@ -16080,25 +15773,8 @@
                 <a:latin typeface="Yu Gothic UI Light" panose="020B0300000000000000" pitchFamily="34" charset="-128"/>
                 <a:ea typeface="Yu Gothic UI Light" panose="020B0300000000000000" pitchFamily="34" charset="-128"/>
               </a:rPr>
-              <a:t>Rows (cases</a:t>
-            </a:r>
-            <a:r>
-              <a:rPr lang="en-US" dirty="0" smtClean="0">
-                <a:solidFill>
-                  <a:schemeClr val="accent1"/>
-                </a:solidFill>
-                <a:latin typeface="Yu Gothic UI Light" panose="020B0300000000000000" pitchFamily="34" charset="-128"/>
-                <a:ea typeface="Yu Gothic UI Light" panose="020B0300000000000000" pitchFamily="34" charset="-128"/>
-              </a:rPr>
-              <a:t>), no duplicates</a:t>
-            </a:r>
-            <a:endParaRPr lang="en-US" dirty="0">
-              <a:solidFill>
-                <a:schemeClr val="accent1"/>
-              </a:solidFill>
-              <a:latin typeface="Yu Gothic UI Light" panose="020B0300000000000000" pitchFamily="34" charset="-128"/>
-              <a:ea typeface="Yu Gothic UI Light" panose="020B0300000000000000" pitchFamily="34" charset="-128"/>
-            </a:endParaRPr>
+              <a:t>Rows (cases), no duplicates</a:t>
+            </a:r>
           </a:p>
           <a:p>
             <a:pPr marL="742950" lvl="1" indent="-285750">
@@ -16123,7 +15799,7 @@
           <p:cNvPr id="11" name="001_subtitle">
             <a:extLst>
               <a:ext uri="{FF2B5EF4-FFF2-40B4-BE49-F238E27FC236}">
-                <a16:creationId xmlns="" xmlns:a16="http://schemas.microsoft.com/office/drawing/2014/main" id="{4F830B43-F57E-4CD9-AEAC-540211606A5F}"/>
+                <a16:creationId xmlns:a16="http://schemas.microsoft.com/office/drawing/2014/main" id="{4F830B43-F57E-4CD9-AEAC-540211606A5F}"/>
               </a:ext>
             </a:extLst>
           </p:cNvPr>
@@ -16165,7 +15841,7 @@
           <p:cNvPr id="10" name="Graphic 2">
             <a:extLst>
               <a:ext uri="{FF2B5EF4-FFF2-40B4-BE49-F238E27FC236}">
-                <a16:creationId xmlns="" xmlns:a16="http://schemas.microsoft.com/office/drawing/2014/main" id="{31A682CE-98B8-82B0-76EB-B2AF7E6B2BC9}"/>
+                <a16:creationId xmlns:a16="http://schemas.microsoft.com/office/drawing/2014/main" id="{31A682CE-98B8-82B0-76EB-B2AF7E6B2BC9}"/>
               </a:ext>
             </a:extLst>
           </p:cNvPr>
@@ -16178,7 +15854,7 @@
           <a:blip r:embed="rId2">
             <a:extLst>
               <a:ext uri="{96DAC541-7B7A-43D3-8B79-37D633B846F1}">
-                <asvg:svgBlip xmlns="" xmlns:asvg="http://schemas.microsoft.com/office/drawing/2016/SVG/main" r:embed="rId5"/>
+                <asvg:svgBlip xmlns:asvg="http://schemas.microsoft.com/office/drawing/2016/SVG/main" r:embed="rId3"/>
               </a:ext>
             </a:extLst>
           </a:blip>
@@ -16206,13 +15882,6 @@
   <p:clrMapOvr>
     <a:masterClrMapping/>
   </p:clrMapOvr>
-  <p:timing>
-    <p:tnLst>
-      <p:par>
-        <p:cTn id="1" dur="indefinite" restart="never" nodeType="tmRoot"/>
-      </p:par>
-    </p:tnLst>
-  </p:timing>
 </p:sld>
 </file>
 
@@ -16235,7 +15904,7 @@
         <p:cNvPr id="1" name="">
           <a:extLst>
             <a:ext uri="{FF2B5EF4-FFF2-40B4-BE49-F238E27FC236}">
-              <a16:creationId xmlns="" xmlns:a16="http://schemas.microsoft.com/office/drawing/2014/main" id="{F28269AF-4181-57F3-67FB-0E5A9365FDAE}"/>
+              <a16:creationId xmlns:a16="http://schemas.microsoft.com/office/drawing/2014/main" id="{F28269AF-4181-57F3-67FB-0E5A9365FDAE}"/>
             </a:ext>
           </a:extLst>
         </p:cNvPr>
@@ -16255,7 +15924,7 @@
           <p:cNvPr id="3" name="Rectangle 2">
             <a:extLst>
               <a:ext uri="{FF2B5EF4-FFF2-40B4-BE49-F238E27FC236}">
-                <a16:creationId xmlns="" xmlns:a16="http://schemas.microsoft.com/office/drawing/2014/main" id="{9EF678FF-E300-D3A6-6651-0FAB069DF9BE}"/>
+                <a16:creationId xmlns:a16="http://schemas.microsoft.com/office/drawing/2014/main" id="{9EF678FF-E300-D3A6-6651-0FAB069DF9BE}"/>
               </a:ext>
             </a:extLst>
           </p:cNvPr>
@@ -16319,7 +15988,7 @@
           <p:cNvPr id="2" name="000_topleftHeading">
             <a:extLst>
               <a:ext uri="{FF2B5EF4-FFF2-40B4-BE49-F238E27FC236}">
-                <a16:creationId xmlns="" xmlns:a16="http://schemas.microsoft.com/office/drawing/2014/main" id="{07DF2542-CE1F-2154-0C7C-2D62B634C371}"/>
+                <a16:creationId xmlns:a16="http://schemas.microsoft.com/office/drawing/2014/main" id="{07DF2542-CE1F-2154-0C7C-2D62B634C371}"/>
               </a:ext>
             </a:extLst>
           </p:cNvPr>
@@ -16343,7 +16012,7 @@
           <a:lstStyle/>
           <a:p>
             <a:r>
-              <a:rPr lang="en-US" dirty="0" smtClean="0">
+              <a:rPr lang="en-US" dirty="0">
                 <a:latin typeface="Yu Gothic UI Light" panose="020B0300000000000000" pitchFamily="34" charset="-128"/>
                 <a:ea typeface="Yu Gothic UI Light" panose="020B0300000000000000" pitchFamily="34" charset="-128"/>
               </a:rPr>
@@ -16361,7 +16030,7 @@
           <p:cNvPr id="10" name="001_subtitle">
             <a:extLst>
               <a:ext uri="{FF2B5EF4-FFF2-40B4-BE49-F238E27FC236}">
-                <a16:creationId xmlns="" xmlns:a16="http://schemas.microsoft.com/office/drawing/2014/main" id="{E6255DD2-6EFB-6BCF-ABF3-C75300CCDE85}"/>
+                <a16:creationId xmlns:a16="http://schemas.microsoft.com/office/drawing/2014/main" id="{E6255DD2-6EFB-6BCF-ABF3-C75300CCDE85}"/>
               </a:ext>
             </a:extLst>
           </p:cNvPr>
@@ -16403,7 +16072,7 @@
           <p:cNvPr id="11" name="Rectangle 10">
             <a:extLst>
               <a:ext uri="{FF2B5EF4-FFF2-40B4-BE49-F238E27FC236}">
-                <a16:creationId xmlns="" xmlns:a16="http://schemas.microsoft.com/office/drawing/2014/main" id="{D10E52DA-273A-6D50-F870-EEE193E91E24}"/>
+                <a16:creationId xmlns:a16="http://schemas.microsoft.com/office/drawing/2014/main" id="{D10E52DA-273A-6D50-F870-EEE193E91E24}"/>
               </a:ext>
             </a:extLst>
           </p:cNvPr>
@@ -16467,7 +16136,7 @@
           <p:cNvPr id="12" name="Rectangle 11">
             <a:extLst>
               <a:ext uri="{FF2B5EF4-FFF2-40B4-BE49-F238E27FC236}">
-                <a16:creationId xmlns="" xmlns:a16="http://schemas.microsoft.com/office/drawing/2014/main" id="{43A46E45-7C66-8742-4A27-F1F01A0BD2FA}"/>
+                <a16:creationId xmlns:a16="http://schemas.microsoft.com/office/drawing/2014/main" id="{43A46E45-7C66-8742-4A27-F1F01A0BD2FA}"/>
               </a:ext>
             </a:extLst>
           </p:cNvPr>
@@ -16531,7 +16200,7 @@
           <p:cNvPr id="15" name="Rectangle 14">
             <a:extLst>
               <a:ext uri="{FF2B5EF4-FFF2-40B4-BE49-F238E27FC236}">
-                <a16:creationId xmlns="" xmlns:a16="http://schemas.microsoft.com/office/drawing/2014/main" id="{B2653D81-1BD9-751F-2C5A-336FEAA42D23}"/>
+                <a16:creationId xmlns:a16="http://schemas.microsoft.com/office/drawing/2014/main" id="{B2653D81-1BD9-751F-2C5A-336FEAA42D23}"/>
               </a:ext>
             </a:extLst>
           </p:cNvPr>
@@ -16612,7 +16281,7 @@
           <p:cNvPr id="16" name="Rectangle 15">
             <a:extLst>
               <a:ext uri="{FF2B5EF4-FFF2-40B4-BE49-F238E27FC236}">
-                <a16:creationId xmlns="" xmlns:a16="http://schemas.microsoft.com/office/drawing/2014/main" id="{0D693161-2C97-B996-A642-24A6E3973ECD}"/>
+                <a16:creationId xmlns:a16="http://schemas.microsoft.com/office/drawing/2014/main" id="{0D693161-2C97-B996-A642-24A6E3973ECD}"/>
               </a:ext>
             </a:extLst>
           </p:cNvPr>
@@ -16676,7 +16345,7 @@
           <p:cNvPr id="18" name="Rectangle 17">
             <a:extLst>
               <a:ext uri="{FF2B5EF4-FFF2-40B4-BE49-F238E27FC236}">
-                <a16:creationId xmlns="" xmlns:a16="http://schemas.microsoft.com/office/drawing/2014/main" id="{59566D40-FB0A-9440-0213-9402D825B9CA}"/>
+                <a16:creationId xmlns:a16="http://schemas.microsoft.com/office/drawing/2014/main" id="{59566D40-FB0A-9440-0213-9402D825B9CA}"/>
               </a:ext>
             </a:extLst>
           </p:cNvPr>
@@ -16740,7 +16409,7 @@
           <p:cNvPr id="20" name="Rectangle 19">
             <a:extLst>
               <a:ext uri="{FF2B5EF4-FFF2-40B4-BE49-F238E27FC236}">
-                <a16:creationId xmlns="" xmlns:a16="http://schemas.microsoft.com/office/drawing/2014/main" id="{37069335-E578-F079-928C-96F5CC5AE599}"/>
+                <a16:creationId xmlns:a16="http://schemas.microsoft.com/office/drawing/2014/main" id="{37069335-E578-F079-928C-96F5CC5AE599}"/>
               </a:ext>
             </a:extLst>
           </p:cNvPr>
@@ -16817,7 +16486,7 @@
           <p:cNvPr id="21" name="Rectangle 20">
             <a:extLst>
               <a:ext uri="{FF2B5EF4-FFF2-40B4-BE49-F238E27FC236}">
-                <a16:creationId xmlns="" xmlns:a16="http://schemas.microsoft.com/office/drawing/2014/main" id="{65107A95-FADC-1697-D1CA-62C9AF58BFD5}"/>
+                <a16:creationId xmlns:a16="http://schemas.microsoft.com/office/drawing/2014/main" id="{65107A95-FADC-1697-D1CA-62C9AF58BFD5}"/>
               </a:ext>
             </a:extLst>
           </p:cNvPr>
@@ -16881,7 +16550,7 @@
           <p:cNvPr id="22" name="Rectangle 21">
             <a:extLst>
               <a:ext uri="{FF2B5EF4-FFF2-40B4-BE49-F238E27FC236}">
-                <a16:creationId xmlns="" xmlns:a16="http://schemas.microsoft.com/office/drawing/2014/main" id="{F9A885C6-8EE2-ECFB-73F2-1E184FF7A424}"/>
+                <a16:creationId xmlns:a16="http://schemas.microsoft.com/office/drawing/2014/main" id="{F9A885C6-8EE2-ECFB-73F2-1E184FF7A424}"/>
               </a:ext>
             </a:extLst>
           </p:cNvPr>
@@ -16958,7 +16627,7 @@
           <p:cNvPr id="23" name="Rectangle 22">
             <a:extLst>
               <a:ext uri="{FF2B5EF4-FFF2-40B4-BE49-F238E27FC236}">
-                <a16:creationId xmlns="" xmlns:a16="http://schemas.microsoft.com/office/drawing/2014/main" id="{2D2CCC73-5AD9-56B1-2A5D-40F03BE5FCA7}"/>
+                <a16:creationId xmlns:a16="http://schemas.microsoft.com/office/drawing/2014/main" id="{2D2CCC73-5AD9-56B1-2A5D-40F03BE5FCA7}"/>
               </a:ext>
             </a:extLst>
           </p:cNvPr>
@@ -17035,7 +16704,7 @@
           <p:cNvPr id="24" name="Rectangle 23">
             <a:extLst>
               <a:ext uri="{FF2B5EF4-FFF2-40B4-BE49-F238E27FC236}">
-                <a16:creationId xmlns="" xmlns:a16="http://schemas.microsoft.com/office/drawing/2014/main" id="{7149751A-38CD-F62F-1C7F-E36D8DC64264}"/>
+                <a16:creationId xmlns:a16="http://schemas.microsoft.com/office/drawing/2014/main" id="{7149751A-38CD-F62F-1C7F-E36D8DC64264}"/>
               </a:ext>
             </a:extLst>
           </p:cNvPr>
@@ -17095,7 +16764,7 @@
           <p:cNvPr id="25" name="Rectangle 24">
             <a:extLst>
               <a:ext uri="{FF2B5EF4-FFF2-40B4-BE49-F238E27FC236}">
-                <a16:creationId xmlns="" xmlns:a16="http://schemas.microsoft.com/office/drawing/2014/main" id="{70D4A10D-3DC9-E2BF-9B04-87312E162405}"/>
+                <a16:creationId xmlns:a16="http://schemas.microsoft.com/office/drawing/2014/main" id="{70D4A10D-3DC9-E2BF-9B04-87312E162405}"/>
               </a:ext>
             </a:extLst>
           </p:cNvPr>
@@ -17155,7 +16824,7 @@
           <p:cNvPr id="27" name="Rectangle 26">
             <a:extLst>
               <a:ext uri="{FF2B5EF4-FFF2-40B4-BE49-F238E27FC236}">
-                <a16:creationId xmlns="" xmlns:a16="http://schemas.microsoft.com/office/drawing/2014/main" id="{123C9AB6-A54B-38F0-99ED-5ED4EED68D78}"/>
+                <a16:creationId xmlns:a16="http://schemas.microsoft.com/office/drawing/2014/main" id="{123C9AB6-A54B-38F0-99ED-5ED4EED68D78}"/>
               </a:ext>
             </a:extLst>
           </p:cNvPr>
@@ -17201,18 +16870,11 @@
           <a:p>
             <a:pPr algn="ctr"/>
             <a:r>
-              <a:rPr lang="en-US" dirty="0" smtClean="0">
-                <a:latin typeface="Yu Gothic UI Light" panose="020B0300000000000000" pitchFamily="34" charset="-128"/>
-                <a:ea typeface="Yu Gothic UI Light" panose="020B0300000000000000" pitchFamily="34" charset="-128"/>
-              </a:rPr>
-              <a:t>297 </a:t>
-            </a:r>
-            <a:r>
               <a:rPr lang="en-US" dirty="0">
                 <a:latin typeface="Yu Gothic UI Light" panose="020B0300000000000000" pitchFamily="34" charset="-128"/>
                 <a:ea typeface="Yu Gothic UI Light" panose="020B0300000000000000" pitchFamily="34" charset="-128"/>
               </a:rPr>
-              <a:t>features</a:t>
+              <a:t>297 features</a:t>
             </a:r>
           </a:p>
           <a:p>
@@ -17232,7 +16894,7 @@
           <p:cNvPr id="4" name="TextBox 3">
             <a:extLst>
               <a:ext uri="{FF2B5EF4-FFF2-40B4-BE49-F238E27FC236}">
-                <a16:creationId xmlns="" xmlns:a16="http://schemas.microsoft.com/office/drawing/2014/main" id="{81B54359-7745-E28B-0783-E306FE9E3954}"/>
+                <a16:creationId xmlns:a16="http://schemas.microsoft.com/office/drawing/2014/main" id="{81B54359-7745-E28B-0783-E306FE9E3954}"/>
               </a:ext>
             </a:extLst>
           </p:cNvPr>
@@ -17280,7 +16942,7 @@
           <p:cNvPr id="5" name="Graphic 4">
             <a:extLst>
               <a:ext uri="{FF2B5EF4-FFF2-40B4-BE49-F238E27FC236}">
-                <a16:creationId xmlns="" xmlns:a16="http://schemas.microsoft.com/office/drawing/2014/main" id="{9C256A0E-0CBF-1E0D-B063-E6690A246AE8}"/>
+                <a16:creationId xmlns:a16="http://schemas.microsoft.com/office/drawing/2014/main" id="{9C256A0E-0CBF-1E0D-B063-E6690A246AE8}"/>
               </a:ext>
             </a:extLst>
           </p:cNvPr>
@@ -17293,7 +16955,7 @@
           <a:blip r:embed="rId2">
             <a:extLst>
               <a:ext uri="{96DAC541-7B7A-43D3-8B79-37D633B846F1}">
-                <asvg:svgBlip xmlns="" xmlns:asvg="http://schemas.microsoft.com/office/drawing/2016/SVG/main" r:embed="rId3"/>
+                <asvg:svgBlip xmlns:asvg="http://schemas.microsoft.com/office/drawing/2016/SVG/main" r:embed="rId3"/>
               </a:ext>
             </a:extLst>
           </a:blip>
@@ -17321,13 +16983,6 @@
   <p:clrMapOvr>
     <a:masterClrMapping/>
   </p:clrMapOvr>
-  <p:timing>
-    <p:tnLst>
-      <p:par>
-        <p:cTn id="1" dur="indefinite" restart="never" nodeType="tmRoot"/>
-      </p:par>
-    </p:tnLst>
-  </p:timing>
 </p:sld>
 </file>
 
@@ -17350,7 +17005,7 @@
         <p:cNvPr id="1" name="">
           <a:extLst>
             <a:ext uri="{FF2B5EF4-FFF2-40B4-BE49-F238E27FC236}">
-              <a16:creationId xmlns="" xmlns:a16="http://schemas.microsoft.com/office/drawing/2014/main" id="{E168F66A-EFC2-B79F-DF19-F2270C44B3D2}"/>
+              <a16:creationId xmlns:a16="http://schemas.microsoft.com/office/drawing/2014/main" id="{E168F66A-EFC2-B79F-DF19-F2270C44B3D2}"/>
             </a:ext>
           </a:extLst>
         </p:cNvPr>
@@ -17370,7 +17025,7 @@
           <p:cNvPr id="44" name="Rectangle 43">
             <a:extLst>
               <a:ext uri="{FF2B5EF4-FFF2-40B4-BE49-F238E27FC236}">
-                <a16:creationId xmlns="" xmlns:a16="http://schemas.microsoft.com/office/drawing/2014/main" id="{E3A88FEA-E64A-DB03-D08C-5020D91D0A88}"/>
+                <a16:creationId xmlns:a16="http://schemas.microsoft.com/office/drawing/2014/main" id="{E3A88FEA-E64A-DB03-D08C-5020D91D0A88}"/>
               </a:ext>
             </a:extLst>
           </p:cNvPr>
@@ -17436,7 +17091,7 @@
           <p:cNvPr id="41" name="Rectangle 40">
             <a:extLst>
               <a:ext uri="{FF2B5EF4-FFF2-40B4-BE49-F238E27FC236}">
-                <a16:creationId xmlns="" xmlns:a16="http://schemas.microsoft.com/office/drawing/2014/main" id="{B92C5B9D-0252-AAFC-26DB-4B889CE5EAB9}"/>
+                <a16:creationId xmlns:a16="http://schemas.microsoft.com/office/drawing/2014/main" id="{B92C5B9D-0252-AAFC-26DB-4B889CE5EAB9}"/>
               </a:ext>
             </a:extLst>
           </p:cNvPr>
@@ -17502,7 +17157,7 @@
           <p:cNvPr id="38" name="Rectangle 37">
             <a:extLst>
               <a:ext uri="{FF2B5EF4-FFF2-40B4-BE49-F238E27FC236}">
-                <a16:creationId xmlns="" xmlns:a16="http://schemas.microsoft.com/office/drawing/2014/main" id="{ABA31ED2-F6CA-856B-1096-F83261EB551C}"/>
+                <a16:creationId xmlns:a16="http://schemas.microsoft.com/office/drawing/2014/main" id="{ABA31ED2-F6CA-856B-1096-F83261EB551C}"/>
               </a:ext>
             </a:extLst>
           </p:cNvPr>
@@ -17568,7 +17223,7 @@
           <p:cNvPr id="2" name="000_topleftHeading">
             <a:extLst>
               <a:ext uri="{FF2B5EF4-FFF2-40B4-BE49-F238E27FC236}">
-                <a16:creationId xmlns="" xmlns:a16="http://schemas.microsoft.com/office/drawing/2014/main" id="{FA4932E3-C3A2-3ECB-E870-9B3C46386376}"/>
+                <a16:creationId xmlns:a16="http://schemas.microsoft.com/office/drawing/2014/main" id="{FA4932E3-C3A2-3ECB-E870-9B3C46386376}"/>
               </a:ext>
             </a:extLst>
           </p:cNvPr>
@@ -17592,7 +17247,7 @@
           <a:lstStyle/>
           <a:p>
             <a:r>
-              <a:rPr lang="en-US" dirty="0" smtClean="0">
+              <a:rPr lang="en-US" dirty="0">
                 <a:latin typeface="Yu Gothic UI Light" panose="020B0300000000000000" pitchFamily="34" charset="-128"/>
                 <a:ea typeface="Yu Gothic UI Light" panose="020B0300000000000000" pitchFamily="34" charset="-128"/>
               </a:rPr>
@@ -17610,7 +17265,7 @@
           <p:cNvPr id="10" name="001_subtitle">
             <a:extLst>
               <a:ext uri="{FF2B5EF4-FFF2-40B4-BE49-F238E27FC236}">
-                <a16:creationId xmlns="" xmlns:a16="http://schemas.microsoft.com/office/drawing/2014/main" id="{6866F34B-98AD-59E8-C990-0B7464DD0A27}"/>
+                <a16:creationId xmlns:a16="http://schemas.microsoft.com/office/drawing/2014/main" id="{6866F34B-98AD-59E8-C990-0B7464DD0A27}"/>
               </a:ext>
             </a:extLst>
           </p:cNvPr>
@@ -17652,7 +17307,7 @@
           <p:cNvPr id="7" name="TextBox 6">
             <a:extLst>
               <a:ext uri="{FF2B5EF4-FFF2-40B4-BE49-F238E27FC236}">
-                <a16:creationId xmlns="" xmlns:a16="http://schemas.microsoft.com/office/drawing/2014/main" id="{5959A0FF-6ACE-F1B8-14C5-AB5CDF735F70}"/>
+                <a16:creationId xmlns:a16="http://schemas.microsoft.com/office/drawing/2014/main" id="{5959A0FF-6ACE-F1B8-14C5-AB5CDF735F70}"/>
               </a:ext>
             </a:extLst>
           </p:cNvPr>
@@ -17702,7 +17357,7 @@
           <p:cNvPr id="9" name="TextBox 8">
             <a:extLst>
               <a:ext uri="{FF2B5EF4-FFF2-40B4-BE49-F238E27FC236}">
-                <a16:creationId xmlns="" xmlns:a16="http://schemas.microsoft.com/office/drawing/2014/main" id="{CADB73A8-A8E3-14E5-69AA-4ED08D37FEE7}"/>
+                <a16:creationId xmlns:a16="http://schemas.microsoft.com/office/drawing/2014/main" id="{CADB73A8-A8E3-14E5-69AA-4ED08D37FEE7}"/>
               </a:ext>
             </a:extLst>
           </p:cNvPr>
@@ -17752,7 +17407,7 @@
           <p:cNvPr id="14" name="TextBox 13">
             <a:extLst>
               <a:ext uri="{FF2B5EF4-FFF2-40B4-BE49-F238E27FC236}">
-                <a16:creationId xmlns="" xmlns:a16="http://schemas.microsoft.com/office/drawing/2014/main" id="{165E27D3-88E8-A91D-0444-B7BF787283B9}"/>
+                <a16:creationId xmlns:a16="http://schemas.microsoft.com/office/drawing/2014/main" id="{165E27D3-88E8-A91D-0444-B7BF787283B9}"/>
               </a:ext>
             </a:extLst>
           </p:cNvPr>
@@ -17800,7 +17455,7 @@
           <p:cNvPr id="16" name="TextBox 15">
             <a:extLst>
               <a:ext uri="{FF2B5EF4-FFF2-40B4-BE49-F238E27FC236}">
-                <a16:creationId xmlns="" xmlns:a16="http://schemas.microsoft.com/office/drawing/2014/main" id="{7DE0B5A0-6F1E-1CC0-7391-47674F3E60D1}"/>
+                <a16:creationId xmlns:a16="http://schemas.microsoft.com/office/drawing/2014/main" id="{7DE0B5A0-6F1E-1CC0-7391-47674F3E60D1}"/>
               </a:ext>
             </a:extLst>
           </p:cNvPr>
@@ -17850,7 +17505,7 @@
           <p:cNvPr id="19" name="TextBox 18">
             <a:extLst>
               <a:ext uri="{FF2B5EF4-FFF2-40B4-BE49-F238E27FC236}">
-                <a16:creationId xmlns="" xmlns:a16="http://schemas.microsoft.com/office/drawing/2014/main" id="{814FAE69-F6C7-91DA-261B-3EAD694E9B15}"/>
+                <a16:creationId xmlns:a16="http://schemas.microsoft.com/office/drawing/2014/main" id="{814FAE69-F6C7-91DA-261B-3EAD694E9B15}"/>
               </a:ext>
             </a:extLst>
           </p:cNvPr>
@@ -17883,31 +17538,7 @@
                 <a:ea typeface="Yu Gothic UI Light" panose="020B0300000000000000" pitchFamily="34" charset="-128"/>
                 <a:cs typeface="Aptos Display" panose="020B0004020202020204" pitchFamily="34" charset="0"/>
               </a:rPr>
-              <a:t>Assumption </a:t>
-            </a:r>
-            <a:r>
-              <a:rPr lang="en-US" sz="1800" kern="0" dirty="0" smtClean="0">
-                <a:solidFill>
-                  <a:schemeClr val="bg1"/>
-                </a:solidFill>
-                <a:effectLst/>
-                <a:latin typeface="Yu Gothic UI Light" panose="020B0300000000000000" pitchFamily="34" charset="-128"/>
-                <a:ea typeface="Yu Gothic UI Light" panose="020B0300000000000000" pitchFamily="34" charset="-128"/>
-                <a:cs typeface="Aptos Display" panose="020B0004020202020204" pitchFamily="34" charset="0"/>
-              </a:rPr>
-              <a:t>proven </a:t>
-            </a:r>
-            <a:r>
-              <a:rPr lang="en-US" sz="1800" kern="0" dirty="0">
-                <a:solidFill>
-                  <a:schemeClr val="bg1"/>
-                </a:solidFill>
-                <a:effectLst/>
-                <a:latin typeface="Yu Gothic UI Light" panose="020B0300000000000000" pitchFamily="34" charset="-128"/>
-                <a:ea typeface="Yu Gothic UI Light" panose="020B0300000000000000" pitchFamily="34" charset="-128"/>
-                <a:cs typeface="Aptos Display" panose="020B0004020202020204" pitchFamily="34" charset="0"/>
-              </a:rPr>
-              <a:t>false</a:t>
+              <a:t>Assumption proven false</a:t>
             </a:r>
             <a:endParaRPr lang="x-none" dirty="0">
               <a:solidFill>
@@ -17924,7 +17555,7 @@
           <p:cNvPr id="21" name="TextBox 20">
             <a:extLst>
               <a:ext uri="{FF2B5EF4-FFF2-40B4-BE49-F238E27FC236}">
-                <a16:creationId xmlns="" xmlns:a16="http://schemas.microsoft.com/office/drawing/2014/main" id="{59895A70-4326-9C66-4E4A-2931728ACE42}"/>
+                <a16:creationId xmlns:a16="http://schemas.microsoft.com/office/drawing/2014/main" id="{59895A70-4326-9C66-4E4A-2931728ACE42}"/>
               </a:ext>
             </a:extLst>
           </p:cNvPr>
@@ -17974,7 +17605,7 @@
           <p:cNvPr id="25" name="TextBox 24">
             <a:extLst>
               <a:ext uri="{FF2B5EF4-FFF2-40B4-BE49-F238E27FC236}">
-                <a16:creationId xmlns="" xmlns:a16="http://schemas.microsoft.com/office/drawing/2014/main" id="{1F1C8CEC-775B-A638-CF3E-217D23676157}"/>
+                <a16:creationId xmlns:a16="http://schemas.microsoft.com/office/drawing/2014/main" id="{1F1C8CEC-775B-A638-CF3E-217D23676157}"/>
               </a:ext>
             </a:extLst>
           </p:cNvPr>
@@ -18038,7 +17669,7 @@
           <p:cNvPr id="42" name="Rectangle 41">
             <a:extLst>
               <a:ext uri="{FF2B5EF4-FFF2-40B4-BE49-F238E27FC236}">
-                <a16:creationId xmlns="" xmlns:a16="http://schemas.microsoft.com/office/drawing/2014/main" id="{C789F945-A2BE-5A47-6153-F17C478D77B3}"/>
+                <a16:creationId xmlns:a16="http://schemas.microsoft.com/office/drawing/2014/main" id="{C789F945-A2BE-5A47-6153-F17C478D77B3}"/>
               </a:ext>
             </a:extLst>
           </p:cNvPr>
@@ -18100,7 +17731,7 @@
           <p:cNvPr id="43" name="Rectangle 42">
             <a:extLst>
               <a:ext uri="{FF2B5EF4-FFF2-40B4-BE49-F238E27FC236}">
-                <a16:creationId xmlns="" xmlns:a16="http://schemas.microsoft.com/office/drawing/2014/main" id="{31D36F3E-427E-8967-0770-8608C11511B8}"/>
+                <a16:creationId xmlns:a16="http://schemas.microsoft.com/office/drawing/2014/main" id="{31D36F3E-427E-8967-0770-8608C11511B8}"/>
               </a:ext>
             </a:extLst>
           </p:cNvPr>
@@ -18166,7 +17797,7 @@
           <p:cNvPr id="45" name="Rectangle 44">
             <a:extLst>
               <a:ext uri="{FF2B5EF4-FFF2-40B4-BE49-F238E27FC236}">
-                <a16:creationId xmlns="" xmlns:a16="http://schemas.microsoft.com/office/drawing/2014/main" id="{4B62DF7C-8367-EEB6-18C0-50E97CEA1CB9}"/>
+                <a16:creationId xmlns:a16="http://schemas.microsoft.com/office/drawing/2014/main" id="{4B62DF7C-8367-EEB6-18C0-50E97CEA1CB9}"/>
               </a:ext>
             </a:extLst>
           </p:cNvPr>
@@ -18232,7 +17863,7 @@
           <p:cNvPr id="47" name="Graphic 46">
             <a:extLst>
               <a:ext uri="{FF2B5EF4-FFF2-40B4-BE49-F238E27FC236}">
-                <a16:creationId xmlns="" xmlns:a16="http://schemas.microsoft.com/office/drawing/2014/main" id="{63C68B22-79CC-5426-1B36-0AF450DC21A5}"/>
+                <a16:creationId xmlns:a16="http://schemas.microsoft.com/office/drawing/2014/main" id="{63C68B22-79CC-5426-1B36-0AF450DC21A5}"/>
               </a:ext>
             </a:extLst>
           </p:cNvPr>
@@ -18245,7 +17876,7 @@
           <a:blip r:embed="rId2">
             <a:extLst>
               <a:ext uri="{96DAC541-7B7A-43D3-8B79-37D633B846F1}">
-                <asvg:svgBlip xmlns="" xmlns:asvg="http://schemas.microsoft.com/office/drawing/2016/SVG/main" r:embed="rId3"/>
+                <asvg:svgBlip xmlns:asvg="http://schemas.microsoft.com/office/drawing/2016/SVG/main" r:embed="rId3"/>
               </a:ext>
             </a:extLst>
           </a:blip>
@@ -18268,7 +17899,7 @@
           <p:cNvPr id="49" name="Graphic 48">
             <a:extLst>
               <a:ext uri="{FF2B5EF4-FFF2-40B4-BE49-F238E27FC236}">
-                <a16:creationId xmlns="" xmlns:a16="http://schemas.microsoft.com/office/drawing/2014/main" id="{5CFF7006-5238-C8CB-022F-1353A8E70B7E}"/>
+                <a16:creationId xmlns:a16="http://schemas.microsoft.com/office/drawing/2014/main" id="{5CFF7006-5238-C8CB-022F-1353A8E70B7E}"/>
               </a:ext>
             </a:extLst>
           </p:cNvPr>
@@ -18281,7 +17912,7 @@
           <a:blip r:embed="rId4">
             <a:extLst>
               <a:ext uri="{96DAC541-7B7A-43D3-8B79-37D633B846F1}">
-                <asvg:svgBlip xmlns="" xmlns:asvg="http://schemas.microsoft.com/office/drawing/2016/SVG/main" r:embed="rId5"/>
+                <asvg:svgBlip xmlns:asvg="http://schemas.microsoft.com/office/drawing/2016/SVG/main" r:embed="rId5"/>
               </a:ext>
             </a:extLst>
           </a:blip>
@@ -18304,7 +17935,7 @@
           <p:cNvPr id="51" name="Graphic 50">
             <a:extLst>
               <a:ext uri="{FF2B5EF4-FFF2-40B4-BE49-F238E27FC236}">
-                <a16:creationId xmlns="" xmlns:a16="http://schemas.microsoft.com/office/drawing/2014/main" id="{F9B15800-D803-ED03-6791-B2E4EBB82A10}"/>
+                <a16:creationId xmlns:a16="http://schemas.microsoft.com/office/drawing/2014/main" id="{F9B15800-D803-ED03-6791-B2E4EBB82A10}"/>
               </a:ext>
             </a:extLst>
           </p:cNvPr>
@@ -18317,7 +17948,7 @@
           <a:blip r:embed="rId6">
             <a:extLst>
               <a:ext uri="{96DAC541-7B7A-43D3-8B79-37D633B846F1}">
-                <asvg:svgBlip xmlns="" xmlns:asvg="http://schemas.microsoft.com/office/drawing/2016/SVG/main" r:embed="rId7"/>
+                <asvg:svgBlip xmlns:asvg="http://schemas.microsoft.com/office/drawing/2016/SVG/main" r:embed="rId7"/>
               </a:ext>
             </a:extLst>
           </a:blip>
@@ -18340,7 +17971,7 @@
           <p:cNvPr id="20" name="Graphic 3">
             <a:extLst>
               <a:ext uri="{FF2B5EF4-FFF2-40B4-BE49-F238E27FC236}">
-                <a16:creationId xmlns="" xmlns:a16="http://schemas.microsoft.com/office/drawing/2014/main" id="{41B84DD7-C8A8-031E-1F48-DAE64F00881C}"/>
+                <a16:creationId xmlns:a16="http://schemas.microsoft.com/office/drawing/2014/main" id="{41B84DD7-C8A8-031E-1F48-DAE64F00881C}"/>
               </a:ext>
             </a:extLst>
           </p:cNvPr>
@@ -18353,7 +17984,7 @@
           <a:blip r:embed="rId8">
             <a:extLst>
               <a:ext uri="{96DAC541-7B7A-43D3-8B79-37D633B846F1}">
-                <asvg:svgBlip xmlns="" xmlns:asvg="http://schemas.microsoft.com/office/drawing/2016/SVG/main" r:embed="rId9"/>
+                <asvg:svgBlip xmlns:asvg="http://schemas.microsoft.com/office/drawing/2016/SVG/main" r:embed="rId9"/>
               </a:ext>
             </a:extLst>
           </a:blip>
@@ -18381,13 +18012,6 @@
   <p:clrMapOvr>
     <a:masterClrMapping/>
   </p:clrMapOvr>
-  <p:timing>
-    <p:tnLst>
-      <p:par>
-        <p:cTn id="1" dur="indefinite" restart="never" nodeType="tmRoot"/>
-      </p:par>
-    </p:tnLst>
-  </p:timing>
 </p:sld>
 </file>
 

</xml_diff>